<commit_message>
changes to slides and notebooks
</commit_message>
<xml_diff>
--- a/Course content/Slides/Topic 5 - Tree-based methods.pptx
+++ b/Course content/Slides/Topic 5 - Tree-based methods.pptx
@@ -220,7 +220,7 @@
           <a:p>
             <a:fld id="{B9B1DC7F-8587-4047-9A5D-1FCB6614CAE0}" type="datetimeFigureOut">
               <a:rPr lang="en-US" smtClean="0"/>
-              <a:t>10/11/2022</a:t>
+              <a:t>10/28/2022</a:t>
             </a:fld>
             <a:endParaRPr lang="en-US"/>
           </a:p>
@@ -634,7 +634,7 @@
           <a:p>
             <a:fld id="{A7DB5662-7327-465C-9A70-AD96B7A8D67A}" type="datetimeFigureOut">
               <a:rPr lang="en-US" smtClean="0"/>
-              <a:t>10/11/2022</a:t>
+              <a:t>10/28/2022</a:t>
             </a:fld>
             <a:endParaRPr lang="en-US"/>
           </a:p>
@@ -832,7 +832,7 @@
           <a:p>
             <a:fld id="{A7DB5662-7327-465C-9A70-AD96B7A8D67A}" type="datetimeFigureOut">
               <a:rPr lang="en-US" smtClean="0"/>
-              <a:t>10/11/2022</a:t>
+              <a:t>10/28/2022</a:t>
             </a:fld>
             <a:endParaRPr lang="en-US"/>
           </a:p>
@@ -1040,7 +1040,7 @@
           <a:p>
             <a:fld id="{A7DB5662-7327-465C-9A70-AD96B7A8D67A}" type="datetimeFigureOut">
               <a:rPr lang="en-US" smtClean="0"/>
-              <a:t>10/11/2022</a:t>
+              <a:t>10/28/2022</a:t>
             </a:fld>
             <a:endParaRPr lang="en-US"/>
           </a:p>
@@ -1238,7 +1238,7 @@
           <a:p>
             <a:fld id="{A7DB5662-7327-465C-9A70-AD96B7A8D67A}" type="datetimeFigureOut">
               <a:rPr lang="en-US" smtClean="0"/>
-              <a:t>10/11/2022</a:t>
+              <a:t>10/28/2022</a:t>
             </a:fld>
             <a:endParaRPr lang="en-US"/>
           </a:p>
@@ -1513,7 +1513,7 @@
           <a:p>
             <a:fld id="{A7DB5662-7327-465C-9A70-AD96B7A8D67A}" type="datetimeFigureOut">
               <a:rPr lang="en-US" smtClean="0"/>
-              <a:t>10/11/2022</a:t>
+              <a:t>10/28/2022</a:t>
             </a:fld>
             <a:endParaRPr lang="en-US"/>
           </a:p>
@@ -1778,7 +1778,7 @@
           <a:p>
             <a:fld id="{A7DB5662-7327-465C-9A70-AD96B7A8D67A}" type="datetimeFigureOut">
               <a:rPr lang="en-US" smtClean="0"/>
-              <a:t>10/11/2022</a:t>
+              <a:t>10/28/2022</a:t>
             </a:fld>
             <a:endParaRPr lang="en-US"/>
           </a:p>
@@ -2190,7 +2190,7 @@
           <a:p>
             <a:fld id="{A7DB5662-7327-465C-9A70-AD96B7A8D67A}" type="datetimeFigureOut">
               <a:rPr lang="en-US" smtClean="0"/>
-              <a:t>10/11/2022</a:t>
+              <a:t>10/28/2022</a:t>
             </a:fld>
             <a:endParaRPr lang="en-US"/>
           </a:p>
@@ -2331,7 +2331,7 @@
           <a:p>
             <a:fld id="{A7DB5662-7327-465C-9A70-AD96B7A8D67A}" type="datetimeFigureOut">
               <a:rPr lang="en-US" smtClean="0"/>
-              <a:t>10/11/2022</a:t>
+              <a:t>10/28/2022</a:t>
             </a:fld>
             <a:endParaRPr lang="en-US"/>
           </a:p>
@@ -2444,7 +2444,7 @@
           <a:p>
             <a:fld id="{A7DB5662-7327-465C-9A70-AD96B7A8D67A}" type="datetimeFigureOut">
               <a:rPr lang="en-US" smtClean="0"/>
-              <a:t>10/11/2022</a:t>
+              <a:t>10/28/2022</a:t>
             </a:fld>
             <a:endParaRPr lang="en-US"/>
           </a:p>
@@ -2755,7 +2755,7 @@
           <a:p>
             <a:fld id="{A7DB5662-7327-465C-9A70-AD96B7A8D67A}" type="datetimeFigureOut">
               <a:rPr lang="en-US" smtClean="0"/>
-              <a:t>10/11/2022</a:t>
+              <a:t>10/28/2022</a:t>
             </a:fld>
             <a:endParaRPr lang="en-US"/>
           </a:p>
@@ -3043,7 +3043,7 @@
           <a:p>
             <a:fld id="{A7DB5662-7327-465C-9A70-AD96B7A8D67A}" type="datetimeFigureOut">
               <a:rPr lang="en-US" smtClean="0"/>
-              <a:t>10/11/2022</a:t>
+              <a:t>10/28/2022</a:t>
             </a:fld>
             <a:endParaRPr lang="en-US"/>
           </a:p>
@@ -3284,7 +3284,7 @@
           <a:p>
             <a:fld id="{A7DB5662-7327-465C-9A70-AD96B7A8D67A}" type="datetimeFigureOut">
               <a:rPr lang="en-US" smtClean="0"/>
-              <a:t>10/11/2022</a:t>
+              <a:t>10/28/2022</a:t>
             </a:fld>
             <a:endParaRPr lang="en-US"/>
           </a:p>
@@ -21950,7 +21950,7 @@
                   <a:t> represents the proportion of training observations in the </a:t>
                 </a:r>
                 <a:r>
-                  <a:rPr lang="en-US" sz="2000" dirty="0" err="1">
+                  <a:rPr lang="en-US" sz="2000" i="1" dirty="0" err="1">
                     <a:latin typeface="+mj-lt"/>
                   </a:rPr>
                   <a:t>mth</a:t>
@@ -21959,17 +21959,20 @@
                   <a:rPr lang="en-US" sz="2000" dirty="0">
                     <a:latin typeface="+mj-lt"/>
                   </a:rPr>
-                  <a:t> region that belong to the kth </a:t>
+                  <a:t> region that belong to the </a:t>
                 </a:r>
                 <a:r>
-                  <a:rPr lang="en-US" sz="2000" dirty="0" err="1">
+                  <a:rPr lang="en-US" sz="2000" i="1" dirty="0">
                     <a:latin typeface="+mj-lt"/>
                   </a:rPr>
-                  <a:t>classe</a:t>
+                  <a:t>kth</a:t>
                 </a:r>
-                <a:endParaRPr lang="en-US" sz="2000" dirty="0">
-                  <a:latin typeface="+mj-lt"/>
-                </a:endParaRPr>
+                <a:r>
+                  <a:rPr lang="en-US" sz="2000" dirty="0">
+                    <a:latin typeface="+mj-lt"/>
+                  </a:rPr>
+                  <a:t> class</a:t>
+                </a:r>
               </a:p>
             </p:txBody>
           </p:sp>
@@ -22413,8 +22416,8 @@
           </a:p>
         </p:txBody>
       </p:sp>
-      <mc:AlternateContent xmlns:mc="http://schemas.openxmlformats.org/markup-compatibility/2006">
-        <mc:Choice xmlns:a14="http://schemas.microsoft.com/office/drawing/2010/main" Requires="a14">
+      <mc:AlternateContent xmlns:mc="http://schemas.openxmlformats.org/markup-compatibility/2006" xmlns:a14="http://schemas.microsoft.com/office/drawing/2010/main">
+        <mc:Choice Requires="a14">
           <p:sp>
             <p:nvSpPr>
               <p:cNvPr id="3" name="Content Placeholder 2">
@@ -22821,7 +22824,7 @@
             </p:txBody>
           </p:sp>
         </mc:Choice>
-        <mc:Fallback>
+        <mc:Fallback xmlns="">
           <p:sp>
             <p:nvSpPr>
               <p:cNvPr id="3" name="Content Placeholder 2">
@@ -23616,8 +23619,8 @@
         </p:blipFill>
         <p:spPr>
           <a:xfrm>
-            <a:off x="587946" y="1690688"/>
-            <a:ext cx="5384970" cy="2884613"/>
+            <a:off x="831647" y="1393506"/>
+            <a:ext cx="5983300" cy="3205127"/>
           </a:xfrm>
           <a:prstGeom prst="rect">
             <a:avLst/>
@@ -23640,19 +23643,178 @@
         </p:nvPicPr>
         <p:blipFill rotWithShape="1">
           <a:blip r:embed="rId2"/>
-          <a:srcRect t="51761"/>
+          <a:srcRect t="51761" r="49858"/>
           <a:stretch/>
         </p:blipFill>
         <p:spPr>
           <a:xfrm>
-            <a:off x="6096000" y="3429000"/>
-            <a:ext cx="5774828" cy="3019351"/>
+            <a:off x="7671537" y="1552913"/>
+            <a:ext cx="3753574" cy="3914004"/>
           </a:xfrm>
           <a:prstGeom prst="rect">
             <a:avLst/>
           </a:prstGeom>
         </p:spPr>
       </p:pic>
+      <p:grpSp>
+        <p:nvGrpSpPr>
+          <p:cNvPr id="9" name="Group 8">
+            <a:extLst>
+              <a:ext uri="{FF2B5EF4-FFF2-40B4-BE49-F238E27FC236}">
+                <a16:creationId xmlns:a16="http://schemas.microsoft.com/office/drawing/2014/main" id="{DABCEC20-BBF9-D33E-C765-8DC1AC18C97C}"/>
+              </a:ext>
+            </a:extLst>
+          </p:cNvPr>
+          <p:cNvGrpSpPr>
+            <a:grpSpLocks noChangeAspect="1"/>
+          </p:cNvGrpSpPr>
+          <p:nvPr/>
+        </p:nvGrpSpPr>
+        <p:grpSpPr>
+          <a:xfrm>
+            <a:off x="2652321" y="4347337"/>
+            <a:ext cx="2906518" cy="2145538"/>
+            <a:chOff x="2895600" y="4379763"/>
+            <a:chExt cx="2620148" cy="1934145"/>
+          </a:xfrm>
+        </p:grpSpPr>
+        <p:pic>
+          <p:nvPicPr>
+            <p:cNvPr id="3" name="Picture 2">
+              <a:extLst>
+                <a:ext uri="{FF2B5EF4-FFF2-40B4-BE49-F238E27FC236}">
+                  <a16:creationId xmlns:a16="http://schemas.microsoft.com/office/drawing/2014/main" id="{613AAA8D-EF25-683D-9C70-E6134ECF18B8}"/>
+                </a:ext>
+              </a:extLst>
+            </p:cNvPr>
+            <p:cNvPicPr>
+              <a:picLocks noChangeAspect="1"/>
+            </p:cNvPicPr>
+            <p:nvPr/>
+          </p:nvPicPr>
+          <p:blipFill rotWithShape="1">
+            <a:blip r:embed="rId2"/>
+            <a:srcRect l="54628" t="73352" b="3931"/>
+            <a:stretch/>
+          </p:blipFill>
+          <p:spPr>
+            <a:xfrm>
+              <a:off x="2895600" y="4892040"/>
+              <a:ext cx="2620148" cy="1421868"/>
+            </a:xfrm>
+            <a:prstGeom prst="rect">
+              <a:avLst/>
+            </a:prstGeom>
+          </p:spPr>
+        </p:pic>
+        <p:pic>
+          <p:nvPicPr>
+            <p:cNvPr id="5" name="Picture 4">
+              <a:extLst>
+                <a:ext uri="{FF2B5EF4-FFF2-40B4-BE49-F238E27FC236}">
+                  <a16:creationId xmlns:a16="http://schemas.microsoft.com/office/drawing/2014/main" id="{D91EF105-2612-47DD-357C-CE14DB032E69}"/>
+                </a:ext>
+              </a:extLst>
+            </p:cNvPr>
+            <p:cNvPicPr>
+              <a:picLocks noChangeAspect="1"/>
+            </p:cNvPicPr>
+            <p:nvPr/>
+          </p:nvPicPr>
+          <p:blipFill rotWithShape="1">
+            <a:blip r:embed="rId2"/>
+            <a:srcRect l="54628" t="51761" b="39889"/>
+            <a:stretch/>
+          </p:blipFill>
+          <p:spPr>
+            <a:xfrm>
+              <a:off x="2895600" y="4379763"/>
+              <a:ext cx="2620148" cy="522609"/>
+            </a:xfrm>
+            <a:prstGeom prst="rect">
+              <a:avLst/>
+            </a:prstGeom>
+          </p:spPr>
+        </p:pic>
+      </p:grpSp>
+      <p:sp>
+        <p:nvSpPr>
+          <p:cNvPr id="10" name="TextBox 9">
+            <a:extLst>
+              <a:ext uri="{FF2B5EF4-FFF2-40B4-BE49-F238E27FC236}">
+                <a16:creationId xmlns:a16="http://schemas.microsoft.com/office/drawing/2014/main" id="{DD184A9C-4CB8-226A-861F-DA937CD7CA75}"/>
+              </a:ext>
+            </a:extLst>
+          </p:cNvPr>
+          <p:cNvSpPr txBox="1"/>
+          <p:nvPr/>
+        </p:nvSpPr>
+        <p:spPr>
+          <a:xfrm>
+            <a:off x="1729740" y="1886854"/>
+            <a:ext cx="1379220" cy="338554"/>
+          </a:xfrm>
+          <a:prstGeom prst="rect">
+            <a:avLst/>
+          </a:prstGeom>
+          <a:noFill/>
+        </p:spPr>
+        <p:txBody>
+          <a:bodyPr wrap="square" rtlCol="0">
+            <a:spAutoFit/>
+          </a:bodyPr>
+          <a:lstStyle/>
+          <a:p>
+            <a:r>
+              <a:rPr lang="en-US" sz="1600" dirty="0">
+                <a:solidFill>
+                  <a:srgbClr val="FF0000"/>
+                </a:solidFill>
+              </a:rPr>
+              <a:t>unpruned</a:t>
+            </a:r>
+          </a:p>
+        </p:txBody>
+      </p:sp>
+      <p:sp>
+        <p:nvSpPr>
+          <p:cNvPr id="11" name="TextBox 10">
+            <a:extLst>
+              <a:ext uri="{FF2B5EF4-FFF2-40B4-BE49-F238E27FC236}">
+                <a16:creationId xmlns:a16="http://schemas.microsoft.com/office/drawing/2014/main" id="{FAE9BD84-1A5F-1CAD-3978-20749718AB61}"/>
+              </a:ext>
+            </a:extLst>
+          </p:cNvPr>
+          <p:cNvSpPr txBox="1"/>
+          <p:nvPr/>
+        </p:nvSpPr>
+        <p:spPr>
+          <a:xfrm>
+            <a:off x="2726360" y="4746326"/>
+            <a:ext cx="1379220" cy="338554"/>
+          </a:xfrm>
+          <a:prstGeom prst="rect">
+            <a:avLst/>
+          </a:prstGeom>
+          <a:noFill/>
+        </p:spPr>
+        <p:txBody>
+          <a:bodyPr wrap="square" rtlCol="0">
+            <a:spAutoFit/>
+          </a:bodyPr>
+          <a:lstStyle/>
+          <a:p>
+            <a:r>
+              <a:rPr lang="en-US" sz="1600" dirty="0">
+                <a:solidFill>
+                  <a:srgbClr val="FF0000"/>
+                </a:solidFill>
+              </a:rPr>
+              <a:t>pruned</a:t>
+            </a:r>
+          </a:p>
+        </p:txBody>
+      </p:sp>
     </p:spTree>
     <p:extLst>
       <p:ext uri="{BB962C8B-B14F-4D97-AF65-F5344CB8AC3E}">
@@ -24070,14 +24232,200 @@
         </p:blipFill>
         <p:spPr>
           <a:xfrm>
-            <a:off x="3729010" y="1690688"/>
-            <a:ext cx="4733979" cy="4710466"/>
+            <a:off x="1138212" y="2353632"/>
+            <a:ext cx="3944983" cy="3925388"/>
           </a:xfrm>
           <a:prstGeom prst="rect">
             <a:avLst/>
           </a:prstGeom>
         </p:spPr>
       </p:pic>
+      <p:sp>
+        <p:nvSpPr>
+          <p:cNvPr id="3" name="TextBox 2">
+            <a:extLst>
+              <a:ext uri="{FF2B5EF4-FFF2-40B4-BE49-F238E27FC236}">
+                <a16:creationId xmlns:a16="http://schemas.microsoft.com/office/drawing/2014/main" id="{59781610-BFC3-8914-2393-E738154B83C1}"/>
+              </a:ext>
+            </a:extLst>
+          </p:cNvPr>
+          <p:cNvSpPr txBox="1"/>
+          <p:nvPr/>
+        </p:nvSpPr>
+        <p:spPr>
+          <a:xfrm>
+            <a:off x="937260" y="1690688"/>
+            <a:ext cx="10880271" cy="400110"/>
+          </a:xfrm>
+          <a:prstGeom prst="rect">
+            <a:avLst/>
+          </a:prstGeom>
+          <a:noFill/>
+        </p:spPr>
+        <p:txBody>
+          <a:bodyPr wrap="square" rtlCol="0">
+            <a:spAutoFit/>
+          </a:bodyPr>
+          <a:lstStyle/>
+          <a:p>
+            <a:pPr marL="285750" indent="-285750">
+              <a:buFont typeface="Wingdings" panose="05000000000000000000" pitchFamily="2" charset="2"/>
+              <a:buChar char="§"/>
+            </a:pPr>
+            <a:r>
+              <a:rPr lang="en-US" sz="2000" dirty="0">
+                <a:latin typeface="+mj-lt"/>
+              </a:rPr>
+              <a:t>Best model depends on the problem at hand</a:t>
+            </a:r>
+          </a:p>
+        </p:txBody>
+      </p:sp>
+      <p:sp>
+        <p:nvSpPr>
+          <p:cNvPr id="8" name="TextBox 7">
+            <a:extLst>
+              <a:ext uri="{FF2B5EF4-FFF2-40B4-BE49-F238E27FC236}">
+                <a16:creationId xmlns:a16="http://schemas.microsoft.com/office/drawing/2014/main" id="{30EA21C4-87A6-6195-F3E6-D845E74C34FF}"/>
+              </a:ext>
+            </a:extLst>
+          </p:cNvPr>
+          <p:cNvSpPr txBox="1"/>
+          <p:nvPr/>
+        </p:nvSpPr>
+        <p:spPr>
+          <a:xfrm>
+            <a:off x="6096000" y="2537460"/>
+            <a:ext cx="5448300" cy="3416320"/>
+          </a:xfrm>
+          <a:prstGeom prst="rect">
+            <a:avLst/>
+          </a:prstGeom>
+          <a:noFill/>
+        </p:spPr>
+        <p:txBody>
+          <a:bodyPr wrap="square" rtlCol="0">
+            <a:spAutoFit/>
+          </a:bodyPr>
+          <a:lstStyle/>
+          <a:p>
+            <a:pPr marL="285750" indent="-285750">
+              <a:buFont typeface="Wingdings" panose="05000000000000000000" pitchFamily="2" charset="2"/>
+              <a:buChar char="§"/>
+            </a:pPr>
+            <a:r>
+              <a:rPr lang="en-US" dirty="0">
+                <a:latin typeface="+mj-lt"/>
+              </a:rPr>
+              <a:t>Trees are easy to explain</a:t>
+            </a:r>
+          </a:p>
+          <a:p>
+            <a:pPr marL="285750" indent="-285750">
+              <a:buFont typeface="Wingdings" panose="05000000000000000000" pitchFamily="2" charset="2"/>
+              <a:buChar char="§"/>
+            </a:pPr>
+            <a:r>
+              <a:rPr lang="en-US" dirty="0">
+                <a:latin typeface="+mj-lt"/>
+              </a:rPr>
+              <a:t>Trees </a:t>
+            </a:r>
+            <a:r>
+              <a:rPr lang="en-US" b="1" dirty="0">
+                <a:latin typeface="+mj-lt"/>
+              </a:rPr>
+              <a:t>might</a:t>
+            </a:r>
+            <a:r>
+              <a:rPr lang="en-US" dirty="0">
+                <a:latin typeface="+mj-lt"/>
+              </a:rPr>
+              <a:t> be closer to human decision-making process</a:t>
+            </a:r>
+          </a:p>
+          <a:p>
+            <a:pPr marL="285750" indent="-285750">
+              <a:buFont typeface="Wingdings" panose="05000000000000000000" pitchFamily="2" charset="2"/>
+              <a:buChar char="§"/>
+            </a:pPr>
+            <a:r>
+              <a:rPr lang="en-US" dirty="0">
+                <a:latin typeface="+mj-lt"/>
+              </a:rPr>
+              <a:t>Trees can be displayed graphically and be easy of interpret</a:t>
+            </a:r>
+          </a:p>
+          <a:p>
+            <a:pPr marL="285750" indent="-285750">
+              <a:buFont typeface="Wingdings" panose="05000000000000000000" pitchFamily="2" charset="2"/>
+              <a:buChar char="§"/>
+            </a:pPr>
+            <a:r>
+              <a:rPr lang="en-US" dirty="0">
+                <a:latin typeface="+mj-lt"/>
+              </a:rPr>
+              <a:t>Trees can easily handle qualitative features without </a:t>
+            </a:r>
+            <a:r>
+              <a:rPr lang="en-US" dirty="0" err="1">
+                <a:latin typeface="+mj-lt"/>
+              </a:rPr>
+              <a:t>dummyfying</a:t>
+            </a:r>
+            <a:endParaRPr lang="en-US" dirty="0">
+              <a:latin typeface="+mj-lt"/>
+            </a:endParaRPr>
+          </a:p>
+          <a:p>
+            <a:pPr marL="285750" indent="-285750">
+              <a:buFont typeface="Wingdings" panose="05000000000000000000" pitchFamily="2" charset="2"/>
+              <a:buChar char="§"/>
+            </a:pPr>
+            <a:endParaRPr lang="en-US" dirty="0">
+              <a:latin typeface="+mj-lt"/>
+            </a:endParaRPr>
+          </a:p>
+          <a:p>
+            <a:r>
+              <a:rPr lang="en-US" dirty="0">
+                <a:latin typeface="+mj-lt"/>
+              </a:rPr>
+              <a:t>However…</a:t>
+            </a:r>
+          </a:p>
+          <a:p>
+            <a:pPr marL="285750" indent="-285750">
+              <a:buFont typeface="Wingdings" panose="05000000000000000000" pitchFamily="2" charset="2"/>
+              <a:buChar char="§"/>
+            </a:pPr>
+            <a:r>
+              <a:rPr lang="en-US" dirty="0">
+                <a:latin typeface="+mj-lt"/>
+              </a:rPr>
+              <a:t>Trees do not have the same level of prediction accuracy as other methods</a:t>
+            </a:r>
+          </a:p>
+          <a:p>
+            <a:pPr marL="285750" indent="-285750">
+              <a:buFont typeface="Wingdings" panose="05000000000000000000" pitchFamily="2" charset="2"/>
+              <a:buChar char="§"/>
+            </a:pPr>
+            <a:r>
+              <a:rPr lang="en-US" dirty="0">
+                <a:latin typeface="+mj-lt"/>
+              </a:rPr>
+              <a:t>Trees </a:t>
+            </a:r>
+            <a:r>
+              <a:rPr lang="en-US" b="1" dirty="0">
+                <a:latin typeface="+mj-lt"/>
+              </a:rPr>
+              <a:t>are not robust</a:t>
+            </a:r>
+          </a:p>
+        </p:txBody>
+      </p:sp>
     </p:spTree>
     <p:extLst>
       <p:ext uri="{BB962C8B-B14F-4D97-AF65-F5344CB8AC3E}">
@@ -26311,8 +26659,8 @@
           </a:prstGeom>
         </p:spPr>
       </p:pic>
-      <mc:AlternateContent xmlns:mc="http://schemas.openxmlformats.org/markup-compatibility/2006">
-        <mc:Choice xmlns:a14="http://schemas.microsoft.com/office/drawing/2010/main" Requires="a14">
+      <mc:AlternateContent xmlns:mc="http://schemas.openxmlformats.org/markup-compatibility/2006" xmlns:a14="http://schemas.microsoft.com/office/drawing/2010/main">
+        <mc:Choice Requires="a14">
           <p:sp>
             <p:nvSpPr>
               <p:cNvPr id="11" name="TextBox 10">
@@ -26443,25 +26791,7 @@
                               </a:solidFill>
                               <a:latin typeface="Cambria Math" panose="02040503050406030204" pitchFamily="18" charset="0"/>
                             </a:rPr>
-                            <m:t>≥</m:t>
-                          </m:r>
-                          <m:r>
-                            <a:rPr lang="en-US" sz="1600" b="0" i="1" smtClean="0">
-                              <a:solidFill>
-                                <a:srgbClr val="FF0000"/>
-                              </a:solidFill>
-                              <a:latin typeface="Cambria Math" panose="02040503050406030204" pitchFamily="18" charset="0"/>
-                            </a:rPr>
-                            <m:t>4.5</m:t>
-                          </m:r>
-                          <m:r>
-                            <a:rPr lang="en-US" sz="1600" b="0" i="1" smtClean="0">
-                              <a:solidFill>
-                                <a:srgbClr val="FF0000"/>
-                              </a:solidFill>
-                              <a:latin typeface="Cambria Math" panose="02040503050406030204" pitchFamily="18" charset="0"/>
-                            </a:rPr>
-                            <m:t>, </m:t>
+                            <m:t>≥4.5, </m:t>
                           </m:r>
                           <m:r>
                             <a:rPr lang="en-US" sz="1600" b="0" i="1" smtClean="0">
@@ -26495,7 +26825,7 @@
             </p:txBody>
           </p:sp>
         </mc:Choice>
-        <mc:Fallback>
+        <mc:Fallback xmlns="">
           <p:sp>
             <p:nvSpPr>
               <p:cNvPr id="11" name="TextBox 10">
@@ -26540,8 +26870,8 @@
           </p:sp>
         </mc:Fallback>
       </mc:AlternateContent>
-      <mc:AlternateContent xmlns:mc="http://schemas.openxmlformats.org/markup-compatibility/2006">
-        <mc:Choice xmlns:a14="http://schemas.microsoft.com/office/drawing/2010/main" Requires="a14">
+      <mc:AlternateContent xmlns:mc="http://schemas.openxmlformats.org/markup-compatibility/2006" xmlns:a14="http://schemas.microsoft.com/office/drawing/2010/main">
+        <mc:Choice Requires="a14">
           <p:sp>
             <p:nvSpPr>
               <p:cNvPr id="14" name="TextBox 13">
@@ -26688,7 +27018,7 @@
             </p:txBody>
           </p:sp>
         </mc:Choice>
-        <mc:Fallback>
+        <mc:Fallback xmlns="">
           <p:sp>
             <p:nvSpPr>
               <p:cNvPr id="14" name="TextBox 13">
@@ -26733,8 +27063,8 @@
           </p:sp>
         </mc:Fallback>
       </mc:AlternateContent>
-      <mc:AlternateContent xmlns:mc="http://schemas.openxmlformats.org/markup-compatibility/2006">
-        <mc:Choice xmlns:a14="http://schemas.microsoft.com/office/drawing/2010/main" Requires="a14">
+      <mc:AlternateContent xmlns:mc="http://schemas.openxmlformats.org/markup-compatibility/2006" xmlns:a14="http://schemas.microsoft.com/office/drawing/2010/main">
+        <mc:Choice Requires="a14">
           <p:sp>
             <p:nvSpPr>
               <p:cNvPr id="16" name="TextBox 15">
@@ -26899,7 +27229,7 @@
             </p:txBody>
           </p:sp>
         </mc:Choice>
-        <mc:Fallback>
+        <mc:Fallback xmlns="">
           <p:sp>
             <p:nvSpPr>
               <p:cNvPr id="16" name="TextBox 15">
@@ -27004,8 +27334,8 @@
           </a:p>
         </p:txBody>
       </p:sp>
-      <mc:AlternateContent xmlns:mc="http://schemas.openxmlformats.org/markup-compatibility/2006">
-        <mc:Choice xmlns:a14="http://schemas.microsoft.com/office/drawing/2010/main" Requires="a14">
+      <mc:AlternateContent xmlns:mc="http://schemas.openxmlformats.org/markup-compatibility/2006" xmlns:a14="http://schemas.microsoft.com/office/drawing/2010/main">
+        <mc:Choice Requires="a14">
           <p:sp>
             <p:nvSpPr>
               <p:cNvPr id="3" name="Content Placeholder 2">
@@ -27386,14 +27716,14 @@
                       <m:sSubPr>
                         <m:ctrlPr>
                           <a:rPr lang="en-US" sz="2000" i="1" smtClean="0">
-                            <a:latin typeface="+mj-lt"/>
+                            <a:latin typeface="Cambria Math" panose="02040503050406030204" pitchFamily="18" charset="0"/>
                           </a:rPr>
                         </m:ctrlPr>
                       </m:sSubPr>
                       <m:e>
                         <m:r>
                           <a:rPr lang="en-US" sz="2000" i="1">
-                            <a:latin typeface="+mj-lt"/>
+                            <a:latin typeface="Cambria Math" panose="02040503050406030204" pitchFamily="18" charset="0"/>
                           </a:rPr>
                           <m:t>𝑅</m:t>
                         </m:r>
@@ -27401,7 +27731,7 @@
                       <m:sub>
                         <m:r>
                           <a:rPr lang="en-US" sz="2000" b="0" i="1" smtClean="0">
-                            <a:latin typeface="+mj-lt"/>
+                            <a:latin typeface="Cambria Math" panose="02040503050406030204" pitchFamily="18" charset="0"/>
                           </a:rPr>
                           <m:t>1</m:t>
                         </m:r>
@@ -27421,14 +27751,14 @@
                       <m:sSubPr>
                         <m:ctrlPr>
                           <a:rPr lang="en-US" sz="2000" i="1">
-                            <a:latin typeface="+mj-lt"/>
+                            <a:latin typeface="Cambria Math" panose="02040503050406030204" pitchFamily="18" charset="0"/>
                           </a:rPr>
                         </m:ctrlPr>
                       </m:sSubPr>
                       <m:e>
                         <m:r>
                           <a:rPr lang="en-US" sz="2000" i="1">
-                            <a:latin typeface="+mj-lt"/>
+                            <a:latin typeface="Cambria Math" panose="02040503050406030204" pitchFamily="18" charset="0"/>
                           </a:rPr>
                           <m:t>𝑅</m:t>
                         </m:r>
@@ -27436,7 +27766,7 @@
                       <m:sub>
                         <m:r>
                           <a:rPr lang="en-US" sz="2000" i="1">
-                            <a:latin typeface="+mj-lt"/>
+                            <a:latin typeface="Cambria Math" panose="02040503050406030204" pitchFamily="18" charset="0"/>
                           </a:rPr>
                           <m:t>2</m:t>
                         </m:r>
@@ -27470,13 +27800,13 @@
                   <m:oMath xmlns:m="http://schemas.openxmlformats.org/officeDocument/2006/math">
                     <m:r>
                       <a:rPr lang="en-US" sz="2000" b="0" i="1" smtClean="0">
-                        <a:latin typeface="+mj-lt"/>
+                        <a:latin typeface="Cambria Math" panose="02040503050406030204" pitchFamily="18" charset="0"/>
                       </a:rPr>
                       <m:t>𝑥</m:t>
                     </m:r>
                     <m:r>
                       <a:rPr lang="en-US" sz="2000" b="0" i="1" smtClean="0">
-                        <a:latin typeface="+mj-lt"/>
+                        <a:latin typeface="Cambria Math" panose="02040503050406030204" pitchFamily="18" charset="0"/>
                         <a:ea typeface="Cambria Math" panose="02040503050406030204" pitchFamily="18" charset="0"/>
                       </a:rPr>
                       <m:t>∈</m:t>
@@ -27485,7 +27815,7 @@
                       <m:sSubPr>
                         <m:ctrlPr>
                           <a:rPr lang="en-US" sz="2000" b="0" i="1" smtClean="0">
-                            <a:latin typeface="+mj-lt"/>
+                            <a:latin typeface="Cambria Math" panose="02040503050406030204" pitchFamily="18" charset="0"/>
                             <a:ea typeface="Cambria Math" panose="02040503050406030204" pitchFamily="18" charset="0"/>
                           </a:rPr>
                         </m:ctrlPr>
@@ -27493,7 +27823,7 @@
                       <m:e>
                         <m:r>
                           <a:rPr lang="en-US" sz="2000" b="0" i="1" smtClean="0">
-                            <a:latin typeface="+mj-lt"/>
+                            <a:latin typeface="Cambria Math" panose="02040503050406030204" pitchFamily="18" charset="0"/>
                             <a:ea typeface="Cambria Math" panose="02040503050406030204" pitchFamily="18" charset="0"/>
                           </a:rPr>
                           <m:t>𝑅</m:t>
@@ -27502,7 +27832,7 @@
                       <m:sub>
                         <m:r>
                           <a:rPr lang="en-US" sz="2000" b="0" i="1" smtClean="0">
-                            <a:latin typeface="+mj-lt"/>
+                            <a:latin typeface="Cambria Math" panose="02040503050406030204" pitchFamily="18" charset="0"/>
                             <a:ea typeface="Cambria Math" panose="02040503050406030204" pitchFamily="18" charset="0"/>
                           </a:rPr>
                           <m:t>1</m:t>
@@ -27521,13 +27851,13 @@
                   <m:oMath xmlns:m="http://schemas.openxmlformats.org/officeDocument/2006/math">
                     <m:r>
                       <a:rPr lang="en-US" sz="2000" i="1">
-                        <a:latin typeface="+mj-lt"/>
+                        <a:latin typeface="Cambria Math" panose="02040503050406030204" pitchFamily="18" charset="0"/>
                       </a:rPr>
                       <m:t>𝑥</m:t>
                     </m:r>
                     <m:r>
                       <a:rPr lang="en-US" sz="2000" i="1">
-                        <a:latin typeface="+mj-lt"/>
+                        <a:latin typeface="Cambria Math" panose="02040503050406030204" pitchFamily="18" charset="0"/>
                         <a:ea typeface="Cambria Math" panose="02040503050406030204" pitchFamily="18" charset="0"/>
                       </a:rPr>
                       <m:t>∈</m:t>
@@ -27536,7 +27866,7 @@
                       <m:sSubPr>
                         <m:ctrlPr>
                           <a:rPr lang="en-US" sz="2000" i="1">
-                            <a:latin typeface="+mj-lt"/>
+                            <a:latin typeface="Cambria Math" panose="02040503050406030204" pitchFamily="18" charset="0"/>
                             <a:ea typeface="Cambria Math" panose="02040503050406030204" pitchFamily="18" charset="0"/>
                           </a:rPr>
                         </m:ctrlPr>
@@ -27544,7 +27874,7 @@
                       <m:e>
                         <m:r>
                           <a:rPr lang="en-US" sz="2000" i="1">
-                            <a:latin typeface="+mj-lt"/>
+                            <a:latin typeface="Cambria Math" panose="02040503050406030204" pitchFamily="18" charset="0"/>
                             <a:ea typeface="Cambria Math" panose="02040503050406030204" pitchFamily="18" charset="0"/>
                           </a:rPr>
                           <m:t>𝑅</m:t>
@@ -27553,7 +27883,7 @@
                       <m:sub>
                         <m:r>
                           <a:rPr lang="en-US" sz="2000" b="0" i="1" smtClean="0">
-                            <a:latin typeface="+mj-lt"/>
+                            <a:latin typeface="Cambria Math" panose="02040503050406030204" pitchFamily="18" charset="0"/>
                             <a:ea typeface="Cambria Math" panose="02040503050406030204" pitchFamily="18" charset="0"/>
                           </a:rPr>
                           <m:t>2</m:t>
@@ -27572,7 +27902,7 @@
             </p:txBody>
           </p:sp>
         </mc:Choice>
-        <mc:Fallback>
+        <mc:Fallback xmlns="">
           <p:sp>
             <p:nvSpPr>
               <p:cNvPr id="3" name="Content Placeholder 2">
@@ -28011,8 +28341,8 @@
           </a:p>
         </p:txBody>
       </p:sp>
-      <mc:AlternateContent xmlns:mc="http://schemas.openxmlformats.org/markup-compatibility/2006">
-        <mc:Choice xmlns:a14="http://schemas.microsoft.com/office/drawing/2010/main" Requires="a14">
+      <mc:AlternateContent xmlns:mc="http://schemas.openxmlformats.org/markup-compatibility/2006" xmlns:a14="http://schemas.microsoft.com/office/drawing/2010/main">
+        <mc:Choice Requires="a14">
           <p:sp>
             <p:nvSpPr>
               <p:cNvPr id="3" name="Content Placeholder 2">
@@ -28604,7 +28934,7 @@
             </p:txBody>
           </p:sp>
         </mc:Choice>
-        <mc:Fallback>
+        <mc:Fallback xmlns="">
           <p:sp>
             <p:nvSpPr>
               <p:cNvPr id="3" name="Content Placeholder 2">
@@ -29069,7 +29399,7 @@
             </p:spPr>
             <p:txBody>
               <a:bodyPr>
-                <a:normAutofit fontScale="92500" lnSpcReduction="10000"/>
+                <a:normAutofit fontScale="92500"/>
               </a:bodyPr>
               <a:lstStyle/>
               <a:p>
@@ -29318,37 +29648,43 @@
                   <a:rPr lang="en-US" sz="2000" dirty="0">
                     <a:latin typeface="+mj-lt"/>
                   </a:rPr>
-                  <a:t>That is, we consider all predictors </a:t>
+                  <a:t>That is, </a:t>
+                </a:r>
+                <a:r>
+                  <a:rPr lang="en-US" sz="2000" b="1" dirty="0">
+                    <a:latin typeface="+mj-lt"/>
+                  </a:rPr>
+                  <a:t>we consider all predictors </a:t>
                 </a:r>
                 <a14:m>
                   <m:oMath xmlns:m="http://schemas.openxmlformats.org/officeDocument/2006/math">
                     <m:sSub>
                       <m:sSubPr>
                         <m:ctrlPr>
-                          <a:rPr lang="en-US" sz="2000" i="1" smtClean="0">
+                          <a:rPr lang="en-US" sz="2000" b="1" i="1" smtClean="0">
                             <a:latin typeface="Cambria Math" panose="02040503050406030204" pitchFamily="18" charset="0"/>
                           </a:rPr>
                         </m:ctrlPr>
                       </m:sSubPr>
                       <m:e>
                         <m:r>
-                          <a:rPr lang="en-US" sz="2000" b="0" i="1" smtClean="0">
+                          <a:rPr lang="en-US" sz="2000" b="1" i="1" smtClean="0">
                             <a:latin typeface="Cambria Math" panose="02040503050406030204" pitchFamily="18" charset="0"/>
                           </a:rPr>
-                          <m:t>𝑋</m:t>
+                          <m:t>𝑿</m:t>
                         </m:r>
                       </m:e>
                       <m:sub>
                         <m:r>
-                          <a:rPr lang="en-US" sz="2000" i="1">
+                          <a:rPr lang="en-US" sz="2000" b="1" i="1">
                             <a:latin typeface="Cambria Math" panose="02040503050406030204" pitchFamily="18" charset="0"/>
                           </a:rPr>
-                          <m:t>1</m:t>
+                          <m:t>𝟏</m:t>
                         </m:r>
                       </m:sub>
                     </m:sSub>
                     <m:r>
-                      <a:rPr lang="en-US" sz="2000" b="0" i="1" smtClean="0">
+                      <a:rPr lang="en-US" sz="2000" b="1" i="1" smtClean="0">
                         <a:latin typeface="Cambria Math" panose="02040503050406030204" pitchFamily="18" charset="0"/>
                       </a:rPr>
                       <m:t>,</m:t>
@@ -29356,38 +29692,38 @@
                     <m:sSub>
                       <m:sSubPr>
                         <m:ctrlPr>
-                          <a:rPr lang="en-US" sz="2000" i="1">
+                          <a:rPr lang="en-US" sz="2000" b="1" i="1">
                             <a:latin typeface="Cambria Math" panose="02040503050406030204" pitchFamily="18" charset="0"/>
                           </a:rPr>
                         </m:ctrlPr>
                       </m:sSubPr>
                       <m:e>
                         <m:r>
-                          <a:rPr lang="en-US" sz="2000" b="0" i="1" smtClean="0">
+                          <a:rPr lang="en-US" sz="2000" b="1" i="1" smtClean="0">
                             <a:latin typeface="Cambria Math" panose="02040503050406030204" pitchFamily="18" charset="0"/>
                           </a:rPr>
-                          <m:t>𝑋</m:t>
+                          <m:t>𝑿</m:t>
                         </m:r>
                       </m:e>
                       <m:sub>
                         <m:r>
-                          <a:rPr lang="en-US" sz="2000" b="0" i="1" smtClean="0">
+                          <a:rPr lang="en-US" sz="2000" b="1" i="1" smtClean="0">
                             <a:latin typeface="Cambria Math" panose="02040503050406030204" pitchFamily="18" charset="0"/>
                           </a:rPr>
-                          <m:t>2</m:t>
+                          <m:t>𝟐</m:t>
                         </m:r>
                       </m:sub>
                     </m:sSub>
                   </m:oMath>
                 </a14:m>
                 <a:r>
-                  <a:rPr lang="en-US" sz="2000" dirty="0">
+                  <a:rPr lang="en-US" sz="2000" b="1" dirty="0">
                     <a:latin typeface="+mj-lt"/>
                   </a:rPr>
                   <a:t>,…,</a:t>
                 </a:r>
                 <a:r>
-                  <a:rPr lang="en-US" sz="2000" dirty="0"/>
+                  <a:rPr lang="en-US" sz="2000" b="1" dirty="0"/>
                   <a:t> </a:t>
                 </a:r>
                 <a14:m>
@@ -29395,44 +29731,44 @@
                     <m:sSub>
                       <m:sSubPr>
                         <m:ctrlPr>
-                          <a:rPr lang="en-US" sz="2000" i="1">
+                          <a:rPr lang="en-US" sz="2000" b="1" i="1">
                             <a:latin typeface="Cambria Math" panose="02040503050406030204" pitchFamily="18" charset="0"/>
                           </a:rPr>
                         </m:ctrlPr>
                       </m:sSubPr>
                       <m:e>
                         <m:r>
-                          <a:rPr lang="en-US" sz="2000" b="0" i="1" smtClean="0">
+                          <a:rPr lang="en-US" sz="2000" b="1" i="1" smtClean="0">
                             <a:latin typeface="Cambria Math" panose="02040503050406030204" pitchFamily="18" charset="0"/>
                           </a:rPr>
-                          <m:t>𝑋</m:t>
+                          <m:t>𝑿</m:t>
                         </m:r>
                       </m:e>
                       <m:sub>
                         <m:r>
-                          <a:rPr lang="en-US" sz="2000" b="0" i="1" smtClean="0">
+                          <a:rPr lang="en-US" sz="2000" b="1" i="1" smtClean="0">
                             <a:latin typeface="Cambria Math" panose="02040503050406030204" pitchFamily="18" charset="0"/>
                           </a:rPr>
-                          <m:t>𝑝</m:t>
+                          <m:t>𝒑</m:t>
                         </m:r>
                       </m:sub>
                     </m:sSub>
                   </m:oMath>
                 </a14:m>
                 <a:r>
-                  <a:rPr lang="en-US" sz="2000" dirty="0">
+                  <a:rPr lang="en-US" sz="2000" b="1" dirty="0">
                     <a:latin typeface="+mj-lt"/>
                   </a:rPr>
                   <a:t> and all possible values of the </a:t>
                 </a:r>
                 <a:r>
-                  <a:rPr lang="en-US" sz="2000" dirty="0" err="1">
+                  <a:rPr lang="en-US" sz="2000" b="1" dirty="0" err="1">
                     <a:latin typeface="+mj-lt"/>
                   </a:rPr>
                   <a:t>cutpoint</a:t>
                 </a:r>
                 <a:r>
-                  <a:rPr lang="en-US" sz="2000" dirty="0">
+                  <a:rPr lang="en-US" sz="2000" b="1" dirty="0">
                     <a:latin typeface="+mj-lt"/>
                   </a:rPr>
                   <a:t> </a:t>
@@ -29440,30 +29776,36 @@
                 <a14:m>
                   <m:oMath xmlns:m="http://schemas.openxmlformats.org/officeDocument/2006/math">
                     <m:r>
-                      <a:rPr lang="en-US" sz="2000" i="1">
+                      <a:rPr lang="en-US" sz="2000" b="1" i="1">
                         <a:latin typeface="Cambria Math" panose="02040503050406030204" pitchFamily="18" charset="0"/>
                       </a:rPr>
-                      <m:t>𝑠</m:t>
+                      <m:t>𝒔</m:t>
                     </m:r>
                   </m:oMath>
                 </a14:m>
                 <a:r>
-                  <a:rPr lang="en-US" sz="2000" dirty="0">
+                  <a:rPr lang="en-US" sz="2000" b="1" dirty="0">
                     <a:latin typeface="+mj-lt"/>
                   </a:rPr>
                   <a:t> for each predictor, and then choose the predictor and </a:t>
                 </a:r>
                 <a:r>
-                  <a:rPr lang="en-US" sz="2000" dirty="0" err="1">
+                  <a:rPr lang="en-US" sz="2000" b="1" dirty="0" err="1">
                     <a:latin typeface="+mj-lt"/>
                   </a:rPr>
                   <a:t>cutpoint</a:t>
                 </a:r>
                 <a:r>
+                  <a:rPr lang="en-US" sz="2000" b="1" dirty="0">
+                    <a:latin typeface="+mj-lt"/>
+                  </a:rPr>
+                  <a:t> such that the resulting tree has the lowest RSS</a:t>
+                </a:r>
+                <a:r>
                   <a:rPr lang="en-US" sz="2000" dirty="0">
                     <a:latin typeface="+mj-lt"/>
                   </a:rPr>
-                  <a:t> such that the resulting tree has the lowest RSS. In detail:</a:t>
+                  <a:t>. In detail:</a:t>
                 </a:r>
               </a:p>
               <a:p>
@@ -30356,7 +30698,7 @@
               <a:blipFill>
                 <a:blip r:embed="rId2"/>
                 <a:stretch>
-                  <a:fillRect l="-464" t="-1120" r="-348"/>
+                  <a:fillRect l="-464" t="-560" r="-870"/>
                 </a:stretch>
               </a:blipFill>
             </p:spPr>
@@ -30806,22 +31148,22 @@
               <a:buChar char="§"/>
             </a:pPr>
             <a:r>
-              <a:rPr lang="en-US" sz="2000" dirty="0">
+              <a:rPr lang="en-US" sz="2400" dirty="0">
                 <a:latin typeface="+mj-lt"/>
               </a:rPr>
               <a:t>Next, we repeat the process looking for the best predictor and </a:t>
             </a:r>
             <a:r>
-              <a:rPr lang="en-US" sz="2000" dirty="0" err="1">
+              <a:rPr lang="en-US" sz="2400" dirty="0" err="1">
                 <a:latin typeface="+mj-lt"/>
               </a:rPr>
               <a:t>cutpoint</a:t>
             </a:r>
             <a:r>
-              <a:rPr lang="en-US" sz="2000" dirty="0">
+              <a:rPr lang="en-US" sz="2400" dirty="0">
                 <a:latin typeface="+mj-lt"/>
               </a:rPr>
-              <a:t> in order to split the data further so as to minimize the RSS within each of the resulting regions. But we only split the two previously identified regions</a:t>
+              <a:t> in order to split the data further so as to minimize the RSS within each of the resulting regions. </a:t>
             </a:r>
           </a:p>
           <a:p>
@@ -30833,7 +31175,7 @@
               <a:buChar char="§"/>
             </a:pPr>
             <a:r>
-              <a:rPr lang="en-US" sz="2000" dirty="0">
+              <a:rPr lang="en-US" sz="2400" dirty="0">
                 <a:latin typeface="+mj-lt"/>
               </a:rPr>
               <a:t>Now that we have three regions, we look to split one of them the further as to minimize RSS…. </a:t>
@@ -30848,12 +31190,12 @@
               <a:buChar char="§"/>
             </a:pPr>
             <a:r>
-              <a:rPr lang="en-US" sz="2000" dirty="0">
+              <a:rPr lang="en-US" sz="2400" dirty="0">
                 <a:latin typeface="+mj-lt"/>
               </a:rPr>
               <a:t>The process continues until a stopping criterion is reached, for instance, that a region contains less than 5 observations.</a:t>
             </a:r>
-            <a:endParaRPr lang="en-US" sz="2000" dirty="0"/>
+            <a:endParaRPr lang="en-US" sz="2400" dirty="0"/>
           </a:p>
           <a:p>
             <a:pPr marL="0" indent="0">
@@ -30862,7 +31204,7 @@
               </a:lnSpc>
               <a:buNone/>
             </a:pPr>
-            <a:endParaRPr lang="en-US" sz="2000" dirty="0">
+            <a:endParaRPr lang="en-US" sz="2400" dirty="0">
               <a:latin typeface="+mj-lt"/>
             </a:endParaRPr>
           </a:p>
@@ -30873,7 +31215,7 @@
               </a:lnSpc>
               <a:buNone/>
             </a:pPr>
-            <a:endParaRPr lang="en-US" sz="2000" dirty="0">
+            <a:endParaRPr lang="en-US" sz="2400" dirty="0">
               <a:latin typeface="+mj-lt"/>
             </a:endParaRPr>
           </a:p>
@@ -30885,7 +31227,7 @@
               <a:buFont typeface="Wingdings" panose="05000000000000000000" pitchFamily="2" charset="2"/>
               <a:buChar char="§"/>
             </a:pPr>
-            <a:endParaRPr lang="en-US" sz="2000" dirty="0">
+            <a:endParaRPr lang="en-US" sz="2400" dirty="0">
               <a:latin typeface="+mj-lt"/>
             </a:endParaRPr>
           </a:p>
@@ -31325,7 +31667,7 @@
               <a:rPr lang="en-US" sz="2000" dirty="0">
                 <a:latin typeface="+mj-lt"/>
               </a:rPr>
-              <a:t>In reality, this procedure produces very complex trees that tend to overfit the data. </a:t>
+              <a:t>In reality, this procedure produces very complex trees that tend to overfit the data</a:t>
             </a:r>
           </a:p>
           <a:p>
@@ -31367,7 +31709,7 @@
               <a:rPr lang="en-US" sz="2000" dirty="0">
                 <a:latin typeface="+mj-lt"/>
               </a:rPr>
-              <a:t>By pruning a tree some branches are remove, helping in achieving a reasonable accuracy without </a:t>
+              <a:t>By pruning a tree some branches are removed, helping in achieving a reasonable accuracy without </a:t>
             </a:r>
             <a:r>
               <a:rPr lang="en-US" sz="2000" dirty="0" err="1">
@@ -31381,51 +31723,6 @@
               </a:rPr>
               <a:t>. K-fold cross validation is involved in the process of pruning a tree</a:t>
             </a:r>
-          </a:p>
-          <a:p>
-            <a:pPr marL="0" indent="0">
-              <a:lnSpc>
-                <a:spcPct val="100000"/>
-              </a:lnSpc>
-              <a:buNone/>
-            </a:pPr>
-            <a:endParaRPr lang="en-US" sz="2000" dirty="0">
-              <a:latin typeface="+mj-lt"/>
-            </a:endParaRPr>
-          </a:p>
-          <a:p>
-            <a:pPr marL="0" indent="0">
-              <a:lnSpc>
-                <a:spcPct val="100000"/>
-              </a:lnSpc>
-              <a:buNone/>
-            </a:pPr>
-            <a:endParaRPr lang="en-US" sz="2000" dirty="0">
-              <a:latin typeface="+mj-lt"/>
-            </a:endParaRPr>
-          </a:p>
-          <a:p>
-            <a:pPr marL="0" indent="0">
-              <a:lnSpc>
-                <a:spcPct val="100000"/>
-              </a:lnSpc>
-              <a:buNone/>
-            </a:pPr>
-            <a:endParaRPr lang="en-US" sz="2000" dirty="0">
-              <a:latin typeface="+mj-lt"/>
-            </a:endParaRPr>
-          </a:p>
-          <a:p>
-            <a:pPr>
-              <a:lnSpc>
-                <a:spcPct val="100000"/>
-              </a:lnSpc>
-              <a:buFont typeface="Wingdings" panose="05000000000000000000" pitchFamily="2" charset="2"/>
-              <a:buChar char="§"/>
-            </a:pPr>
-            <a:endParaRPr lang="en-US" sz="2000" dirty="0">
-              <a:latin typeface="+mj-lt"/>
-            </a:endParaRPr>
           </a:p>
         </p:txBody>
       </p:sp>
@@ -31761,6 +32058,156 @@
               <a:effectLst/>
               <a:latin typeface="Arial" panose="020B0604020202020204" pitchFamily="34" charset="0"/>
             </a:endParaRPr>
+          </a:p>
+        </p:txBody>
+      </p:sp>
+      <p:pic>
+        <p:nvPicPr>
+          <p:cNvPr id="10" name="Picture 9">
+            <a:extLst>
+              <a:ext uri="{FF2B5EF4-FFF2-40B4-BE49-F238E27FC236}">
+                <a16:creationId xmlns:a16="http://schemas.microsoft.com/office/drawing/2014/main" id="{867FB5BA-00BB-C932-E118-6DF3C43B208E}"/>
+              </a:ext>
+            </a:extLst>
+          </p:cNvPr>
+          <p:cNvPicPr>
+            <a:picLocks noChangeAspect="1"/>
+          </p:cNvPicPr>
+          <p:nvPr/>
+        </p:nvPicPr>
+        <p:blipFill>
+          <a:blip r:embed="rId2"/>
+          <a:stretch>
+            <a:fillRect/>
+          </a:stretch>
+        </p:blipFill>
+        <p:spPr>
+          <a:xfrm>
+            <a:off x="6743137" y="3766439"/>
+            <a:ext cx="3994622" cy="2749296"/>
+          </a:xfrm>
+          <a:prstGeom prst="rect">
+            <a:avLst/>
+          </a:prstGeom>
+        </p:spPr>
+      </p:pic>
+      <p:grpSp>
+        <p:nvGrpSpPr>
+          <p:cNvPr id="12" name="Group 11">
+            <a:extLst>
+              <a:ext uri="{FF2B5EF4-FFF2-40B4-BE49-F238E27FC236}">
+                <a16:creationId xmlns:a16="http://schemas.microsoft.com/office/drawing/2014/main" id="{76464B13-1F9D-C0B0-42EA-CE49914A9F13}"/>
+              </a:ext>
+            </a:extLst>
+          </p:cNvPr>
+          <p:cNvGrpSpPr>
+            <a:grpSpLocks noChangeAspect="1"/>
+          </p:cNvGrpSpPr>
+          <p:nvPr/>
+        </p:nvGrpSpPr>
+        <p:grpSpPr>
+          <a:xfrm>
+            <a:off x="1111995" y="3993514"/>
+            <a:ext cx="4813923" cy="2258823"/>
+            <a:chOff x="2096102" y="4457899"/>
+            <a:chExt cx="4336868" cy="2034976"/>
+          </a:xfrm>
+        </p:grpSpPr>
+        <p:pic>
+          <p:nvPicPr>
+            <p:cNvPr id="8" name="Picture 7">
+              <a:extLst>
+                <a:ext uri="{FF2B5EF4-FFF2-40B4-BE49-F238E27FC236}">
+                  <a16:creationId xmlns:a16="http://schemas.microsoft.com/office/drawing/2014/main" id="{4AEA9345-07CD-FFBC-E13C-A7370AF2486D}"/>
+                </a:ext>
+              </a:extLst>
+            </p:cNvPr>
+            <p:cNvPicPr>
+              <a:picLocks noChangeAspect="1"/>
+            </p:cNvPicPr>
+            <p:nvPr/>
+          </p:nvPicPr>
+          <p:blipFill rotWithShape="1">
+            <a:blip r:embed="rId3"/>
+            <a:srcRect t="61134"/>
+            <a:stretch/>
+          </p:blipFill>
+          <p:spPr>
+            <a:xfrm>
+              <a:off x="2096102" y="5014210"/>
+              <a:ext cx="4336868" cy="1478665"/>
+            </a:xfrm>
+            <a:prstGeom prst="rect">
+              <a:avLst/>
+            </a:prstGeom>
+          </p:spPr>
+        </p:pic>
+        <p:pic>
+          <p:nvPicPr>
+            <p:cNvPr id="11" name="Picture 10">
+              <a:extLst>
+                <a:ext uri="{FF2B5EF4-FFF2-40B4-BE49-F238E27FC236}">
+                  <a16:creationId xmlns:a16="http://schemas.microsoft.com/office/drawing/2014/main" id="{7FD07041-4642-AAE5-A2F4-218AB34D9AAD}"/>
+                </a:ext>
+              </a:extLst>
+            </p:cNvPr>
+            <p:cNvPicPr>
+              <a:picLocks noChangeAspect="1"/>
+            </p:cNvPicPr>
+            <p:nvPr/>
+          </p:nvPicPr>
+          <p:blipFill rotWithShape="1">
+            <a:blip r:embed="rId3"/>
+            <a:srcRect b="85378"/>
+            <a:stretch/>
+          </p:blipFill>
+          <p:spPr>
+            <a:xfrm>
+              <a:off x="2096102" y="4457899"/>
+              <a:ext cx="4336868" cy="556311"/>
+            </a:xfrm>
+            <a:prstGeom prst="rect">
+              <a:avLst/>
+            </a:prstGeom>
+          </p:spPr>
+        </p:pic>
+      </p:grpSp>
+      <p:sp>
+        <p:nvSpPr>
+          <p:cNvPr id="14" name="TextBox 13">
+            <a:extLst>
+              <a:ext uri="{FF2B5EF4-FFF2-40B4-BE49-F238E27FC236}">
+                <a16:creationId xmlns:a16="http://schemas.microsoft.com/office/drawing/2014/main" id="{BE14FEB2-BA14-D3CC-0354-74D6D463469B}"/>
+              </a:ext>
+            </a:extLst>
+          </p:cNvPr>
+          <p:cNvSpPr txBox="1"/>
+          <p:nvPr/>
+        </p:nvSpPr>
+        <p:spPr>
+          <a:xfrm>
+            <a:off x="747934" y="4487818"/>
+            <a:ext cx="1338773" cy="307777"/>
+          </a:xfrm>
+          <a:prstGeom prst="rect">
+            <a:avLst/>
+          </a:prstGeom>
+          <a:noFill/>
+        </p:spPr>
+        <p:txBody>
+          <a:bodyPr wrap="square" rtlCol="0">
+            <a:spAutoFit/>
+          </a:bodyPr>
+          <a:lstStyle/>
+          <a:p>
+            <a:r>
+              <a:rPr lang="en-US" sz="1400" dirty="0">
+                <a:solidFill>
+                  <a:srgbClr val="FF0000"/>
+                </a:solidFill>
+              </a:rPr>
+              <a:t>unpruned tree</a:t>
+            </a:r>
           </a:p>
         </p:txBody>
       </p:sp>

</xml_diff>

<commit_message>
changes in slides and notebooks
</commit_message>
<xml_diff>
--- a/Course content/Slides/Topic 5 - Tree-based methods.pptx
+++ b/Course content/Slides/Topic 5 - Tree-based methods.pptx
@@ -5,7 +5,7 @@
     <p:sldMasterId id="2147483648" r:id="rId1"/>
   </p:sldMasterIdLst>
   <p:notesMasterIdLst>
-    <p:notesMasterId r:id="rId15"/>
+    <p:notesMasterId r:id="rId22"/>
   </p:notesMasterIdLst>
   <p:sldIdLst>
     <p:sldId id="278" r:id="rId2"/>
@@ -20,7 +20,14 @@
     <p:sldId id="307" r:id="rId11"/>
     <p:sldId id="308" r:id="rId12"/>
     <p:sldId id="309" r:id="rId13"/>
-    <p:sldId id="310" r:id="rId14"/>
+    <p:sldId id="311" r:id="rId14"/>
+    <p:sldId id="310" r:id="rId15"/>
+    <p:sldId id="312" r:id="rId16"/>
+    <p:sldId id="313" r:id="rId17"/>
+    <p:sldId id="314" r:id="rId18"/>
+    <p:sldId id="315" r:id="rId19"/>
+    <p:sldId id="317" r:id="rId20"/>
+    <p:sldId id="316" r:id="rId21"/>
   </p:sldIdLst>
   <p:sldSz cx="12192000" cy="6858000"/>
   <p:notesSz cx="6858000" cy="9144000"/>
@@ -220,7 +227,7 @@
           <a:p>
             <a:fld id="{B9B1DC7F-8587-4047-9A5D-1FCB6614CAE0}" type="datetimeFigureOut">
               <a:rPr lang="en-US" smtClean="0"/>
-              <a:t>10/28/2022</a:t>
+              <a:t>10/31/2022</a:t>
             </a:fld>
             <a:endParaRPr lang="en-US"/>
           </a:p>
@@ -634,7 +641,7 @@
           <a:p>
             <a:fld id="{A7DB5662-7327-465C-9A70-AD96B7A8D67A}" type="datetimeFigureOut">
               <a:rPr lang="en-US" smtClean="0"/>
-              <a:t>10/28/2022</a:t>
+              <a:t>10/31/2022</a:t>
             </a:fld>
             <a:endParaRPr lang="en-US"/>
           </a:p>
@@ -832,7 +839,7 @@
           <a:p>
             <a:fld id="{A7DB5662-7327-465C-9A70-AD96B7A8D67A}" type="datetimeFigureOut">
               <a:rPr lang="en-US" smtClean="0"/>
-              <a:t>10/28/2022</a:t>
+              <a:t>10/31/2022</a:t>
             </a:fld>
             <a:endParaRPr lang="en-US"/>
           </a:p>
@@ -1040,7 +1047,7 @@
           <a:p>
             <a:fld id="{A7DB5662-7327-465C-9A70-AD96B7A8D67A}" type="datetimeFigureOut">
               <a:rPr lang="en-US" smtClean="0"/>
-              <a:t>10/28/2022</a:t>
+              <a:t>10/31/2022</a:t>
             </a:fld>
             <a:endParaRPr lang="en-US"/>
           </a:p>
@@ -1238,7 +1245,7 @@
           <a:p>
             <a:fld id="{A7DB5662-7327-465C-9A70-AD96B7A8D67A}" type="datetimeFigureOut">
               <a:rPr lang="en-US" smtClean="0"/>
-              <a:t>10/28/2022</a:t>
+              <a:t>10/31/2022</a:t>
             </a:fld>
             <a:endParaRPr lang="en-US"/>
           </a:p>
@@ -1513,7 +1520,7 @@
           <a:p>
             <a:fld id="{A7DB5662-7327-465C-9A70-AD96B7A8D67A}" type="datetimeFigureOut">
               <a:rPr lang="en-US" smtClean="0"/>
-              <a:t>10/28/2022</a:t>
+              <a:t>10/31/2022</a:t>
             </a:fld>
             <a:endParaRPr lang="en-US"/>
           </a:p>
@@ -1778,7 +1785,7 @@
           <a:p>
             <a:fld id="{A7DB5662-7327-465C-9A70-AD96B7A8D67A}" type="datetimeFigureOut">
               <a:rPr lang="en-US" smtClean="0"/>
-              <a:t>10/28/2022</a:t>
+              <a:t>10/31/2022</a:t>
             </a:fld>
             <a:endParaRPr lang="en-US"/>
           </a:p>
@@ -2190,7 +2197,7 @@
           <a:p>
             <a:fld id="{A7DB5662-7327-465C-9A70-AD96B7A8D67A}" type="datetimeFigureOut">
               <a:rPr lang="en-US" smtClean="0"/>
-              <a:t>10/28/2022</a:t>
+              <a:t>10/31/2022</a:t>
             </a:fld>
             <a:endParaRPr lang="en-US"/>
           </a:p>
@@ -2331,7 +2338,7 @@
           <a:p>
             <a:fld id="{A7DB5662-7327-465C-9A70-AD96B7A8D67A}" type="datetimeFigureOut">
               <a:rPr lang="en-US" smtClean="0"/>
-              <a:t>10/28/2022</a:t>
+              <a:t>10/31/2022</a:t>
             </a:fld>
             <a:endParaRPr lang="en-US"/>
           </a:p>
@@ -2444,7 +2451,7 @@
           <a:p>
             <a:fld id="{A7DB5662-7327-465C-9A70-AD96B7A8D67A}" type="datetimeFigureOut">
               <a:rPr lang="en-US" smtClean="0"/>
-              <a:t>10/28/2022</a:t>
+              <a:t>10/31/2022</a:t>
             </a:fld>
             <a:endParaRPr lang="en-US"/>
           </a:p>
@@ -2755,7 +2762,7 @@
           <a:p>
             <a:fld id="{A7DB5662-7327-465C-9A70-AD96B7A8D67A}" type="datetimeFigureOut">
               <a:rPr lang="en-US" smtClean="0"/>
-              <a:t>10/28/2022</a:t>
+              <a:t>10/31/2022</a:t>
             </a:fld>
             <a:endParaRPr lang="en-US"/>
           </a:p>
@@ -3043,7 +3050,7 @@
           <a:p>
             <a:fld id="{A7DB5662-7327-465C-9A70-AD96B7A8D67A}" type="datetimeFigureOut">
               <a:rPr lang="en-US" smtClean="0"/>
-              <a:t>10/28/2022</a:t>
+              <a:t>10/31/2022</a:t>
             </a:fld>
             <a:endParaRPr lang="en-US"/>
           </a:p>
@@ -3284,7 +3291,7 @@
           <a:p>
             <a:fld id="{A7DB5662-7327-465C-9A70-AD96B7A8D67A}" type="datetimeFigureOut">
               <a:rPr lang="en-US" smtClean="0"/>
-              <a:t>10/28/2022</a:t>
+              <a:t>10/31/2022</a:t>
             </a:fld>
             <a:endParaRPr lang="en-US"/>
           </a:p>
@@ -21681,8 +21688,8 @@
           </a:p>
         </p:txBody>
       </p:sp>
-      <mc:AlternateContent xmlns:mc="http://schemas.openxmlformats.org/markup-compatibility/2006">
-        <mc:Choice xmlns:a14="http://schemas.microsoft.com/office/drawing/2010/main" Requires="a14">
+      <mc:AlternateContent xmlns:mc="http://schemas.openxmlformats.org/markup-compatibility/2006" xmlns:a14="http://schemas.microsoft.com/office/drawing/2010/main">
+        <mc:Choice Requires="a14">
           <p:sp>
             <p:nvSpPr>
               <p:cNvPr id="3" name="Content Placeholder 2">
@@ -21977,7 +21984,7 @@
             </p:txBody>
           </p:sp>
         </mc:Choice>
-        <mc:Fallback>
+        <mc:Fallback xmlns="">
           <p:sp>
             <p:nvSpPr>
               <p:cNvPr id="3" name="Content Placeholder 2">
@@ -23870,6 +23877,610 @@
           <a:p>
             <a:r>
               <a:rPr lang="en-US" sz="4000" dirty="0"/>
+              <a:t>Decision Trees - Regularization</a:t>
+            </a:r>
+          </a:p>
+        </p:txBody>
+      </p:sp>
+      <p:sp>
+        <p:nvSpPr>
+          <p:cNvPr id="3" name="Content Placeholder 2">
+            <a:extLst>
+              <a:ext uri="{FF2B5EF4-FFF2-40B4-BE49-F238E27FC236}">
+                <a16:creationId xmlns:a16="http://schemas.microsoft.com/office/drawing/2014/main" id="{068F0C39-44FF-99B2-7103-C6D38F774B5B}"/>
+              </a:ext>
+            </a:extLst>
+          </p:cNvPr>
+          <p:cNvSpPr>
+            <a:spLocks noGrp="1"/>
+          </p:cNvSpPr>
+          <p:nvPr>
+            <p:ph idx="1"/>
+          </p:nvPr>
+        </p:nvSpPr>
+        <p:spPr>
+          <a:xfrm>
+            <a:off x="844778" y="1819047"/>
+            <a:ext cx="10515600" cy="4351338"/>
+          </a:xfrm>
+        </p:spPr>
+        <p:txBody>
+          <a:bodyPr>
+            <a:normAutofit fontScale="92500" lnSpcReduction="10000"/>
+          </a:bodyPr>
+          <a:lstStyle/>
+          <a:p>
+            <a:pPr>
+              <a:lnSpc>
+                <a:spcPct val="150000"/>
+              </a:lnSpc>
+              <a:buFont typeface="Wingdings" panose="05000000000000000000" pitchFamily="2" charset="2"/>
+              <a:buChar char="§"/>
+            </a:pPr>
+            <a:r>
+              <a:rPr lang="en-US" sz="2000" dirty="0">
+                <a:latin typeface="+mj-lt"/>
+              </a:rPr>
+              <a:t>As mentioned, decision trees make very few assumptions about the training data. Hence, if left unconstrained, they will adapt to the data, fitting very closely (overfitting)</a:t>
+            </a:r>
+          </a:p>
+          <a:p>
+            <a:pPr>
+              <a:lnSpc>
+                <a:spcPct val="150000"/>
+              </a:lnSpc>
+              <a:buFont typeface="Wingdings" panose="05000000000000000000" pitchFamily="2" charset="2"/>
+              <a:buChar char="§"/>
+            </a:pPr>
+            <a:r>
+              <a:rPr lang="en-US" sz="2000" dirty="0">
+                <a:latin typeface="+mj-lt"/>
+              </a:rPr>
+              <a:t>Alternatively to pruning in order to avoid overfitting, it is possible to restrict the Decision tree freedom during training via its hyperparameters. This is called </a:t>
+            </a:r>
+            <a:r>
+              <a:rPr lang="en-US" sz="2000" i="1" dirty="0">
+                <a:latin typeface="+mj-lt"/>
+              </a:rPr>
+              <a:t>regularization</a:t>
+            </a:r>
+          </a:p>
+          <a:p>
+            <a:pPr>
+              <a:lnSpc>
+                <a:spcPct val="150000"/>
+              </a:lnSpc>
+              <a:buFont typeface="Wingdings" panose="05000000000000000000" pitchFamily="2" charset="2"/>
+              <a:buChar char="§"/>
+            </a:pPr>
+            <a:r>
+              <a:rPr lang="en-US" sz="2000" dirty="0">
+                <a:latin typeface="+mj-lt"/>
+              </a:rPr>
+              <a:t>It is possible to tweak:</a:t>
+            </a:r>
+          </a:p>
+          <a:p>
+            <a:pPr lvl="1">
+              <a:lnSpc>
+                <a:spcPct val="150000"/>
+              </a:lnSpc>
+              <a:buFont typeface="Wingdings" panose="05000000000000000000" pitchFamily="2" charset="2"/>
+              <a:buChar char="§"/>
+            </a:pPr>
+            <a:r>
+              <a:rPr lang="en-US" sz="1600" b="1" dirty="0" err="1">
+                <a:latin typeface="+mj-lt"/>
+              </a:rPr>
+              <a:t>max_depth</a:t>
+            </a:r>
+            <a:r>
+              <a:rPr lang="en-US" sz="1600" dirty="0">
+                <a:latin typeface="+mj-lt"/>
+              </a:rPr>
+              <a:t>: maximum depth (nodes) of the trees</a:t>
+            </a:r>
+          </a:p>
+          <a:p>
+            <a:pPr lvl="1">
+              <a:lnSpc>
+                <a:spcPct val="150000"/>
+              </a:lnSpc>
+              <a:buFont typeface="Wingdings" panose="05000000000000000000" pitchFamily="2" charset="2"/>
+              <a:buChar char="§"/>
+            </a:pPr>
+            <a:r>
+              <a:rPr lang="en-US" sz="1600" b="1" dirty="0" err="1">
+                <a:latin typeface="+mj-lt"/>
+              </a:rPr>
+              <a:t>min_samples_split</a:t>
+            </a:r>
+            <a:r>
+              <a:rPr lang="en-US" sz="1600" dirty="0">
+                <a:latin typeface="+mj-lt"/>
+              </a:rPr>
+              <a:t>: minimum number of samples a node must have before splitting it</a:t>
+            </a:r>
+          </a:p>
+          <a:p>
+            <a:pPr lvl="1">
+              <a:lnSpc>
+                <a:spcPct val="150000"/>
+              </a:lnSpc>
+              <a:buFont typeface="Wingdings" panose="05000000000000000000" pitchFamily="2" charset="2"/>
+              <a:buChar char="§"/>
+            </a:pPr>
+            <a:r>
+              <a:rPr lang="en-US" sz="1600" b="1" dirty="0" err="1">
+                <a:latin typeface="+mj-lt"/>
+              </a:rPr>
+              <a:t>min_samples_leaf</a:t>
+            </a:r>
+            <a:r>
+              <a:rPr lang="en-US" sz="1600" dirty="0">
+                <a:latin typeface="+mj-lt"/>
+              </a:rPr>
+              <a:t>: minimum number of samples a leaf node must have</a:t>
+            </a:r>
+          </a:p>
+          <a:p>
+            <a:pPr lvl="1">
+              <a:lnSpc>
+                <a:spcPct val="150000"/>
+              </a:lnSpc>
+              <a:buFont typeface="Wingdings" panose="05000000000000000000" pitchFamily="2" charset="2"/>
+              <a:buChar char="§"/>
+            </a:pPr>
+            <a:r>
+              <a:rPr lang="en-US" sz="1600" b="1" dirty="0" err="1">
+                <a:latin typeface="+mj-lt"/>
+              </a:rPr>
+              <a:t>max_leaf_nodes</a:t>
+            </a:r>
+            <a:r>
+              <a:rPr lang="en-US" sz="1600" dirty="0">
+                <a:latin typeface="+mj-lt"/>
+              </a:rPr>
+              <a:t>: maximum number of </a:t>
+            </a:r>
+            <a:r>
+              <a:rPr lang="en-US" sz="1600" dirty="0" err="1">
+                <a:latin typeface="+mj-lt"/>
+              </a:rPr>
+              <a:t>leafs</a:t>
+            </a:r>
+            <a:r>
+              <a:rPr lang="en-US" sz="1600" dirty="0">
+                <a:latin typeface="+mj-lt"/>
+              </a:rPr>
+              <a:t> nodes</a:t>
+            </a:r>
+          </a:p>
+          <a:p>
+            <a:pPr lvl="1">
+              <a:lnSpc>
+                <a:spcPct val="150000"/>
+              </a:lnSpc>
+              <a:buFont typeface="Wingdings" panose="05000000000000000000" pitchFamily="2" charset="2"/>
+              <a:buChar char="§"/>
+            </a:pPr>
+            <a:r>
+              <a:rPr lang="en-US" sz="1600" b="1" dirty="0" err="1">
+                <a:latin typeface="+mj-lt"/>
+              </a:rPr>
+              <a:t>max_features</a:t>
+            </a:r>
+            <a:r>
+              <a:rPr lang="en-US" sz="1600" dirty="0">
+                <a:latin typeface="+mj-lt"/>
+              </a:rPr>
+              <a:t>: maximum number of features evaluated for splitting</a:t>
+            </a:r>
+          </a:p>
+          <a:p>
+            <a:pPr lvl="1">
+              <a:lnSpc>
+                <a:spcPct val="150000"/>
+              </a:lnSpc>
+              <a:buFont typeface="Wingdings" panose="05000000000000000000" pitchFamily="2" charset="2"/>
+              <a:buChar char="§"/>
+            </a:pPr>
+            <a:endParaRPr lang="en-US" sz="1600" dirty="0">
+              <a:latin typeface="+mj-lt"/>
+            </a:endParaRPr>
+          </a:p>
+        </p:txBody>
+      </p:sp>
+      <p:sp>
+        <p:nvSpPr>
+          <p:cNvPr id="4" name="Rectángulo 3">
+            <a:extLst>
+              <a:ext uri="{FF2B5EF4-FFF2-40B4-BE49-F238E27FC236}">
+                <a16:creationId xmlns:a16="http://schemas.microsoft.com/office/drawing/2014/main" id="{7BF95E35-4D9C-7F59-F308-C61FF9CD1B58}"/>
+              </a:ext>
+            </a:extLst>
+          </p:cNvPr>
+          <p:cNvSpPr/>
+          <p:nvPr/>
+        </p:nvSpPr>
+        <p:spPr>
+          <a:xfrm>
+            <a:off x="0" y="0"/>
+            <a:ext cx="374469" cy="6858000"/>
+          </a:xfrm>
+          <a:prstGeom prst="rect">
+            <a:avLst/>
+          </a:prstGeom>
+        </p:spPr>
+        <p:style>
+          <a:lnRef idx="2">
+            <a:schemeClr val="accent2">
+              <a:shade val="50000"/>
+            </a:schemeClr>
+          </a:lnRef>
+          <a:fillRef idx="1">
+            <a:schemeClr val="accent2"/>
+          </a:fillRef>
+          <a:effectRef idx="0">
+            <a:schemeClr val="accent2"/>
+          </a:effectRef>
+          <a:fontRef idx="minor">
+            <a:schemeClr val="lt1"/>
+          </a:fontRef>
+        </p:style>
+        <p:txBody>
+          <a:bodyPr rtlCol="0" anchor="ctr"/>
+          <a:lstStyle/>
+          <a:p>
+            <a:pPr algn="ctr"/>
+            <a:endParaRPr lang="es-ES"/>
+          </a:p>
+        </p:txBody>
+      </p:sp>
+      <p:sp>
+        <p:nvSpPr>
+          <p:cNvPr id="6" name="Rectangle 143">
+            <a:extLst>
+              <a:ext uri="{FF2B5EF4-FFF2-40B4-BE49-F238E27FC236}">
+                <a16:creationId xmlns:a16="http://schemas.microsoft.com/office/drawing/2014/main" id="{C9A975F5-C7DC-9274-20CA-B5939A2A86BD}"/>
+              </a:ext>
+            </a:extLst>
+          </p:cNvPr>
+          <p:cNvSpPr>
+            <a:spLocks noChangeArrowheads="1"/>
+          </p:cNvSpPr>
+          <p:nvPr/>
+        </p:nvSpPr>
+        <p:spPr bwMode="auto">
+          <a:xfrm>
+            <a:off x="448342" y="6549317"/>
+            <a:ext cx="5730175" cy="261610"/>
+          </a:xfrm>
+          <a:prstGeom prst="rect">
+            <a:avLst/>
+          </a:prstGeom>
+          <a:noFill/>
+          <a:ln>
+            <a:noFill/>
+          </a:ln>
+          <a:effectLst/>
+          <a:extLst>
+            <a:ext uri="{909E8E84-426E-40DD-AFC4-6F175D3DCCD1}">
+              <a14:hiddenFill xmlns:a14="http://schemas.microsoft.com/office/drawing/2010/main">
+                <a:solidFill>
+                  <a:schemeClr val="accent1"/>
+                </a:solidFill>
+              </a14:hiddenFill>
+            </a:ext>
+            <a:ext uri="{91240B29-F687-4F45-9708-019B960494DF}">
+              <a14:hiddenLine xmlns:a14="http://schemas.microsoft.com/office/drawing/2010/main" w="9525">
+                <a:solidFill>
+                  <a:schemeClr val="tx1"/>
+                </a:solidFill>
+                <a:miter lim="800000"/>
+                <a:headEnd/>
+                <a:tailEnd/>
+              </a14:hiddenLine>
+            </a:ext>
+            <a:ext uri="{AF507438-7753-43E0-B8FC-AC1667EBCBE1}">
+              <a14:hiddenEffects xmlns:a14="http://schemas.microsoft.com/office/drawing/2010/main">
+                <a:effectLst>
+                  <a:outerShdw dist="35921" dir="2700000" algn="ctr" rotWithShape="0">
+                    <a:schemeClr val="bg2"/>
+                  </a:outerShdw>
+                </a:effectLst>
+              </a14:hiddenEffects>
+            </a:ext>
+          </a:extLst>
+        </p:spPr>
+        <p:txBody>
+          <a:bodyPr vert="horz" wrap="square" lIns="91440" tIns="45720" rIns="91440" bIns="45720" numCol="1" anchor="ctr" anchorCtr="0" compatLnSpc="1">
+            <a:prstTxWarp prst="textNoShape">
+              <a:avLst/>
+            </a:prstTxWarp>
+            <a:spAutoFit/>
+          </a:bodyPr>
+          <a:lstStyle/>
+          <a:p>
+            <a:pPr marL="0" marR="0" lvl="0" indent="0" algn="l" defTabSz="914400" rtl="0" eaLnBrk="0" fontAlgn="base" latinLnBrk="0" hangingPunct="0">
+              <a:lnSpc>
+                <a:spcPct val="100000"/>
+              </a:lnSpc>
+              <a:spcBef>
+                <a:spcPct val="0"/>
+              </a:spcBef>
+              <a:spcAft>
+                <a:spcPct val="0"/>
+              </a:spcAft>
+              <a:buClrTx/>
+              <a:buSzTx/>
+              <a:buFontTx/>
+              <a:buNone/>
+              <a:tabLst/>
+            </a:pPr>
+            <a:r>
+              <a:rPr kumimoji="0" lang="en-US" altLang="es-ES" sz="1100" b="0" i="0" u="none" strike="noStrike" cap="none" normalizeH="0" baseline="0" dirty="0">
+                <a:ln>
+                  <a:noFill/>
+                </a:ln>
+                <a:solidFill>
+                  <a:srgbClr val="F4A200"/>
+                </a:solidFill>
+                <a:effectLst/>
+                <a:latin typeface="Arial" panose="020B0604020202020204" pitchFamily="34" charset="0"/>
+                <a:ea typeface="Myriad Pro Light"/>
+                <a:cs typeface="Times New Roman" panose="02020603050405020304" pitchFamily="18" charset="0"/>
+              </a:rPr>
+              <a:t>Master in Quantitative Economic Analysis </a:t>
+            </a:r>
+            <a:r>
+              <a:rPr kumimoji="0" lang="en-US" altLang="es-ES" sz="1100" b="0" i="0" u="none" strike="noStrike" cap="none" normalizeH="0" baseline="0" dirty="0" err="1">
+                <a:ln>
+                  <a:noFill/>
+                </a:ln>
+                <a:solidFill>
+                  <a:srgbClr val="F4A200"/>
+                </a:solidFill>
+                <a:effectLst/>
+                <a:latin typeface="Arial" panose="020B0604020202020204" pitchFamily="34" charset="0"/>
+                <a:ea typeface="Myriad Pro Light"/>
+                <a:cs typeface="Times New Roman" panose="02020603050405020304" pitchFamily="18" charset="0"/>
+              </a:rPr>
+              <a:t>MQuEA</a:t>
+            </a:r>
+            <a:endParaRPr kumimoji="0" lang="es-ES" altLang="es-ES" sz="300" b="0" i="0" u="none" strike="noStrike" cap="none" normalizeH="0" baseline="0" dirty="0">
+              <a:ln>
+                <a:noFill/>
+              </a:ln>
+              <a:solidFill>
+                <a:schemeClr val="tx1"/>
+              </a:solidFill>
+              <a:effectLst/>
+              <a:latin typeface="Arial" panose="020B0604020202020204" pitchFamily="34" charset="0"/>
+            </a:endParaRPr>
+          </a:p>
+        </p:txBody>
+      </p:sp>
+      <p:sp>
+        <p:nvSpPr>
+          <p:cNvPr id="7" name="Rectangle 143">
+            <a:extLst>
+              <a:ext uri="{FF2B5EF4-FFF2-40B4-BE49-F238E27FC236}">
+                <a16:creationId xmlns:a16="http://schemas.microsoft.com/office/drawing/2014/main" id="{2BE2E3EB-749E-E562-030D-C3F46E714169}"/>
+              </a:ext>
+            </a:extLst>
+          </p:cNvPr>
+          <p:cNvSpPr>
+            <a:spLocks noChangeArrowheads="1"/>
+          </p:cNvSpPr>
+          <p:nvPr/>
+        </p:nvSpPr>
+        <p:spPr bwMode="auto">
+          <a:xfrm>
+            <a:off x="6186394" y="6559955"/>
+            <a:ext cx="5730175" cy="261610"/>
+          </a:xfrm>
+          <a:prstGeom prst="rect">
+            <a:avLst/>
+          </a:prstGeom>
+          <a:noFill/>
+          <a:ln>
+            <a:noFill/>
+          </a:ln>
+          <a:effectLst/>
+          <a:extLst>
+            <a:ext uri="{909E8E84-426E-40DD-AFC4-6F175D3DCCD1}">
+              <a14:hiddenFill xmlns:a14="http://schemas.microsoft.com/office/drawing/2010/main">
+                <a:solidFill>
+                  <a:schemeClr val="accent1"/>
+                </a:solidFill>
+              </a14:hiddenFill>
+            </a:ext>
+            <a:ext uri="{91240B29-F687-4F45-9708-019B960494DF}">
+              <a14:hiddenLine xmlns:a14="http://schemas.microsoft.com/office/drawing/2010/main" w="9525">
+                <a:solidFill>
+                  <a:schemeClr val="tx1"/>
+                </a:solidFill>
+                <a:miter lim="800000"/>
+                <a:headEnd/>
+                <a:tailEnd/>
+              </a14:hiddenLine>
+            </a:ext>
+            <a:ext uri="{AF507438-7753-43E0-B8FC-AC1667EBCBE1}">
+              <a14:hiddenEffects xmlns:a14="http://schemas.microsoft.com/office/drawing/2010/main">
+                <a:effectLst>
+                  <a:outerShdw dist="35921" dir="2700000" algn="ctr" rotWithShape="0">
+                    <a:schemeClr val="bg2"/>
+                  </a:outerShdw>
+                </a:effectLst>
+              </a14:hiddenEffects>
+            </a:ext>
+          </a:extLst>
+        </p:spPr>
+        <p:txBody>
+          <a:bodyPr vert="horz" wrap="square" lIns="91440" tIns="45720" rIns="91440" bIns="45720" numCol="1" anchor="ctr" anchorCtr="0" compatLnSpc="1">
+            <a:prstTxWarp prst="textNoShape">
+              <a:avLst/>
+            </a:prstTxWarp>
+            <a:spAutoFit/>
+          </a:bodyPr>
+          <a:lstStyle/>
+          <a:p>
+            <a:pPr marL="0" marR="0" lvl="0" indent="0" algn="r" defTabSz="914400" rtl="0" eaLnBrk="0" fontAlgn="base" latinLnBrk="0" hangingPunct="0">
+              <a:lnSpc>
+                <a:spcPct val="100000"/>
+              </a:lnSpc>
+              <a:spcBef>
+                <a:spcPct val="0"/>
+              </a:spcBef>
+              <a:spcAft>
+                <a:spcPct val="0"/>
+              </a:spcAft>
+              <a:buClrTx/>
+              <a:buSzTx/>
+              <a:buFontTx/>
+              <a:buNone/>
+              <a:tabLst/>
+            </a:pPr>
+            <a:r>
+              <a:rPr kumimoji="0" lang="en-US" altLang="es-ES" sz="1100" b="0" i="0" u="none" strike="noStrike" cap="none" normalizeH="0" baseline="0" dirty="0">
+                <a:ln>
+                  <a:noFill/>
+                </a:ln>
+                <a:solidFill>
+                  <a:srgbClr val="F4A200"/>
+                </a:solidFill>
+                <a:effectLst/>
+                <a:latin typeface="Arial" panose="020B0604020202020204" pitchFamily="34" charset="0"/>
+                <a:ea typeface="Myriad Pro Light"/>
+                <a:cs typeface="Times New Roman" panose="02020603050405020304" pitchFamily="18" charset="0"/>
+              </a:rPr>
+              <a:t>Universidad </a:t>
+            </a:r>
+            <a:r>
+              <a:rPr kumimoji="0" lang="en-US" altLang="es-ES" sz="1100" b="0" i="0" u="none" strike="noStrike" cap="none" normalizeH="0" baseline="0" dirty="0" err="1">
+                <a:ln>
+                  <a:noFill/>
+                </a:ln>
+                <a:solidFill>
+                  <a:srgbClr val="F4A200"/>
+                </a:solidFill>
+                <a:effectLst/>
+                <a:latin typeface="Arial" panose="020B0604020202020204" pitchFamily="34" charset="0"/>
+                <a:ea typeface="Myriad Pro Light"/>
+                <a:cs typeface="Times New Roman" panose="02020603050405020304" pitchFamily="18" charset="0"/>
+              </a:rPr>
+              <a:t>Aut</a:t>
+            </a:r>
+            <a:r>
+              <a:rPr lang="en-US" altLang="es-ES" sz="1100" dirty="0" err="1">
+                <a:solidFill>
+                  <a:srgbClr val="F4A200"/>
+                </a:solidFill>
+                <a:latin typeface="Arial" panose="020B0604020202020204" pitchFamily="34" charset="0"/>
+                <a:ea typeface="Myriad Pro Light"/>
+                <a:cs typeface="Times New Roman" panose="02020603050405020304" pitchFamily="18" charset="0"/>
+              </a:rPr>
+              <a:t>ó</a:t>
+            </a:r>
+            <a:r>
+              <a:rPr kumimoji="0" lang="en-US" altLang="es-ES" sz="1100" b="0" i="0" u="none" strike="noStrike" cap="none" normalizeH="0" baseline="0" dirty="0" err="1">
+                <a:ln>
+                  <a:noFill/>
+                </a:ln>
+                <a:solidFill>
+                  <a:srgbClr val="F4A200"/>
+                </a:solidFill>
+                <a:effectLst/>
+                <a:latin typeface="Arial" panose="020B0604020202020204" pitchFamily="34" charset="0"/>
+                <a:ea typeface="Myriad Pro Light"/>
+                <a:cs typeface="Times New Roman" panose="02020603050405020304" pitchFamily="18" charset="0"/>
+              </a:rPr>
+              <a:t>noma</a:t>
+            </a:r>
+            <a:r>
+              <a:rPr kumimoji="0" lang="en-US" altLang="es-ES" sz="1100" b="0" i="0" u="none" strike="noStrike" cap="none" normalizeH="0" baseline="0" dirty="0">
+                <a:ln>
+                  <a:noFill/>
+                </a:ln>
+                <a:solidFill>
+                  <a:srgbClr val="F4A200"/>
+                </a:solidFill>
+                <a:effectLst/>
+                <a:latin typeface="Arial" panose="020B0604020202020204" pitchFamily="34" charset="0"/>
+                <a:ea typeface="Myriad Pro Light"/>
+                <a:cs typeface="Times New Roman" panose="02020603050405020304" pitchFamily="18" charset="0"/>
+              </a:rPr>
+              <a:t> de Madrid</a:t>
+            </a:r>
+            <a:endParaRPr kumimoji="0" lang="es-ES" altLang="es-ES" sz="300" b="0" i="0" u="none" strike="noStrike" cap="none" normalizeH="0" baseline="0" dirty="0">
+              <a:ln>
+                <a:noFill/>
+              </a:ln>
+              <a:solidFill>
+                <a:schemeClr val="tx1"/>
+              </a:solidFill>
+              <a:effectLst/>
+              <a:latin typeface="Arial" panose="020B0604020202020204" pitchFamily="34" charset="0"/>
+            </a:endParaRPr>
+          </a:p>
+        </p:txBody>
+      </p:sp>
+    </p:spTree>
+    <p:extLst>
+      <p:ext uri="{BB962C8B-B14F-4D97-AF65-F5344CB8AC3E}">
+        <p14:creationId xmlns:p14="http://schemas.microsoft.com/office/powerpoint/2010/main" val="1397500234"/>
+      </p:ext>
+    </p:extLst>
+  </p:cSld>
+  <p:clrMapOvr>
+    <a:masterClrMapping/>
+  </p:clrMapOvr>
+</p:sld>
+</file>
+
+<file path=ppt/slides/slide14.xml><?xml version="1.0" encoding="utf-8"?>
+<p:sld xmlns:a="http://schemas.openxmlformats.org/drawingml/2006/main" xmlns:r="http://schemas.openxmlformats.org/officeDocument/2006/relationships" xmlns:p="http://schemas.openxmlformats.org/presentationml/2006/main">
+  <p:cSld>
+    <p:spTree>
+      <p:nvGrpSpPr>
+        <p:cNvPr id="1" name=""/>
+        <p:cNvGrpSpPr/>
+        <p:nvPr/>
+      </p:nvGrpSpPr>
+      <p:grpSpPr>
+        <a:xfrm>
+          <a:off x="0" y="0"/>
+          <a:ext cx="0" cy="0"/>
+          <a:chOff x="0" y="0"/>
+          <a:chExt cx="0" cy="0"/>
+        </a:xfrm>
+      </p:grpSpPr>
+      <p:sp>
+        <p:nvSpPr>
+          <p:cNvPr id="2" name="Title 1">
+            <a:extLst>
+              <a:ext uri="{FF2B5EF4-FFF2-40B4-BE49-F238E27FC236}">
+                <a16:creationId xmlns:a16="http://schemas.microsoft.com/office/drawing/2014/main" id="{31C29F6F-54A2-5964-F2B2-982952460386}"/>
+              </a:ext>
+            </a:extLst>
+          </p:cNvPr>
+          <p:cNvSpPr>
+            <a:spLocks noGrp="1"/>
+          </p:cNvSpPr>
+          <p:nvPr>
+            <p:ph type="title"/>
+          </p:nvPr>
+        </p:nvSpPr>
+        <p:spPr/>
+        <p:txBody>
+          <a:bodyPr>
+            <a:normAutofit/>
+          </a:bodyPr>
+          <a:lstStyle/>
+          <a:p>
+            <a:r>
+              <a:rPr lang="en-US" sz="4000" dirty="0"/>
               <a:t>Decision Trees Vs Linear models</a:t>
             </a:r>
           </a:p>
@@ -24439,6 +25050,3139 @@
 </p:sld>
 </file>
 
+<file path=ppt/slides/slide15.xml><?xml version="1.0" encoding="utf-8"?>
+<p:sld xmlns:a="http://schemas.openxmlformats.org/drawingml/2006/main" xmlns:r="http://schemas.openxmlformats.org/officeDocument/2006/relationships" xmlns:p="http://schemas.openxmlformats.org/presentationml/2006/main">
+  <p:cSld>
+    <p:spTree>
+      <p:nvGrpSpPr>
+        <p:cNvPr id="1" name=""/>
+        <p:cNvGrpSpPr/>
+        <p:nvPr/>
+      </p:nvGrpSpPr>
+      <p:grpSpPr>
+        <a:xfrm>
+          <a:off x="0" y="0"/>
+          <a:ext cx="0" cy="0"/>
+          <a:chOff x="0" y="0"/>
+          <a:chExt cx="0" cy="0"/>
+        </a:xfrm>
+      </p:grpSpPr>
+      <p:sp>
+        <p:nvSpPr>
+          <p:cNvPr id="2" name="Title 1">
+            <a:extLst>
+              <a:ext uri="{FF2B5EF4-FFF2-40B4-BE49-F238E27FC236}">
+                <a16:creationId xmlns:a16="http://schemas.microsoft.com/office/drawing/2014/main" id="{31C29F6F-54A2-5964-F2B2-982952460386}"/>
+              </a:ext>
+            </a:extLst>
+          </p:cNvPr>
+          <p:cNvSpPr>
+            <a:spLocks noGrp="1"/>
+          </p:cNvSpPr>
+          <p:nvPr>
+            <p:ph type="title"/>
+          </p:nvPr>
+        </p:nvSpPr>
+        <p:spPr/>
+        <p:txBody>
+          <a:bodyPr>
+            <a:normAutofit/>
+          </a:bodyPr>
+          <a:lstStyle/>
+          <a:p>
+            <a:r>
+              <a:rPr lang="en-US" sz="4000" dirty="0"/>
+              <a:t>Ensemble methods – Voting classifiers</a:t>
+            </a:r>
+          </a:p>
+        </p:txBody>
+      </p:sp>
+      <p:sp>
+        <p:nvSpPr>
+          <p:cNvPr id="3" name="Content Placeholder 2">
+            <a:extLst>
+              <a:ext uri="{FF2B5EF4-FFF2-40B4-BE49-F238E27FC236}">
+                <a16:creationId xmlns:a16="http://schemas.microsoft.com/office/drawing/2014/main" id="{068F0C39-44FF-99B2-7103-C6D38F774B5B}"/>
+              </a:ext>
+            </a:extLst>
+          </p:cNvPr>
+          <p:cNvSpPr>
+            <a:spLocks noGrp="1"/>
+          </p:cNvSpPr>
+          <p:nvPr>
+            <p:ph idx="1"/>
+          </p:nvPr>
+        </p:nvSpPr>
+        <p:spPr>
+          <a:xfrm>
+            <a:off x="844778" y="1819047"/>
+            <a:ext cx="10515600" cy="4351338"/>
+          </a:xfrm>
+        </p:spPr>
+        <p:txBody>
+          <a:bodyPr>
+            <a:normAutofit/>
+          </a:bodyPr>
+          <a:lstStyle/>
+          <a:p>
+            <a:pPr>
+              <a:lnSpc>
+                <a:spcPct val="150000"/>
+              </a:lnSpc>
+              <a:buFont typeface="Wingdings" panose="05000000000000000000" pitchFamily="2" charset="2"/>
+              <a:buChar char="§"/>
+            </a:pPr>
+            <a:r>
+              <a:rPr lang="en-US" sz="2000" dirty="0">
+                <a:latin typeface="+mj-lt"/>
+              </a:rPr>
+              <a:t>Trees are simple and interpretable. But they cannot compete with other techniques in terms of prediction accuracy.</a:t>
+            </a:r>
+          </a:p>
+          <a:p>
+            <a:pPr>
+              <a:lnSpc>
+                <a:spcPct val="150000"/>
+              </a:lnSpc>
+              <a:buFont typeface="Wingdings" panose="05000000000000000000" pitchFamily="2" charset="2"/>
+              <a:buChar char="§"/>
+            </a:pPr>
+            <a:r>
+              <a:rPr lang="en-US" sz="2000" dirty="0">
+                <a:latin typeface="+mj-lt"/>
+              </a:rPr>
+              <a:t>But what if we could produce multiple trees and combine them to yield a single consensus prediction (based on ‘votes’)? This is called an </a:t>
+            </a:r>
+            <a:r>
+              <a:rPr lang="en-US" sz="2000" i="1" dirty="0">
+                <a:latin typeface="+mj-lt"/>
+              </a:rPr>
+              <a:t>Ensemble</a:t>
+            </a:r>
+          </a:p>
+          <a:p>
+            <a:pPr>
+              <a:lnSpc>
+                <a:spcPct val="150000"/>
+              </a:lnSpc>
+              <a:buFont typeface="Wingdings" panose="05000000000000000000" pitchFamily="2" charset="2"/>
+              <a:buChar char="§"/>
+            </a:pPr>
+            <a:r>
+              <a:rPr lang="en-US" sz="2000" dirty="0">
+                <a:latin typeface="+mj-lt"/>
+              </a:rPr>
+              <a:t>Combining a large number of trees often results in a dramatic improvement in prediction accuracy (at the expense of some interpretation)</a:t>
+            </a:r>
+            <a:endParaRPr lang="en-US" sz="1600" dirty="0">
+              <a:latin typeface="+mj-lt"/>
+            </a:endParaRPr>
+          </a:p>
+          <a:p>
+            <a:pPr lvl="1">
+              <a:lnSpc>
+                <a:spcPct val="150000"/>
+              </a:lnSpc>
+              <a:buFont typeface="Wingdings" panose="05000000000000000000" pitchFamily="2" charset="2"/>
+              <a:buChar char="§"/>
+            </a:pPr>
+            <a:endParaRPr lang="en-US" sz="1600" dirty="0">
+              <a:latin typeface="+mj-lt"/>
+            </a:endParaRPr>
+          </a:p>
+        </p:txBody>
+      </p:sp>
+      <p:sp>
+        <p:nvSpPr>
+          <p:cNvPr id="4" name="Rectángulo 3">
+            <a:extLst>
+              <a:ext uri="{FF2B5EF4-FFF2-40B4-BE49-F238E27FC236}">
+                <a16:creationId xmlns:a16="http://schemas.microsoft.com/office/drawing/2014/main" id="{7BF95E35-4D9C-7F59-F308-C61FF9CD1B58}"/>
+              </a:ext>
+            </a:extLst>
+          </p:cNvPr>
+          <p:cNvSpPr/>
+          <p:nvPr/>
+        </p:nvSpPr>
+        <p:spPr>
+          <a:xfrm>
+            <a:off x="0" y="0"/>
+            <a:ext cx="374469" cy="6858000"/>
+          </a:xfrm>
+          <a:prstGeom prst="rect">
+            <a:avLst/>
+          </a:prstGeom>
+        </p:spPr>
+        <p:style>
+          <a:lnRef idx="2">
+            <a:schemeClr val="accent2">
+              <a:shade val="50000"/>
+            </a:schemeClr>
+          </a:lnRef>
+          <a:fillRef idx="1">
+            <a:schemeClr val="accent2"/>
+          </a:fillRef>
+          <a:effectRef idx="0">
+            <a:schemeClr val="accent2"/>
+          </a:effectRef>
+          <a:fontRef idx="minor">
+            <a:schemeClr val="lt1"/>
+          </a:fontRef>
+        </p:style>
+        <p:txBody>
+          <a:bodyPr rtlCol="0" anchor="ctr"/>
+          <a:lstStyle/>
+          <a:p>
+            <a:pPr algn="ctr"/>
+            <a:endParaRPr lang="es-ES"/>
+          </a:p>
+        </p:txBody>
+      </p:sp>
+      <p:sp>
+        <p:nvSpPr>
+          <p:cNvPr id="6" name="Rectangle 143">
+            <a:extLst>
+              <a:ext uri="{FF2B5EF4-FFF2-40B4-BE49-F238E27FC236}">
+                <a16:creationId xmlns:a16="http://schemas.microsoft.com/office/drawing/2014/main" id="{C9A975F5-C7DC-9274-20CA-B5939A2A86BD}"/>
+              </a:ext>
+            </a:extLst>
+          </p:cNvPr>
+          <p:cNvSpPr>
+            <a:spLocks noChangeArrowheads="1"/>
+          </p:cNvSpPr>
+          <p:nvPr/>
+        </p:nvSpPr>
+        <p:spPr bwMode="auto">
+          <a:xfrm>
+            <a:off x="448342" y="6549317"/>
+            <a:ext cx="5730175" cy="261610"/>
+          </a:xfrm>
+          <a:prstGeom prst="rect">
+            <a:avLst/>
+          </a:prstGeom>
+          <a:noFill/>
+          <a:ln>
+            <a:noFill/>
+          </a:ln>
+          <a:effectLst/>
+          <a:extLst>
+            <a:ext uri="{909E8E84-426E-40DD-AFC4-6F175D3DCCD1}">
+              <a14:hiddenFill xmlns:a14="http://schemas.microsoft.com/office/drawing/2010/main">
+                <a:solidFill>
+                  <a:schemeClr val="accent1"/>
+                </a:solidFill>
+              </a14:hiddenFill>
+            </a:ext>
+            <a:ext uri="{91240B29-F687-4F45-9708-019B960494DF}">
+              <a14:hiddenLine xmlns:a14="http://schemas.microsoft.com/office/drawing/2010/main" w="9525">
+                <a:solidFill>
+                  <a:schemeClr val="tx1"/>
+                </a:solidFill>
+                <a:miter lim="800000"/>
+                <a:headEnd/>
+                <a:tailEnd/>
+              </a14:hiddenLine>
+            </a:ext>
+            <a:ext uri="{AF507438-7753-43E0-B8FC-AC1667EBCBE1}">
+              <a14:hiddenEffects xmlns:a14="http://schemas.microsoft.com/office/drawing/2010/main">
+                <a:effectLst>
+                  <a:outerShdw dist="35921" dir="2700000" algn="ctr" rotWithShape="0">
+                    <a:schemeClr val="bg2"/>
+                  </a:outerShdw>
+                </a:effectLst>
+              </a14:hiddenEffects>
+            </a:ext>
+          </a:extLst>
+        </p:spPr>
+        <p:txBody>
+          <a:bodyPr vert="horz" wrap="square" lIns="91440" tIns="45720" rIns="91440" bIns="45720" numCol="1" anchor="ctr" anchorCtr="0" compatLnSpc="1">
+            <a:prstTxWarp prst="textNoShape">
+              <a:avLst/>
+            </a:prstTxWarp>
+            <a:spAutoFit/>
+          </a:bodyPr>
+          <a:lstStyle/>
+          <a:p>
+            <a:pPr marL="0" marR="0" lvl="0" indent="0" algn="l" defTabSz="914400" rtl="0" eaLnBrk="0" fontAlgn="base" latinLnBrk="0" hangingPunct="0">
+              <a:lnSpc>
+                <a:spcPct val="100000"/>
+              </a:lnSpc>
+              <a:spcBef>
+                <a:spcPct val="0"/>
+              </a:spcBef>
+              <a:spcAft>
+                <a:spcPct val="0"/>
+              </a:spcAft>
+              <a:buClrTx/>
+              <a:buSzTx/>
+              <a:buFontTx/>
+              <a:buNone/>
+              <a:tabLst/>
+            </a:pPr>
+            <a:r>
+              <a:rPr kumimoji="0" lang="en-US" altLang="es-ES" sz="1100" b="0" i="0" u="none" strike="noStrike" cap="none" normalizeH="0" baseline="0" dirty="0">
+                <a:ln>
+                  <a:noFill/>
+                </a:ln>
+                <a:solidFill>
+                  <a:srgbClr val="F4A200"/>
+                </a:solidFill>
+                <a:effectLst/>
+                <a:latin typeface="Arial" panose="020B0604020202020204" pitchFamily="34" charset="0"/>
+                <a:ea typeface="Myriad Pro Light"/>
+                <a:cs typeface="Times New Roman" panose="02020603050405020304" pitchFamily="18" charset="0"/>
+              </a:rPr>
+              <a:t>Master in Quantitative Economic Analysis </a:t>
+            </a:r>
+            <a:r>
+              <a:rPr kumimoji="0" lang="en-US" altLang="es-ES" sz="1100" b="0" i="0" u="none" strike="noStrike" cap="none" normalizeH="0" baseline="0" dirty="0" err="1">
+                <a:ln>
+                  <a:noFill/>
+                </a:ln>
+                <a:solidFill>
+                  <a:srgbClr val="F4A200"/>
+                </a:solidFill>
+                <a:effectLst/>
+                <a:latin typeface="Arial" panose="020B0604020202020204" pitchFamily="34" charset="0"/>
+                <a:ea typeface="Myriad Pro Light"/>
+                <a:cs typeface="Times New Roman" panose="02020603050405020304" pitchFamily="18" charset="0"/>
+              </a:rPr>
+              <a:t>MQuEA</a:t>
+            </a:r>
+            <a:endParaRPr kumimoji="0" lang="es-ES" altLang="es-ES" sz="300" b="0" i="0" u="none" strike="noStrike" cap="none" normalizeH="0" baseline="0" dirty="0">
+              <a:ln>
+                <a:noFill/>
+              </a:ln>
+              <a:solidFill>
+                <a:schemeClr val="tx1"/>
+              </a:solidFill>
+              <a:effectLst/>
+              <a:latin typeface="Arial" panose="020B0604020202020204" pitchFamily="34" charset="0"/>
+            </a:endParaRPr>
+          </a:p>
+        </p:txBody>
+      </p:sp>
+      <p:sp>
+        <p:nvSpPr>
+          <p:cNvPr id="7" name="Rectangle 143">
+            <a:extLst>
+              <a:ext uri="{FF2B5EF4-FFF2-40B4-BE49-F238E27FC236}">
+                <a16:creationId xmlns:a16="http://schemas.microsoft.com/office/drawing/2014/main" id="{2BE2E3EB-749E-E562-030D-C3F46E714169}"/>
+              </a:ext>
+            </a:extLst>
+          </p:cNvPr>
+          <p:cNvSpPr>
+            <a:spLocks noChangeArrowheads="1"/>
+          </p:cNvSpPr>
+          <p:nvPr/>
+        </p:nvSpPr>
+        <p:spPr bwMode="auto">
+          <a:xfrm>
+            <a:off x="6186394" y="6559955"/>
+            <a:ext cx="5730175" cy="261610"/>
+          </a:xfrm>
+          <a:prstGeom prst="rect">
+            <a:avLst/>
+          </a:prstGeom>
+          <a:noFill/>
+          <a:ln>
+            <a:noFill/>
+          </a:ln>
+          <a:effectLst/>
+          <a:extLst>
+            <a:ext uri="{909E8E84-426E-40DD-AFC4-6F175D3DCCD1}">
+              <a14:hiddenFill xmlns:a14="http://schemas.microsoft.com/office/drawing/2010/main">
+                <a:solidFill>
+                  <a:schemeClr val="accent1"/>
+                </a:solidFill>
+              </a14:hiddenFill>
+            </a:ext>
+            <a:ext uri="{91240B29-F687-4F45-9708-019B960494DF}">
+              <a14:hiddenLine xmlns:a14="http://schemas.microsoft.com/office/drawing/2010/main" w="9525">
+                <a:solidFill>
+                  <a:schemeClr val="tx1"/>
+                </a:solidFill>
+                <a:miter lim="800000"/>
+                <a:headEnd/>
+                <a:tailEnd/>
+              </a14:hiddenLine>
+            </a:ext>
+            <a:ext uri="{AF507438-7753-43E0-B8FC-AC1667EBCBE1}">
+              <a14:hiddenEffects xmlns:a14="http://schemas.microsoft.com/office/drawing/2010/main">
+                <a:effectLst>
+                  <a:outerShdw dist="35921" dir="2700000" algn="ctr" rotWithShape="0">
+                    <a:schemeClr val="bg2"/>
+                  </a:outerShdw>
+                </a:effectLst>
+              </a14:hiddenEffects>
+            </a:ext>
+          </a:extLst>
+        </p:spPr>
+        <p:txBody>
+          <a:bodyPr vert="horz" wrap="square" lIns="91440" tIns="45720" rIns="91440" bIns="45720" numCol="1" anchor="ctr" anchorCtr="0" compatLnSpc="1">
+            <a:prstTxWarp prst="textNoShape">
+              <a:avLst/>
+            </a:prstTxWarp>
+            <a:spAutoFit/>
+          </a:bodyPr>
+          <a:lstStyle/>
+          <a:p>
+            <a:pPr marL="0" marR="0" lvl="0" indent="0" algn="r" defTabSz="914400" rtl="0" eaLnBrk="0" fontAlgn="base" latinLnBrk="0" hangingPunct="0">
+              <a:lnSpc>
+                <a:spcPct val="100000"/>
+              </a:lnSpc>
+              <a:spcBef>
+                <a:spcPct val="0"/>
+              </a:spcBef>
+              <a:spcAft>
+                <a:spcPct val="0"/>
+              </a:spcAft>
+              <a:buClrTx/>
+              <a:buSzTx/>
+              <a:buFontTx/>
+              <a:buNone/>
+              <a:tabLst/>
+            </a:pPr>
+            <a:r>
+              <a:rPr kumimoji="0" lang="en-US" altLang="es-ES" sz="1100" b="0" i="0" u="none" strike="noStrike" cap="none" normalizeH="0" baseline="0" dirty="0">
+                <a:ln>
+                  <a:noFill/>
+                </a:ln>
+                <a:solidFill>
+                  <a:srgbClr val="F4A200"/>
+                </a:solidFill>
+                <a:effectLst/>
+                <a:latin typeface="Arial" panose="020B0604020202020204" pitchFamily="34" charset="0"/>
+                <a:ea typeface="Myriad Pro Light"/>
+                <a:cs typeface="Times New Roman" panose="02020603050405020304" pitchFamily="18" charset="0"/>
+              </a:rPr>
+              <a:t>Universidad </a:t>
+            </a:r>
+            <a:r>
+              <a:rPr kumimoji="0" lang="en-US" altLang="es-ES" sz="1100" b="0" i="0" u="none" strike="noStrike" cap="none" normalizeH="0" baseline="0" dirty="0" err="1">
+                <a:ln>
+                  <a:noFill/>
+                </a:ln>
+                <a:solidFill>
+                  <a:srgbClr val="F4A200"/>
+                </a:solidFill>
+                <a:effectLst/>
+                <a:latin typeface="Arial" panose="020B0604020202020204" pitchFamily="34" charset="0"/>
+                <a:ea typeface="Myriad Pro Light"/>
+                <a:cs typeface="Times New Roman" panose="02020603050405020304" pitchFamily="18" charset="0"/>
+              </a:rPr>
+              <a:t>Aut</a:t>
+            </a:r>
+            <a:r>
+              <a:rPr lang="en-US" altLang="es-ES" sz="1100" dirty="0" err="1">
+                <a:solidFill>
+                  <a:srgbClr val="F4A200"/>
+                </a:solidFill>
+                <a:latin typeface="Arial" panose="020B0604020202020204" pitchFamily="34" charset="0"/>
+                <a:ea typeface="Myriad Pro Light"/>
+                <a:cs typeface="Times New Roman" panose="02020603050405020304" pitchFamily="18" charset="0"/>
+              </a:rPr>
+              <a:t>ó</a:t>
+            </a:r>
+            <a:r>
+              <a:rPr kumimoji="0" lang="en-US" altLang="es-ES" sz="1100" b="0" i="0" u="none" strike="noStrike" cap="none" normalizeH="0" baseline="0" dirty="0" err="1">
+                <a:ln>
+                  <a:noFill/>
+                </a:ln>
+                <a:solidFill>
+                  <a:srgbClr val="F4A200"/>
+                </a:solidFill>
+                <a:effectLst/>
+                <a:latin typeface="Arial" panose="020B0604020202020204" pitchFamily="34" charset="0"/>
+                <a:ea typeface="Myriad Pro Light"/>
+                <a:cs typeface="Times New Roman" panose="02020603050405020304" pitchFamily="18" charset="0"/>
+              </a:rPr>
+              <a:t>noma</a:t>
+            </a:r>
+            <a:r>
+              <a:rPr kumimoji="0" lang="en-US" altLang="es-ES" sz="1100" b="0" i="0" u="none" strike="noStrike" cap="none" normalizeH="0" baseline="0" dirty="0">
+                <a:ln>
+                  <a:noFill/>
+                </a:ln>
+                <a:solidFill>
+                  <a:srgbClr val="F4A200"/>
+                </a:solidFill>
+                <a:effectLst/>
+                <a:latin typeface="Arial" panose="020B0604020202020204" pitchFamily="34" charset="0"/>
+                <a:ea typeface="Myriad Pro Light"/>
+                <a:cs typeface="Times New Roman" panose="02020603050405020304" pitchFamily="18" charset="0"/>
+              </a:rPr>
+              <a:t> de Madrid</a:t>
+            </a:r>
+            <a:endParaRPr kumimoji="0" lang="es-ES" altLang="es-ES" sz="300" b="0" i="0" u="none" strike="noStrike" cap="none" normalizeH="0" baseline="0" dirty="0">
+              <a:ln>
+                <a:noFill/>
+              </a:ln>
+              <a:solidFill>
+                <a:schemeClr val="tx1"/>
+              </a:solidFill>
+              <a:effectLst/>
+              <a:latin typeface="Arial" panose="020B0604020202020204" pitchFamily="34" charset="0"/>
+            </a:endParaRPr>
+          </a:p>
+        </p:txBody>
+      </p:sp>
+    </p:spTree>
+    <p:extLst>
+      <p:ext uri="{BB962C8B-B14F-4D97-AF65-F5344CB8AC3E}">
+        <p14:creationId xmlns:p14="http://schemas.microsoft.com/office/powerpoint/2010/main" val="1472489950"/>
+      </p:ext>
+    </p:extLst>
+  </p:cSld>
+  <p:clrMapOvr>
+    <a:masterClrMapping/>
+  </p:clrMapOvr>
+</p:sld>
+</file>
+
+<file path=ppt/slides/slide16.xml><?xml version="1.0" encoding="utf-8"?>
+<p:sld xmlns:a="http://schemas.openxmlformats.org/drawingml/2006/main" xmlns:r="http://schemas.openxmlformats.org/officeDocument/2006/relationships" xmlns:p="http://schemas.openxmlformats.org/presentationml/2006/main">
+  <p:cSld>
+    <p:spTree>
+      <p:nvGrpSpPr>
+        <p:cNvPr id="1" name=""/>
+        <p:cNvGrpSpPr/>
+        <p:nvPr/>
+      </p:nvGrpSpPr>
+      <p:grpSpPr>
+        <a:xfrm>
+          <a:off x="0" y="0"/>
+          <a:ext cx="0" cy="0"/>
+          <a:chOff x="0" y="0"/>
+          <a:chExt cx="0" cy="0"/>
+        </a:xfrm>
+      </p:grpSpPr>
+      <p:sp>
+        <p:nvSpPr>
+          <p:cNvPr id="2" name="Title 1">
+            <a:extLst>
+              <a:ext uri="{FF2B5EF4-FFF2-40B4-BE49-F238E27FC236}">
+                <a16:creationId xmlns:a16="http://schemas.microsoft.com/office/drawing/2014/main" id="{31C29F6F-54A2-5964-F2B2-982952460386}"/>
+              </a:ext>
+            </a:extLst>
+          </p:cNvPr>
+          <p:cNvSpPr>
+            <a:spLocks noGrp="1"/>
+          </p:cNvSpPr>
+          <p:nvPr>
+            <p:ph type="title"/>
+          </p:nvPr>
+        </p:nvSpPr>
+        <p:spPr/>
+        <p:txBody>
+          <a:bodyPr>
+            <a:normAutofit/>
+          </a:bodyPr>
+          <a:lstStyle/>
+          <a:p>
+            <a:r>
+              <a:rPr lang="en-US" sz="4000" dirty="0"/>
+              <a:t>Ensemble methods – Bagging</a:t>
+            </a:r>
+          </a:p>
+        </p:txBody>
+      </p:sp>
+      <mc:AlternateContent xmlns:mc="http://schemas.openxmlformats.org/markup-compatibility/2006">
+        <mc:Choice xmlns:a14="http://schemas.microsoft.com/office/drawing/2010/main" Requires="a14">
+          <p:sp>
+            <p:nvSpPr>
+              <p:cNvPr id="3" name="Content Placeholder 2">
+                <a:extLst>
+                  <a:ext uri="{FF2B5EF4-FFF2-40B4-BE49-F238E27FC236}">
+                    <a16:creationId xmlns:a16="http://schemas.microsoft.com/office/drawing/2014/main" id="{068F0C39-44FF-99B2-7103-C6D38F774B5B}"/>
+                  </a:ext>
+                </a:extLst>
+              </p:cNvPr>
+              <p:cNvSpPr>
+                <a:spLocks noGrp="1"/>
+              </p:cNvSpPr>
+              <p:nvPr>
+                <p:ph idx="1"/>
+              </p:nvPr>
+            </p:nvSpPr>
+            <p:spPr>
+              <a:xfrm>
+                <a:off x="844778" y="1819047"/>
+                <a:ext cx="10515600" cy="4351338"/>
+              </a:xfrm>
+            </p:spPr>
+            <p:txBody>
+              <a:bodyPr>
+                <a:normAutofit/>
+              </a:bodyPr>
+              <a:lstStyle/>
+              <a:p>
+                <a:pPr>
+                  <a:lnSpc>
+                    <a:spcPct val="150000"/>
+                  </a:lnSpc>
+                  <a:buFont typeface="Wingdings" panose="05000000000000000000" pitchFamily="2" charset="2"/>
+                  <a:buChar char="§"/>
+                </a:pPr>
+                <a:r>
+                  <a:rPr lang="en-US" sz="2000" dirty="0">
+                    <a:latin typeface="+mj-lt"/>
+                  </a:rPr>
+                  <a:t>Decision trees suffer from high variance. </a:t>
+                </a:r>
+                <a:r>
+                  <a:rPr lang="en-US" sz="2000" i="1" dirty="0">
+                    <a:latin typeface="+mj-lt"/>
+                  </a:rPr>
+                  <a:t>Bootstrap aggregation</a:t>
+                </a:r>
+                <a:r>
+                  <a:rPr lang="en-US" sz="2000" dirty="0">
+                    <a:latin typeface="+mj-lt"/>
+                  </a:rPr>
+                  <a:t> or </a:t>
+                </a:r>
+                <a:r>
+                  <a:rPr lang="en-US" sz="2000" i="1" dirty="0">
+                    <a:latin typeface="+mj-lt"/>
+                  </a:rPr>
+                  <a:t>bagging</a:t>
+                </a:r>
+                <a:r>
+                  <a:rPr lang="en-US" sz="2000" dirty="0">
+                    <a:latin typeface="+mj-lt"/>
+                  </a:rPr>
+                  <a:t>, reduces the variance of a statistical learning method.</a:t>
+                </a:r>
+              </a:p>
+              <a:p>
+                <a:pPr>
+                  <a:lnSpc>
+                    <a:spcPct val="150000"/>
+                  </a:lnSpc>
+                  <a:buFont typeface="Wingdings" panose="05000000000000000000" pitchFamily="2" charset="2"/>
+                  <a:buChar char="§"/>
+                </a:pPr>
+                <a:r>
+                  <a:rPr lang="en-US" sz="2000" dirty="0">
+                    <a:latin typeface="+mj-lt"/>
+                  </a:rPr>
+                  <a:t>Given a set of </a:t>
+                </a:r>
+                <a:r>
+                  <a:rPr lang="en-US" sz="2000" i="1" dirty="0">
+                    <a:latin typeface="+mj-lt"/>
+                  </a:rPr>
+                  <a:t>n</a:t>
+                </a:r>
+                <a:r>
+                  <a:rPr lang="en-US" sz="2000" dirty="0">
+                    <a:latin typeface="+mj-lt"/>
+                  </a:rPr>
+                  <a:t> independent </a:t>
+                </a:r>
+                <a:r>
+                  <a:rPr lang="en-US" sz="2000" dirty="0" err="1">
+                    <a:latin typeface="+mj-lt"/>
+                  </a:rPr>
+                  <a:t>observatios</a:t>
+                </a:r>
+                <a:r>
+                  <a:rPr lang="en-US" sz="2000" dirty="0">
+                    <a:latin typeface="+mj-lt"/>
+                  </a:rPr>
+                  <a:t> </a:t>
+                </a:r>
+                <a14:m>
+                  <m:oMath xmlns:m="http://schemas.openxmlformats.org/officeDocument/2006/math">
+                    <m:sSub>
+                      <m:sSubPr>
+                        <m:ctrlPr>
+                          <a:rPr lang="en-US" sz="2000" i="1" smtClean="0">
+                            <a:latin typeface="Cambria Math" panose="02040503050406030204" pitchFamily="18" charset="0"/>
+                          </a:rPr>
+                        </m:ctrlPr>
+                      </m:sSubPr>
+                      <m:e>
+                        <m:r>
+                          <a:rPr lang="en-US" sz="2000" b="0" i="1" smtClean="0">
+                            <a:latin typeface="Cambria Math" panose="02040503050406030204" pitchFamily="18" charset="0"/>
+                          </a:rPr>
+                          <m:t>𝑍</m:t>
+                        </m:r>
+                      </m:e>
+                      <m:sub>
+                        <m:r>
+                          <a:rPr lang="en-US" sz="2000" b="0" i="1" smtClean="0">
+                            <a:latin typeface="Cambria Math" panose="02040503050406030204" pitchFamily="18" charset="0"/>
+                          </a:rPr>
+                          <m:t>1</m:t>
+                        </m:r>
+                      </m:sub>
+                    </m:sSub>
+                    <m:r>
+                      <a:rPr lang="en-US" sz="2000" b="0" i="1" smtClean="0">
+                        <a:latin typeface="Cambria Math" panose="02040503050406030204" pitchFamily="18" charset="0"/>
+                      </a:rPr>
+                      <m:t>,</m:t>
+                    </m:r>
+                    <m:sSub>
+                      <m:sSubPr>
+                        <m:ctrlPr>
+                          <a:rPr lang="en-US" sz="2000" i="1">
+                            <a:latin typeface="Cambria Math" panose="02040503050406030204" pitchFamily="18" charset="0"/>
+                          </a:rPr>
+                        </m:ctrlPr>
+                      </m:sSubPr>
+                      <m:e>
+                        <m:r>
+                          <a:rPr lang="en-US" sz="2000" i="1">
+                            <a:latin typeface="Cambria Math" panose="02040503050406030204" pitchFamily="18" charset="0"/>
+                          </a:rPr>
+                          <m:t>𝑍</m:t>
+                        </m:r>
+                      </m:e>
+                      <m:sub>
+                        <m:r>
+                          <a:rPr lang="en-US" sz="2000" b="0" i="1" smtClean="0">
+                            <a:latin typeface="Cambria Math" panose="02040503050406030204" pitchFamily="18" charset="0"/>
+                          </a:rPr>
+                          <m:t>2</m:t>
+                        </m:r>
+                      </m:sub>
+                    </m:sSub>
+                  </m:oMath>
+                </a14:m>
+                <a:r>
+                  <a:rPr lang="en-US" sz="2000" dirty="0">
+                    <a:latin typeface="+mj-lt"/>
+                  </a:rPr>
+                  <a:t>,…,</a:t>
+                </a:r>
+                <a:r>
+                  <a:rPr lang="en-US" sz="2000" dirty="0"/>
+                  <a:t> </a:t>
+                </a:r>
+                <a14:m>
+                  <m:oMath xmlns:m="http://schemas.openxmlformats.org/officeDocument/2006/math">
+                    <m:sSub>
+                      <m:sSubPr>
+                        <m:ctrlPr>
+                          <a:rPr lang="en-US" sz="2000" i="1">
+                            <a:latin typeface="Cambria Math" panose="02040503050406030204" pitchFamily="18" charset="0"/>
+                          </a:rPr>
+                        </m:ctrlPr>
+                      </m:sSubPr>
+                      <m:e>
+                        <m:r>
+                          <a:rPr lang="en-US" sz="2000" i="1">
+                            <a:latin typeface="Cambria Math" panose="02040503050406030204" pitchFamily="18" charset="0"/>
+                          </a:rPr>
+                          <m:t>𝑍</m:t>
+                        </m:r>
+                      </m:e>
+                      <m:sub>
+                        <m:r>
+                          <a:rPr lang="en-US" sz="2000" b="0" i="1" smtClean="0">
+                            <a:latin typeface="Cambria Math" panose="02040503050406030204" pitchFamily="18" charset="0"/>
+                          </a:rPr>
+                          <m:t>𝑛</m:t>
+                        </m:r>
+                      </m:sub>
+                    </m:sSub>
+                  </m:oMath>
+                </a14:m>
+                <a:r>
+                  <a:rPr lang="en-US" sz="2000" dirty="0">
+                    <a:latin typeface="+mj-lt"/>
+                  </a:rPr>
+                  <a:t>, each with variance </a:t>
+                </a:r>
+                <a14:m>
+                  <m:oMath xmlns:m="http://schemas.openxmlformats.org/officeDocument/2006/math">
+                    <m:sSub>
+                      <m:sSubPr>
+                        <m:ctrlPr>
+                          <a:rPr lang="en-US" sz="2000" i="1">
+                            <a:latin typeface="Cambria Math" panose="02040503050406030204" pitchFamily="18" charset="0"/>
+                          </a:rPr>
+                        </m:ctrlPr>
+                      </m:sSubPr>
+                      <m:e>
+                        <m:r>
+                          <a:rPr lang="en-US" sz="2000" i="1" smtClean="0">
+                            <a:latin typeface="Cambria Math" panose="02040503050406030204" pitchFamily="18" charset="0"/>
+                            <a:ea typeface="Cambria Math" panose="02040503050406030204" pitchFamily="18" charset="0"/>
+                          </a:rPr>
+                          <m:t>𝜎</m:t>
+                        </m:r>
+                      </m:e>
+                      <m:sub>
+                        <m:r>
+                          <a:rPr lang="en-US" sz="2000" b="0" i="1" smtClean="0">
+                            <a:latin typeface="Cambria Math" panose="02040503050406030204" pitchFamily="18" charset="0"/>
+                          </a:rPr>
+                          <m:t>𝑛</m:t>
+                        </m:r>
+                      </m:sub>
+                    </m:sSub>
+                  </m:oMath>
+                </a14:m>
+                <a:r>
+                  <a:rPr lang="en-US" sz="2000" dirty="0">
+                    <a:latin typeface="+mj-lt"/>
+                  </a:rPr>
+                  <a:t>, the variance of the mean </a:t>
+                </a:r>
+                <a14:m>
+                  <m:oMath xmlns:m="http://schemas.openxmlformats.org/officeDocument/2006/math">
+                    <m:acc>
+                      <m:accPr>
+                        <m:chr m:val="̅"/>
+                        <m:ctrlPr>
+                          <a:rPr lang="en-US" sz="2000" i="1" smtClean="0">
+                            <a:latin typeface="Cambria Math" panose="02040503050406030204" pitchFamily="18" charset="0"/>
+                          </a:rPr>
+                        </m:ctrlPr>
+                      </m:accPr>
+                      <m:e>
+                        <m:r>
+                          <a:rPr lang="en-US" sz="2000" b="0" i="1" smtClean="0">
+                            <a:latin typeface="Cambria Math" panose="02040503050406030204" pitchFamily="18" charset="0"/>
+                          </a:rPr>
+                          <m:t>𝑍</m:t>
+                        </m:r>
+                      </m:e>
+                    </m:acc>
+                  </m:oMath>
+                </a14:m>
+                <a:r>
+                  <a:rPr lang="en-US" sz="2000" dirty="0">
+                    <a:latin typeface="+mj-lt"/>
+                  </a:rPr>
+                  <a:t> of the observations is given by </a:t>
+                </a:r>
+                <a14:m>
+                  <m:oMath xmlns:m="http://schemas.openxmlformats.org/officeDocument/2006/math">
+                    <m:f>
+                      <m:fPr>
+                        <m:type m:val="skw"/>
+                        <m:ctrlPr>
+                          <a:rPr lang="en-US" sz="2000" i="1" smtClean="0">
+                            <a:latin typeface="Cambria Math" panose="02040503050406030204" pitchFamily="18" charset="0"/>
+                          </a:rPr>
+                        </m:ctrlPr>
+                      </m:fPr>
+                      <m:num>
+                        <m:sSub>
+                          <m:sSubPr>
+                            <m:ctrlPr>
+                              <a:rPr lang="en-US" sz="2000" i="1">
+                                <a:latin typeface="Cambria Math" panose="02040503050406030204" pitchFamily="18" charset="0"/>
+                              </a:rPr>
+                            </m:ctrlPr>
+                          </m:sSubPr>
+                          <m:e>
+                            <m:r>
+                              <a:rPr lang="en-US" sz="2000" i="1">
+                                <a:latin typeface="Cambria Math" panose="02040503050406030204" pitchFamily="18" charset="0"/>
+                                <a:ea typeface="Cambria Math" panose="02040503050406030204" pitchFamily="18" charset="0"/>
+                              </a:rPr>
+                              <m:t>𝜎</m:t>
+                            </m:r>
+                          </m:e>
+                          <m:sub>
+                            <m:r>
+                              <a:rPr lang="en-US" sz="2000" i="1">
+                                <a:latin typeface="Cambria Math" panose="02040503050406030204" pitchFamily="18" charset="0"/>
+                              </a:rPr>
+                              <m:t>𝑛</m:t>
+                            </m:r>
+                          </m:sub>
+                        </m:sSub>
+                      </m:num>
+                      <m:den>
+                        <m:r>
+                          <a:rPr lang="en-US" sz="2000" b="0" i="1" smtClean="0">
+                            <a:latin typeface="Cambria Math" panose="02040503050406030204" pitchFamily="18" charset="0"/>
+                          </a:rPr>
+                          <m:t>𝑛</m:t>
+                        </m:r>
+                      </m:den>
+                    </m:f>
+                  </m:oMath>
+                </a14:m>
+                <a:r>
+                  <a:rPr lang="en-US" sz="2000" dirty="0">
+                    <a:latin typeface="+mj-lt"/>
+                  </a:rPr>
+                  <a:t>. In other words, averaging a set of observations reduces variance. </a:t>
+                </a:r>
+              </a:p>
+              <a:p>
+                <a:pPr>
+                  <a:lnSpc>
+                    <a:spcPct val="150000"/>
+                  </a:lnSpc>
+                  <a:buFont typeface="Wingdings" panose="05000000000000000000" pitchFamily="2" charset="2"/>
+                  <a:buChar char="§"/>
+                </a:pPr>
+                <a:r>
+                  <a:rPr lang="en-US" sz="2000" dirty="0">
+                    <a:latin typeface="+mj-lt"/>
+                  </a:rPr>
+                  <a:t>Therefore, a way to reduce the variance (and, hence, increase prediction accuracy) is to take many training sets from the population, build a separate prediction model using each training set, and average the resulting predictions.</a:t>
+                </a:r>
+              </a:p>
+            </p:txBody>
+          </p:sp>
+        </mc:Choice>
+        <mc:Fallback>
+          <p:sp>
+            <p:nvSpPr>
+              <p:cNvPr id="3" name="Content Placeholder 2">
+                <a:extLst>
+                  <a:ext uri="{FF2B5EF4-FFF2-40B4-BE49-F238E27FC236}">
+                    <a16:creationId xmlns:a16="http://schemas.microsoft.com/office/drawing/2014/main" id="{068F0C39-44FF-99B2-7103-C6D38F774B5B}"/>
+                  </a:ext>
+                </a:extLst>
+              </p:cNvPr>
+              <p:cNvSpPr>
+                <a:spLocks noGrp="1" noRot="1" noChangeAspect="1" noMove="1" noResize="1" noEditPoints="1" noAdjustHandles="1" noChangeArrowheads="1" noChangeShapeType="1" noTextEdit="1"/>
+              </p:cNvSpPr>
+              <p:nvPr>
+                <p:ph idx="1"/>
+              </p:nvPr>
+            </p:nvSpPr>
+            <p:spPr>
+              <a:xfrm>
+                <a:off x="844778" y="1819047"/>
+                <a:ext cx="10515600" cy="4351338"/>
+              </a:xfrm>
+              <a:blipFill>
+                <a:blip r:embed="rId2"/>
+                <a:stretch>
+                  <a:fillRect l="-522"/>
+                </a:stretch>
+              </a:blipFill>
+            </p:spPr>
+            <p:txBody>
+              <a:bodyPr/>
+              <a:lstStyle/>
+              <a:p>
+                <a:r>
+                  <a:rPr lang="en-US">
+                    <a:noFill/>
+                  </a:rPr>
+                  <a:t> </a:t>
+                </a:r>
+              </a:p>
+            </p:txBody>
+          </p:sp>
+        </mc:Fallback>
+      </mc:AlternateContent>
+      <p:sp>
+        <p:nvSpPr>
+          <p:cNvPr id="4" name="Rectángulo 3">
+            <a:extLst>
+              <a:ext uri="{FF2B5EF4-FFF2-40B4-BE49-F238E27FC236}">
+                <a16:creationId xmlns:a16="http://schemas.microsoft.com/office/drawing/2014/main" id="{7BF95E35-4D9C-7F59-F308-C61FF9CD1B58}"/>
+              </a:ext>
+            </a:extLst>
+          </p:cNvPr>
+          <p:cNvSpPr/>
+          <p:nvPr/>
+        </p:nvSpPr>
+        <p:spPr>
+          <a:xfrm>
+            <a:off x="0" y="0"/>
+            <a:ext cx="374469" cy="6858000"/>
+          </a:xfrm>
+          <a:prstGeom prst="rect">
+            <a:avLst/>
+          </a:prstGeom>
+        </p:spPr>
+        <p:style>
+          <a:lnRef idx="2">
+            <a:schemeClr val="accent2">
+              <a:shade val="50000"/>
+            </a:schemeClr>
+          </a:lnRef>
+          <a:fillRef idx="1">
+            <a:schemeClr val="accent2"/>
+          </a:fillRef>
+          <a:effectRef idx="0">
+            <a:schemeClr val="accent2"/>
+          </a:effectRef>
+          <a:fontRef idx="minor">
+            <a:schemeClr val="lt1"/>
+          </a:fontRef>
+        </p:style>
+        <p:txBody>
+          <a:bodyPr rtlCol="0" anchor="ctr"/>
+          <a:lstStyle/>
+          <a:p>
+            <a:pPr algn="ctr"/>
+            <a:endParaRPr lang="es-ES"/>
+          </a:p>
+        </p:txBody>
+      </p:sp>
+      <p:sp>
+        <p:nvSpPr>
+          <p:cNvPr id="6" name="Rectangle 143">
+            <a:extLst>
+              <a:ext uri="{FF2B5EF4-FFF2-40B4-BE49-F238E27FC236}">
+                <a16:creationId xmlns:a16="http://schemas.microsoft.com/office/drawing/2014/main" id="{C9A975F5-C7DC-9274-20CA-B5939A2A86BD}"/>
+              </a:ext>
+            </a:extLst>
+          </p:cNvPr>
+          <p:cNvSpPr>
+            <a:spLocks noChangeArrowheads="1"/>
+          </p:cNvSpPr>
+          <p:nvPr/>
+        </p:nvSpPr>
+        <p:spPr bwMode="auto">
+          <a:xfrm>
+            <a:off x="448342" y="6549317"/>
+            <a:ext cx="5730175" cy="261610"/>
+          </a:xfrm>
+          <a:prstGeom prst="rect">
+            <a:avLst/>
+          </a:prstGeom>
+          <a:noFill/>
+          <a:ln>
+            <a:noFill/>
+          </a:ln>
+          <a:effectLst/>
+          <a:extLst>
+            <a:ext uri="{909E8E84-426E-40DD-AFC4-6F175D3DCCD1}">
+              <a14:hiddenFill xmlns:a14="http://schemas.microsoft.com/office/drawing/2010/main">
+                <a:solidFill>
+                  <a:schemeClr val="accent1"/>
+                </a:solidFill>
+              </a14:hiddenFill>
+            </a:ext>
+            <a:ext uri="{91240B29-F687-4F45-9708-019B960494DF}">
+              <a14:hiddenLine xmlns:a14="http://schemas.microsoft.com/office/drawing/2010/main" w="9525">
+                <a:solidFill>
+                  <a:schemeClr val="tx1"/>
+                </a:solidFill>
+                <a:miter lim="800000"/>
+                <a:headEnd/>
+                <a:tailEnd/>
+              </a14:hiddenLine>
+            </a:ext>
+            <a:ext uri="{AF507438-7753-43E0-B8FC-AC1667EBCBE1}">
+              <a14:hiddenEffects xmlns:a14="http://schemas.microsoft.com/office/drawing/2010/main">
+                <a:effectLst>
+                  <a:outerShdw dist="35921" dir="2700000" algn="ctr" rotWithShape="0">
+                    <a:schemeClr val="bg2"/>
+                  </a:outerShdw>
+                </a:effectLst>
+              </a14:hiddenEffects>
+            </a:ext>
+          </a:extLst>
+        </p:spPr>
+        <p:txBody>
+          <a:bodyPr vert="horz" wrap="square" lIns="91440" tIns="45720" rIns="91440" bIns="45720" numCol="1" anchor="ctr" anchorCtr="0" compatLnSpc="1">
+            <a:prstTxWarp prst="textNoShape">
+              <a:avLst/>
+            </a:prstTxWarp>
+            <a:spAutoFit/>
+          </a:bodyPr>
+          <a:lstStyle/>
+          <a:p>
+            <a:pPr marL="0" marR="0" lvl="0" indent="0" algn="l" defTabSz="914400" rtl="0" eaLnBrk="0" fontAlgn="base" latinLnBrk="0" hangingPunct="0">
+              <a:lnSpc>
+                <a:spcPct val="100000"/>
+              </a:lnSpc>
+              <a:spcBef>
+                <a:spcPct val="0"/>
+              </a:spcBef>
+              <a:spcAft>
+                <a:spcPct val="0"/>
+              </a:spcAft>
+              <a:buClrTx/>
+              <a:buSzTx/>
+              <a:buFontTx/>
+              <a:buNone/>
+              <a:tabLst/>
+            </a:pPr>
+            <a:r>
+              <a:rPr kumimoji="0" lang="en-US" altLang="es-ES" sz="1100" b="0" i="0" u="none" strike="noStrike" cap="none" normalizeH="0" baseline="0" dirty="0">
+                <a:ln>
+                  <a:noFill/>
+                </a:ln>
+                <a:solidFill>
+                  <a:srgbClr val="F4A200"/>
+                </a:solidFill>
+                <a:effectLst/>
+                <a:latin typeface="Arial" panose="020B0604020202020204" pitchFamily="34" charset="0"/>
+                <a:ea typeface="Myriad Pro Light"/>
+                <a:cs typeface="Times New Roman" panose="02020603050405020304" pitchFamily="18" charset="0"/>
+              </a:rPr>
+              <a:t>Master in Quantitative Economic Analysis </a:t>
+            </a:r>
+            <a:r>
+              <a:rPr kumimoji="0" lang="en-US" altLang="es-ES" sz="1100" b="0" i="0" u="none" strike="noStrike" cap="none" normalizeH="0" baseline="0" dirty="0" err="1">
+                <a:ln>
+                  <a:noFill/>
+                </a:ln>
+                <a:solidFill>
+                  <a:srgbClr val="F4A200"/>
+                </a:solidFill>
+                <a:effectLst/>
+                <a:latin typeface="Arial" panose="020B0604020202020204" pitchFamily="34" charset="0"/>
+                <a:ea typeface="Myriad Pro Light"/>
+                <a:cs typeface="Times New Roman" panose="02020603050405020304" pitchFamily="18" charset="0"/>
+              </a:rPr>
+              <a:t>MQuEA</a:t>
+            </a:r>
+            <a:endParaRPr kumimoji="0" lang="es-ES" altLang="es-ES" sz="300" b="0" i="0" u="none" strike="noStrike" cap="none" normalizeH="0" baseline="0" dirty="0">
+              <a:ln>
+                <a:noFill/>
+              </a:ln>
+              <a:solidFill>
+                <a:schemeClr val="tx1"/>
+              </a:solidFill>
+              <a:effectLst/>
+              <a:latin typeface="Arial" panose="020B0604020202020204" pitchFamily="34" charset="0"/>
+            </a:endParaRPr>
+          </a:p>
+        </p:txBody>
+      </p:sp>
+      <p:sp>
+        <p:nvSpPr>
+          <p:cNvPr id="7" name="Rectangle 143">
+            <a:extLst>
+              <a:ext uri="{FF2B5EF4-FFF2-40B4-BE49-F238E27FC236}">
+                <a16:creationId xmlns:a16="http://schemas.microsoft.com/office/drawing/2014/main" id="{2BE2E3EB-749E-E562-030D-C3F46E714169}"/>
+              </a:ext>
+            </a:extLst>
+          </p:cNvPr>
+          <p:cNvSpPr>
+            <a:spLocks noChangeArrowheads="1"/>
+          </p:cNvSpPr>
+          <p:nvPr/>
+        </p:nvSpPr>
+        <p:spPr bwMode="auto">
+          <a:xfrm>
+            <a:off x="6186394" y="6559955"/>
+            <a:ext cx="5730175" cy="261610"/>
+          </a:xfrm>
+          <a:prstGeom prst="rect">
+            <a:avLst/>
+          </a:prstGeom>
+          <a:noFill/>
+          <a:ln>
+            <a:noFill/>
+          </a:ln>
+          <a:effectLst/>
+          <a:extLst>
+            <a:ext uri="{909E8E84-426E-40DD-AFC4-6F175D3DCCD1}">
+              <a14:hiddenFill xmlns:a14="http://schemas.microsoft.com/office/drawing/2010/main">
+                <a:solidFill>
+                  <a:schemeClr val="accent1"/>
+                </a:solidFill>
+              </a14:hiddenFill>
+            </a:ext>
+            <a:ext uri="{91240B29-F687-4F45-9708-019B960494DF}">
+              <a14:hiddenLine xmlns:a14="http://schemas.microsoft.com/office/drawing/2010/main" w="9525">
+                <a:solidFill>
+                  <a:schemeClr val="tx1"/>
+                </a:solidFill>
+                <a:miter lim="800000"/>
+                <a:headEnd/>
+                <a:tailEnd/>
+              </a14:hiddenLine>
+            </a:ext>
+            <a:ext uri="{AF507438-7753-43E0-B8FC-AC1667EBCBE1}">
+              <a14:hiddenEffects xmlns:a14="http://schemas.microsoft.com/office/drawing/2010/main">
+                <a:effectLst>
+                  <a:outerShdw dist="35921" dir="2700000" algn="ctr" rotWithShape="0">
+                    <a:schemeClr val="bg2"/>
+                  </a:outerShdw>
+                </a:effectLst>
+              </a14:hiddenEffects>
+            </a:ext>
+          </a:extLst>
+        </p:spPr>
+        <p:txBody>
+          <a:bodyPr vert="horz" wrap="square" lIns="91440" tIns="45720" rIns="91440" bIns="45720" numCol="1" anchor="ctr" anchorCtr="0" compatLnSpc="1">
+            <a:prstTxWarp prst="textNoShape">
+              <a:avLst/>
+            </a:prstTxWarp>
+            <a:spAutoFit/>
+          </a:bodyPr>
+          <a:lstStyle/>
+          <a:p>
+            <a:pPr marL="0" marR="0" lvl="0" indent="0" algn="r" defTabSz="914400" rtl="0" eaLnBrk="0" fontAlgn="base" latinLnBrk="0" hangingPunct="0">
+              <a:lnSpc>
+                <a:spcPct val="100000"/>
+              </a:lnSpc>
+              <a:spcBef>
+                <a:spcPct val="0"/>
+              </a:spcBef>
+              <a:spcAft>
+                <a:spcPct val="0"/>
+              </a:spcAft>
+              <a:buClrTx/>
+              <a:buSzTx/>
+              <a:buFontTx/>
+              <a:buNone/>
+              <a:tabLst/>
+            </a:pPr>
+            <a:r>
+              <a:rPr kumimoji="0" lang="en-US" altLang="es-ES" sz="1100" b="0" i="0" u="none" strike="noStrike" cap="none" normalizeH="0" baseline="0" dirty="0">
+                <a:ln>
+                  <a:noFill/>
+                </a:ln>
+                <a:solidFill>
+                  <a:srgbClr val="F4A200"/>
+                </a:solidFill>
+                <a:effectLst/>
+                <a:latin typeface="Arial" panose="020B0604020202020204" pitchFamily="34" charset="0"/>
+                <a:ea typeface="Myriad Pro Light"/>
+                <a:cs typeface="Times New Roman" panose="02020603050405020304" pitchFamily="18" charset="0"/>
+              </a:rPr>
+              <a:t>Universidad </a:t>
+            </a:r>
+            <a:r>
+              <a:rPr kumimoji="0" lang="en-US" altLang="es-ES" sz="1100" b="0" i="0" u="none" strike="noStrike" cap="none" normalizeH="0" baseline="0" dirty="0" err="1">
+                <a:ln>
+                  <a:noFill/>
+                </a:ln>
+                <a:solidFill>
+                  <a:srgbClr val="F4A200"/>
+                </a:solidFill>
+                <a:effectLst/>
+                <a:latin typeface="Arial" panose="020B0604020202020204" pitchFamily="34" charset="0"/>
+                <a:ea typeface="Myriad Pro Light"/>
+                <a:cs typeface="Times New Roman" panose="02020603050405020304" pitchFamily="18" charset="0"/>
+              </a:rPr>
+              <a:t>Aut</a:t>
+            </a:r>
+            <a:r>
+              <a:rPr lang="en-US" altLang="es-ES" sz="1100" dirty="0" err="1">
+                <a:solidFill>
+                  <a:srgbClr val="F4A200"/>
+                </a:solidFill>
+                <a:latin typeface="Arial" panose="020B0604020202020204" pitchFamily="34" charset="0"/>
+                <a:ea typeface="Myriad Pro Light"/>
+                <a:cs typeface="Times New Roman" panose="02020603050405020304" pitchFamily="18" charset="0"/>
+              </a:rPr>
+              <a:t>ó</a:t>
+            </a:r>
+            <a:r>
+              <a:rPr kumimoji="0" lang="en-US" altLang="es-ES" sz="1100" b="0" i="0" u="none" strike="noStrike" cap="none" normalizeH="0" baseline="0" dirty="0" err="1">
+                <a:ln>
+                  <a:noFill/>
+                </a:ln>
+                <a:solidFill>
+                  <a:srgbClr val="F4A200"/>
+                </a:solidFill>
+                <a:effectLst/>
+                <a:latin typeface="Arial" panose="020B0604020202020204" pitchFamily="34" charset="0"/>
+                <a:ea typeface="Myriad Pro Light"/>
+                <a:cs typeface="Times New Roman" panose="02020603050405020304" pitchFamily="18" charset="0"/>
+              </a:rPr>
+              <a:t>noma</a:t>
+            </a:r>
+            <a:r>
+              <a:rPr kumimoji="0" lang="en-US" altLang="es-ES" sz="1100" b="0" i="0" u="none" strike="noStrike" cap="none" normalizeH="0" baseline="0" dirty="0">
+                <a:ln>
+                  <a:noFill/>
+                </a:ln>
+                <a:solidFill>
+                  <a:srgbClr val="F4A200"/>
+                </a:solidFill>
+                <a:effectLst/>
+                <a:latin typeface="Arial" panose="020B0604020202020204" pitchFamily="34" charset="0"/>
+                <a:ea typeface="Myriad Pro Light"/>
+                <a:cs typeface="Times New Roman" panose="02020603050405020304" pitchFamily="18" charset="0"/>
+              </a:rPr>
+              <a:t> de Madrid</a:t>
+            </a:r>
+            <a:endParaRPr kumimoji="0" lang="es-ES" altLang="es-ES" sz="300" b="0" i="0" u="none" strike="noStrike" cap="none" normalizeH="0" baseline="0" dirty="0">
+              <a:ln>
+                <a:noFill/>
+              </a:ln>
+              <a:solidFill>
+                <a:schemeClr val="tx1"/>
+              </a:solidFill>
+              <a:effectLst/>
+              <a:latin typeface="Arial" panose="020B0604020202020204" pitchFamily="34" charset="0"/>
+            </a:endParaRPr>
+          </a:p>
+        </p:txBody>
+      </p:sp>
+    </p:spTree>
+    <p:extLst>
+      <p:ext uri="{BB962C8B-B14F-4D97-AF65-F5344CB8AC3E}">
+        <p14:creationId xmlns:p14="http://schemas.microsoft.com/office/powerpoint/2010/main" val="2121924901"/>
+      </p:ext>
+    </p:extLst>
+  </p:cSld>
+  <p:clrMapOvr>
+    <a:masterClrMapping/>
+  </p:clrMapOvr>
+</p:sld>
+</file>
+
+<file path=ppt/slides/slide17.xml><?xml version="1.0" encoding="utf-8"?>
+<p:sld xmlns:a="http://schemas.openxmlformats.org/drawingml/2006/main" xmlns:r="http://schemas.openxmlformats.org/officeDocument/2006/relationships" xmlns:p="http://schemas.openxmlformats.org/presentationml/2006/main">
+  <p:cSld>
+    <p:spTree>
+      <p:nvGrpSpPr>
+        <p:cNvPr id="1" name=""/>
+        <p:cNvGrpSpPr/>
+        <p:nvPr/>
+      </p:nvGrpSpPr>
+      <p:grpSpPr>
+        <a:xfrm>
+          <a:off x="0" y="0"/>
+          <a:ext cx="0" cy="0"/>
+          <a:chOff x="0" y="0"/>
+          <a:chExt cx="0" cy="0"/>
+        </a:xfrm>
+      </p:grpSpPr>
+      <p:sp>
+        <p:nvSpPr>
+          <p:cNvPr id="2" name="Title 1">
+            <a:extLst>
+              <a:ext uri="{FF2B5EF4-FFF2-40B4-BE49-F238E27FC236}">
+                <a16:creationId xmlns:a16="http://schemas.microsoft.com/office/drawing/2014/main" id="{31C29F6F-54A2-5964-F2B2-982952460386}"/>
+              </a:ext>
+            </a:extLst>
+          </p:cNvPr>
+          <p:cNvSpPr>
+            <a:spLocks noGrp="1"/>
+          </p:cNvSpPr>
+          <p:nvPr>
+            <p:ph type="title"/>
+          </p:nvPr>
+        </p:nvSpPr>
+        <p:spPr/>
+        <p:txBody>
+          <a:bodyPr>
+            <a:normAutofit/>
+          </a:bodyPr>
+          <a:lstStyle/>
+          <a:p>
+            <a:r>
+              <a:rPr lang="en-US" sz="4000" dirty="0"/>
+              <a:t>Ensemble methods – Bagging</a:t>
+            </a:r>
+          </a:p>
+        </p:txBody>
+      </p:sp>
+      <mc:AlternateContent xmlns:mc="http://schemas.openxmlformats.org/markup-compatibility/2006">
+        <mc:Choice xmlns:a14="http://schemas.microsoft.com/office/drawing/2010/main" Requires="a14">
+          <p:sp>
+            <p:nvSpPr>
+              <p:cNvPr id="3" name="Content Placeholder 2">
+                <a:extLst>
+                  <a:ext uri="{FF2B5EF4-FFF2-40B4-BE49-F238E27FC236}">
+                    <a16:creationId xmlns:a16="http://schemas.microsoft.com/office/drawing/2014/main" id="{068F0C39-44FF-99B2-7103-C6D38F774B5B}"/>
+                  </a:ext>
+                </a:extLst>
+              </p:cNvPr>
+              <p:cNvSpPr>
+                <a:spLocks noGrp="1"/>
+              </p:cNvSpPr>
+              <p:nvPr>
+                <p:ph idx="1"/>
+              </p:nvPr>
+            </p:nvSpPr>
+            <p:spPr>
+              <a:xfrm>
+                <a:off x="844778" y="1819047"/>
+                <a:ext cx="10515600" cy="4351338"/>
+              </a:xfrm>
+            </p:spPr>
+            <p:txBody>
+              <a:bodyPr>
+                <a:normAutofit fontScale="92500"/>
+              </a:bodyPr>
+              <a:lstStyle/>
+              <a:p>
+                <a:pPr>
+                  <a:lnSpc>
+                    <a:spcPct val="150000"/>
+                  </a:lnSpc>
+                  <a:buFont typeface="Wingdings" panose="05000000000000000000" pitchFamily="2" charset="2"/>
+                  <a:buChar char="§"/>
+                </a:pPr>
+                <a:r>
+                  <a:rPr lang="en-US" sz="2000" dirty="0">
+                    <a:latin typeface="+mj-lt"/>
+                  </a:rPr>
+                  <a:t>Obviously, we don’t have access to many training sets, but we can bootstrap. We generate </a:t>
+                </a:r>
+                <a:r>
+                  <a:rPr lang="en-US" sz="2000" i="1" dirty="0">
+                    <a:latin typeface="+mj-lt"/>
+                  </a:rPr>
+                  <a:t>B</a:t>
+                </a:r>
+                <a:r>
+                  <a:rPr lang="en-US" sz="2000" dirty="0">
+                    <a:latin typeface="+mj-lt"/>
+                  </a:rPr>
+                  <a:t> different bootstrapped training data sets, train our model on them, and finally average the prediction. This is called </a:t>
+                </a:r>
+                <a:r>
+                  <a:rPr lang="en-US" sz="2000" b="1" i="1" dirty="0">
+                    <a:latin typeface="+mj-lt"/>
+                  </a:rPr>
+                  <a:t>bagging</a:t>
+                </a:r>
+                <a:r>
+                  <a:rPr lang="en-US" sz="2000" i="1" dirty="0">
+                    <a:latin typeface="+mj-lt"/>
+                  </a:rPr>
+                  <a:t>.</a:t>
+                </a:r>
+                <a:endParaRPr lang="en-US" sz="2000" dirty="0">
+                  <a:latin typeface="+mj-lt"/>
+                </a:endParaRPr>
+              </a:p>
+              <a:p>
+                <a:pPr marL="0" indent="0">
+                  <a:lnSpc>
+                    <a:spcPct val="150000"/>
+                  </a:lnSpc>
+                  <a:buNone/>
+                </a:pPr>
+                <a14:m>
+                  <m:oMathPara xmlns:m="http://schemas.openxmlformats.org/officeDocument/2006/math">
+                    <m:oMathParaPr>
+                      <m:jc m:val="centerGroup"/>
+                    </m:oMathParaPr>
+                    <m:oMath xmlns:m="http://schemas.openxmlformats.org/officeDocument/2006/math">
+                      <m:sSub>
+                        <m:sSubPr>
+                          <m:ctrlPr>
+                            <a:rPr lang="en-US" sz="2000" i="1" smtClean="0">
+                              <a:latin typeface="Cambria Math" panose="02040503050406030204" pitchFamily="18" charset="0"/>
+                            </a:rPr>
+                          </m:ctrlPr>
+                        </m:sSubPr>
+                        <m:e>
+                          <m:acc>
+                            <m:accPr>
+                              <m:chr m:val="̂"/>
+                              <m:ctrlPr>
+                                <a:rPr lang="en-US" sz="2000" i="1" smtClean="0">
+                                  <a:latin typeface="Cambria Math" panose="02040503050406030204" pitchFamily="18" charset="0"/>
+                                </a:rPr>
+                              </m:ctrlPr>
+                            </m:accPr>
+                            <m:e>
+                              <m:r>
+                                <a:rPr lang="en-US" sz="2000" b="0" i="1" smtClean="0">
+                                  <a:latin typeface="Cambria Math" panose="02040503050406030204" pitchFamily="18" charset="0"/>
+                                </a:rPr>
+                                <m:t>𝑓</m:t>
+                              </m:r>
+                            </m:e>
+                          </m:acc>
+                        </m:e>
+                        <m:sub>
+                          <m:r>
+                            <a:rPr lang="en-US" sz="2000" b="0" i="1" smtClean="0">
+                              <a:latin typeface="Cambria Math" panose="02040503050406030204" pitchFamily="18" charset="0"/>
+                            </a:rPr>
+                            <m:t>𝑏𝑎𝑔</m:t>
+                          </m:r>
+                        </m:sub>
+                      </m:sSub>
+                      <m:d>
+                        <m:dPr>
+                          <m:ctrlPr>
+                            <a:rPr lang="en-US" sz="2000" b="0" i="1" smtClean="0">
+                              <a:latin typeface="Cambria Math" panose="02040503050406030204" pitchFamily="18" charset="0"/>
+                            </a:rPr>
+                          </m:ctrlPr>
+                        </m:dPr>
+                        <m:e>
+                          <m:r>
+                            <a:rPr lang="en-US" sz="2000" b="0" i="1" smtClean="0">
+                              <a:latin typeface="Cambria Math" panose="02040503050406030204" pitchFamily="18" charset="0"/>
+                            </a:rPr>
+                            <m:t>𝑥</m:t>
+                          </m:r>
+                        </m:e>
+                      </m:d>
+                      <m:r>
+                        <a:rPr lang="en-US" sz="2000" b="0" i="1" smtClean="0">
+                          <a:latin typeface="Cambria Math" panose="02040503050406030204" pitchFamily="18" charset="0"/>
+                        </a:rPr>
+                        <m:t>=</m:t>
+                      </m:r>
+                      <m:f>
+                        <m:fPr>
+                          <m:ctrlPr>
+                            <a:rPr lang="en-US" sz="2000" b="0" i="1" smtClean="0">
+                              <a:latin typeface="Cambria Math" panose="02040503050406030204" pitchFamily="18" charset="0"/>
+                            </a:rPr>
+                          </m:ctrlPr>
+                        </m:fPr>
+                        <m:num>
+                          <m:r>
+                            <a:rPr lang="en-US" sz="2000" b="0" i="1" smtClean="0">
+                              <a:latin typeface="Cambria Math" panose="02040503050406030204" pitchFamily="18" charset="0"/>
+                            </a:rPr>
+                            <m:t>1</m:t>
+                          </m:r>
+                        </m:num>
+                        <m:den>
+                          <m:r>
+                            <a:rPr lang="en-US" sz="2000" b="0" i="1" smtClean="0">
+                              <a:latin typeface="Cambria Math" panose="02040503050406030204" pitchFamily="18" charset="0"/>
+                            </a:rPr>
+                            <m:t>𝐵</m:t>
+                          </m:r>
+                        </m:den>
+                      </m:f>
+                      <m:nary>
+                        <m:naryPr>
+                          <m:chr m:val="∑"/>
+                          <m:ctrlPr>
+                            <a:rPr lang="en-US" sz="2000" b="0" i="1" smtClean="0">
+                              <a:latin typeface="Cambria Math" panose="02040503050406030204" pitchFamily="18" charset="0"/>
+                            </a:rPr>
+                          </m:ctrlPr>
+                        </m:naryPr>
+                        <m:sub>
+                          <m:r>
+                            <m:rPr>
+                              <m:brk m:alnAt="23"/>
+                            </m:rPr>
+                            <a:rPr lang="en-US" sz="2000" b="0" i="1" smtClean="0">
+                              <a:latin typeface="Cambria Math" panose="02040503050406030204" pitchFamily="18" charset="0"/>
+                            </a:rPr>
+                            <m:t>𝑏</m:t>
+                          </m:r>
+                          <m:r>
+                            <a:rPr lang="en-US" sz="2000" b="0" i="1" smtClean="0">
+                              <a:latin typeface="Cambria Math" panose="02040503050406030204" pitchFamily="18" charset="0"/>
+                            </a:rPr>
+                            <m:t>=1</m:t>
+                          </m:r>
+                        </m:sub>
+                        <m:sup>
+                          <m:r>
+                            <a:rPr lang="en-US" sz="2000" b="0" i="1" smtClean="0">
+                              <a:latin typeface="Cambria Math" panose="02040503050406030204" pitchFamily="18" charset="0"/>
+                            </a:rPr>
+                            <m:t>𝐵</m:t>
+                          </m:r>
+                        </m:sup>
+                        <m:e>
+                          <m:sSup>
+                            <m:sSupPr>
+                              <m:ctrlPr>
+                                <a:rPr lang="en-US" sz="2000" b="0" i="1" smtClean="0">
+                                  <a:latin typeface="Cambria Math" panose="02040503050406030204" pitchFamily="18" charset="0"/>
+                                </a:rPr>
+                              </m:ctrlPr>
+                            </m:sSupPr>
+                            <m:e>
+                              <m:acc>
+                                <m:accPr>
+                                  <m:chr m:val="̂"/>
+                                  <m:ctrlPr>
+                                    <a:rPr lang="en-US" sz="2000" b="0" i="1" smtClean="0">
+                                      <a:latin typeface="Cambria Math" panose="02040503050406030204" pitchFamily="18" charset="0"/>
+                                    </a:rPr>
+                                  </m:ctrlPr>
+                                </m:accPr>
+                                <m:e>
+                                  <m:r>
+                                    <a:rPr lang="en-US" sz="2000" b="0" i="1" smtClean="0">
+                                      <a:latin typeface="Cambria Math" panose="02040503050406030204" pitchFamily="18" charset="0"/>
+                                    </a:rPr>
+                                    <m:t>𝑓</m:t>
+                                  </m:r>
+                                </m:e>
+                              </m:acc>
+                            </m:e>
+                            <m:sup>
+                              <m:r>
+                                <a:rPr lang="en-US" sz="2000" b="0" i="1" smtClean="0">
+                                  <a:latin typeface="Cambria Math" panose="02040503050406030204" pitchFamily="18" charset="0"/>
+                                </a:rPr>
+                                <m:t>∗</m:t>
+                              </m:r>
+                              <m:r>
+                                <a:rPr lang="en-US" sz="2000" b="0" i="1" smtClean="0">
+                                  <a:latin typeface="Cambria Math" panose="02040503050406030204" pitchFamily="18" charset="0"/>
+                                </a:rPr>
+                                <m:t>𝑏</m:t>
+                              </m:r>
+                            </m:sup>
+                          </m:sSup>
+                          <m:r>
+                            <a:rPr lang="en-US" sz="2000" b="0" i="1" smtClean="0">
+                              <a:latin typeface="Cambria Math" panose="02040503050406030204" pitchFamily="18" charset="0"/>
+                            </a:rPr>
+                            <m:t>(</m:t>
+                          </m:r>
+                          <m:r>
+                            <a:rPr lang="en-US" sz="2000" b="0" i="1" smtClean="0">
+                              <a:latin typeface="Cambria Math" panose="02040503050406030204" pitchFamily="18" charset="0"/>
+                            </a:rPr>
+                            <m:t>𝑥</m:t>
+                          </m:r>
+                          <m:r>
+                            <a:rPr lang="en-US" sz="2000" b="0" i="1" smtClean="0">
+                              <a:latin typeface="Cambria Math" panose="02040503050406030204" pitchFamily="18" charset="0"/>
+                            </a:rPr>
+                            <m:t>)</m:t>
+                          </m:r>
+                        </m:e>
+                      </m:nary>
+                    </m:oMath>
+                  </m:oMathPara>
+                </a14:m>
+                <a:endParaRPr lang="en-US" sz="2000" b="0" dirty="0">
+                  <a:latin typeface="+mj-lt"/>
+                </a:endParaRPr>
+              </a:p>
+              <a:p>
+                <a:pPr>
+                  <a:lnSpc>
+                    <a:spcPct val="150000"/>
+                  </a:lnSpc>
+                </a:pPr>
+                <a:r>
+                  <a:rPr lang="en-US" sz="2000" dirty="0">
+                    <a:latin typeface="+mj-lt"/>
+                  </a:rPr>
+                  <a:t>Bagging is particularly useful for regression trees. Trees (hundreds of thousands) grow deep and are not pruned. Hence, each tree has high variance, but low bias. Averaging the </a:t>
+                </a:r>
+                <a:r>
+                  <a:rPr lang="en-US" sz="2000" i="1" dirty="0">
+                    <a:latin typeface="+mj-lt"/>
+                  </a:rPr>
+                  <a:t>B </a:t>
+                </a:r>
+                <a:r>
+                  <a:rPr lang="en-US" sz="2000" dirty="0">
+                    <a:latin typeface="+mj-lt"/>
+                  </a:rPr>
+                  <a:t>trees reduces the variance</a:t>
+                </a:r>
+              </a:p>
+              <a:p>
+                <a:pPr>
+                  <a:lnSpc>
+                    <a:spcPct val="150000"/>
+                  </a:lnSpc>
+                </a:pPr>
+                <a:r>
+                  <a:rPr lang="en-US" sz="2000" dirty="0">
+                    <a:latin typeface="+mj-lt"/>
+                  </a:rPr>
+                  <a:t>In the case of classification, each tree makes prediction and take the </a:t>
+                </a:r>
+                <a:r>
+                  <a:rPr lang="en-US" sz="2000" i="1" dirty="0">
+                    <a:latin typeface="+mj-lt"/>
+                  </a:rPr>
+                  <a:t>majority vote.</a:t>
+                </a:r>
+                <a:endParaRPr lang="en-US" sz="2000" dirty="0">
+                  <a:latin typeface="+mj-lt"/>
+                </a:endParaRPr>
+              </a:p>
+            </p:txBody>
+          </p:sp>
+        </mc:Choice>
+        <mc:Fallback>
+          <p:sp>
+            <p:nvSpPr>
+              <p:cNvPr id="3" name="Content Placeholder 2">
+                <a:extLst>
+                  <a:ext uri="{FF2B5EF4-FFF2-40B4-BE49-F238E27FC236}">
+                    <a16:creationId xmlns:a16="http://schemas.microsoft.com/office/drawing/2014/main" id="{068F0C39-44FF-99B2-7103-C6D38F774B5B}"/>
+                  </a:ext>
+                </a:extLst>
+              </p:cNvPr>
+              <p:cNvSpPr>
+                <a:spLocks noGrp="1" noRot="1" noChangeAspect="1" noMove="1" noResize="1" noEditPoints="1" noAdjustHandles="1" noChangeArrowheads="1" noChangeShapeType="1" noTextEdit="1"/>
+              </p:cNvSpPr>
+              <p:nvPr>
+                <p:ph idx="1"/>
+              </p:nvPr>
+            </p:nvSpPr>
+            <p:spPr>
+              <a:xfrm>
+                <a:off x="844778" y="1819047"/>
+                <a:ext cx="10515600" cy="4351338"/>
+              </a:xfrm>
+              <a:blipFill>
+                <a:blip r:embed="rId2"/>
+                <a:stretch>
+                  <a:fillRect l="-464"/>
+                </a:stretch>
+              </a:blipFill>
+            </p:spPr>
+            <p:txBody>
+              <a:bodyPr/>
+              <a:lstStyle/>
+              <a:p>
+                <a:r>
+                  <a:rPr lang="en-US">
+                    <a:noFill/>
+                  </a:rPr>
+                  <a:t> </a:t>
+                </a:r>
+              </a:p>
+            </p:txBody>
+          </p:sp>
+        </mc:Fallback>
+      </mc:AlternateContent>
+      <p:sp>
+        <p:nvSpPr>
+          <p:cNvPr id="4" name="Rectángulo 3">
+            <a:extLst>
+              <a:ext uri="{FF2B5EF4-FFF2-40B4-BE49-F238E27FC236}">
+                <a16:creationId xmlns:a16="http://schemas.microsoft.com/office/drawing/2014/main" id="{7BF95E35-4D9C-7F59-F308-C61FF9CD1B58}"/>
+              </a:ext>
+            </a:extLst>
+          </p:cNvPr>
+          <p:cNvSpPr/>
+          <p:nvPr/>
+        </p:nvSpPr>
+        <p:spPr>
+          <a:xfrm>
+            <a:off x="0" y="0"/>
+            <a:ext cx="374469" cy="6858000"/>
+          </a:xfrm>
+          <a:prstGeom prst="rect">
+            <a:avLst/>
+          </a:prstGeom>
+        </p:spPr>
+        <p:style>
+          <a:lnRef idx="2">
+            <a:schemeClr val="accent2">
+              <a:shade val="50000"/>
+            </a:schemeClr>
+          </a:lnRef>
+          <a:fillRef idx="1">
+            <a:schemeClr val="accent2"/>
+          </a:fillRef>
+          <a:effectRef idx="0">
+            <a:schemeClr val="accent2"/>
+          </a:effectRef>
+          <a:fontRef idx="minor">
+            <a:schemeClr val="lt1"/>
+          </a:fontRef>
+        </p:style>
+        <p:txBody>
+          <a:bodyPr rtlCol="0" anchor="ctr"/>
+          <a:lstStyle/>
+          <a:p>
+            <a:pPr algn="ctr"/>
+            <a:endParaRPr lang="es-ES"/>
+          </a:p>
+        </p:txBody>
+      </p:sp>
+      <p:sp>
+        <p:nvSpPr>
+          <p:cNvPr id="6" name="Rectangle 143">
+            <a:extLst>
+              <a:ext uri="{FF2B5EF4-FFF2-40B4-BE49-F238E27FC236}">
+                <a16:creationId xmlns:a16="http://schemas.microsoft.com/office/drawing/2014/main" id="{C9A975F5-C7DC-9274-20CA-B5939A2A86BD}"/>
+              </a:ext>
+            </a:extLst>
+          </p:cNvPr>
+          <p:cNvSpPr>
+            <a:spLocks noChangeArrowheads="1"/>
+          </p:cNvSpPr>
+          <p:nvPr/>
+        </p:nvSpPr>
+        <p:spPr bwMode="auto">
+          <a:xfrm>
+            <a:off x="448342" y="6549317"/>
+            <a:ext cx="5730175" cy="261610"/>
+          </a:xfrm>
+          <a:prstGeom prst="rect">
+            <a:avLst/>
+          </a:prstGeom>
+          <a:noFill/>
+          <a:ln>
+            <a:noFill/>
+          </a:ln>
+          <a:effectLst/>
+          <a:extLst>
+            <a:ext uri="{909E8E84-426E-40DD-AFC4-6F175D3DCCD1}">
+              <a14:hiddenFill xmlns:a14="http://schemas.microsoft.com/office/drawing/2010/main">
+                <a:solidFill>
+                  <a:schemeClr val="accent1"/>
+                </a:solidFill>
+              </a14:hiddenFill>
+            </a:ext>
+            <a:ext uri="{91240B29-F687-4F45-9708-019B960494DF}">
+              <a14:hiddenLine xmlns:a14="http://schemas.microsoft.com/office/drawing/2010/main" w="9525">
+                <a:solidFill>
+                  <a:schemeClr val="tx1"/>
+                </a:solidFill>
+                <a:miter lim="800000"/>
+                <a:headEnd/>
+                <a:tailEnd/>
+              </a14:hiddenLine>
+            </a:ext>
+            <a:ext uri="{AF507438-7753-43E0-B8FC-AC1667EBCBE1}">
+              <a14:hiddenEffects xmlns:a14="http://schemas.microsoft.com/office/drawing/2010/main">
+                <a:effectLst>
+                  <a:outerShdw dist="35921" dir="2700000" algn="ctr" rotWithShape="0">
+                    <a:schemeClr val="bg2"/>
+                  </a:outerShdw>
+                </a:effectLst>
+              </a14:hiddenEffects>
+            </a:ext>
+          </a:extLst>
+        </p:spPr>
+        <p:txBody>
+          <a:bodyPr vert="horz" wrap="square" lIns="91440" tIns="45720" rIns="91440" bIns="45720" numCol="1" anchor="ctr" anchorCtr="0" compatLnSpc="1">
+            <a:prstTxWarp prst="textNoShape">
+              <a:avLst/>
+            </a:prstTxWarp>
+            <a:spAutoFit/>
+          </a:bodyPr>
+          <a:lstStyle/>
+          <a:p>
+            <a:pPr marL="0" marR="0" lvl="0" indent="0" algn="l" defTabSz="914400" rtl="0" eaLnBrk="0" fontAlgn="base" latinLnBrk="0" hangingPunct="0">
+              <a:lnSpc>
+                <a:spcPct val="100000"/>
+              </a:lnSpc>
+              <a:spcBef>
+                <a:spcPct val="0"/>
+              </a:spcBef>
+              <a:spcAft>
+                <a:spcPct val="0"/>
+              </a:spcAft>
+              <a:buClrTx/>
+              <a:buSzTx/>
+              <a:buFontTx/>
+              <a:buNone/>
+              <a:tabLst/>
+            </a:pPr>
+            <a:r>
+              <a:rPr kumimoji="0" lang="en-US" altLang="es-ES" sz="1100" b="0" i="0" u="none" strike="noStrike" cap="none" normalizeH="0" baseline="0" dirty="0">
+                <a:ln>
+                  <a:noFill/>
+                </a:ln>
+                <a:solidFill>
+                  <a:srgbClr val="F4A200"/>
+                </a:solidFill>
+                <a:effectLst/>
+                <a:latin typeface="Arial" panose="020B0604020202020204" pitchFamily="34" charset="0"/>
+                <a:ea typeface="Myriad Pro Light"/>
+                <a:cs typeface="Times New Roman" panose="02020603050405020304" pitchFamily="18" charset="0"/>
+              </a:rPr>
+              <a:t>Master in Quantitative Economic Analysis </a:t>
+            </a:r>
+            <a:r>
+              <a:rPr kumimoji="0" lang="en-US" altLang="es-ES" sz="1100" b="0" i="0" u="none" strike="noStrike" cap="none" normalizeH="0" baseline="0" dirty="0" err="1">
+                <a:ln>
+                  <a:noFill/>
+                </a:ln>
+                <a:solidFill>
+                  <a:srgbClr val="F4A200"/>
+                </a:solidFill>
+                <a:effectLst/>
+                <a:latin typeface="Arial" panose="020B0604020202020204" pitchFamily="34" charset="0"/>
+                <a:ea typeface="Myriad Pro Light"/>
+                <a:cs typeface="Times New Roman" panose="02020603050405020304" pitchFamily="18" charset="0"/>
+              </a:rPr>
+              <a:t>MQuEA</a:t>
+            </a:r>
+            <a:endParaRPr kumimoji="0" lang="es-ES" altLang="es-ES" sz="300" b="0" i="0" u="none" strike="noStrike" cap="none" normalizeH="0" baseline="0" dirty="0">
+              <a:ln>
+                <a:noFill/>
+              </a:ln>
+              <a:solidFill>
+                <a:schemeClr val="tx1"/>
+              </a:solidFill>
+              <a:effectLst/>
+              <a:latin typeface="Arial" panose="020B0604020202020204" pitchFamily="34" charset="0"/>
+            </a:endParaRPr>
+          </a:p>
+        </p:txBody>
+      </p:sp>
+      <p:sp>
+        <p:nvSpPr>
+          <p:cNvPr id="7" name="Rectangle 143">
+            <a:extLst>
+              <a:ext uri="{FF2B5EF4-FFF2-40B4-BE49-F238E27FC236}">
+                <a16:creationId xmlns:a16="http://schemas.microsoft.com/office/drawing/2014/main" id="{2BE2E3EB-749E-E562-030D-C3F46E714169}"/>
+              </a:ext>
+            </a:extLst>
+          </p:cNvPr>
+          <p:cNvSpPr>
+            <a:spLocks noChangeArrowheads="1"/>
+          </p:cNvSpPr>
+          <p:nvPr/>
+        </p:nvSpPr>
+        <p:spPr bwMode="auto">
+          <a:xfrm>
+            <a:off x="6186394" y="6559955"/>
+            <a:ext cx="5730175" cy="261610"/>
+          </a:xfrm>
+          <a:prstGeom prst="rect">
+            <a:avLst/>
+          </a:prstGeom>
+          <a:noFill/>
+          <a:ln>
+            <a:noFill/>
+          </a:ln>
+          <a:effectLst/>
+          <a:extLst>
+            <a:ext uri="{909E8E84-426E-40DD-AFC4-6F175D3DCCD1}">
+              <a14:hiddenFill xmlns:a14="http://schemas.microsoft.com/office/drawing/2010/main">
+                <a:solidFill>
+                  <a:schemeClr val="accent1"/>
+                </a:solidFill>
+              </a14:hiddenFill>
+            </a:ext>
+            <a:ext uri="{91240B29-F687-4F45-9708-019B960494DF}">
+              <a14:hiddenLine xmlns:a14="http://schemas.microsoft.com/office/drawing/2010/main" w="9525">
+                <a:solidFill>
+                  <a:schemeClr val="tx1"/>
+                </a:solidFill>
+                <a:miter lim="800000"/>
+                <a:headEnd/>
+                <a:tailEnd/>
+              </a14:hiddenLine>
+            </a:ext>
+            <a:ext uri="{AF507438-7753-43E0-B8FC-AC1667EBCBE1}">
+              <a14:hiddenEffects xmlns:a14="http://schemas.microsoft.com/office/drawing/2010/main">
+                <a:effectLst>
+                  <a:outerShdw dist="35921" dir="2700000" algn="ctr" rotWithShape="0">
+                    <a:schemeClr val="bg2"/>
+                  </a:outerShdw>
+                </a:effectLst>
+              </a14:hiddenEffects>
+            </a:ext>
+          </a:extLst>
+        </p:spPr>
+        <p:txBody>
+          <a:bodyPr vert="horz" wrap="square" lIns="91440" tIns="45720" rIns="91440" bIns="45720" numCol="1" anchor="ctr" anchorCtr="0" compatLnSpc="1">
+            <a:prstTxWarp prst="textNoShape">
+              <a:avLst/>
+            </a:prstTxWarp>
+            <a:spAutoFit/>
+          </a:bodyPr>
+          <a:lstStyle/>
+          <a:p>
+            <a:pPr marL="0" marR="0" lvl="0" indent="0" algn="r" defTabSz="914400" rtl="0" eaLnBrk="0" fontAlgn="base" latinLnBrk="0" hangingPunct="0">
+              <a:lnSpc>
+                <a:spcPct val="100000"/>
+              </a:lnSpc>
+              <a:spcBef>
+                <a:spcPct val="0"/>
+              </a:spcBef>
+              <a:spcAft>
+                <a:spcPct val="0"/>
+              </a:spcAft>
+              <a:buClrTx/>
+              <a:buSzTx/>
+              <a:buFontTx/>
+              <a:buNone/>
+              <a:tabLst/>
+            </a:pPr>
+            <a:r>
+              <a:rPr kumimoji="0" lang="en-US" altLang="es-ES" sz="1100" b="0" i="0" u="none" strike="noStrike" cap="none" normalizeH="0" baseline="0" dirty="0">
+                <a:ln>
+                  <a:noFill/>
+                </a:ln>
+                <a:solidFill>
+                  <a:srgbClr val="F4A200"/>
+                </a:solidFill>
+                <a:effectLst/>
+                <a:latin typeface="Arial" panose="020B0604020202020204" pitchFamily="34" charset="0"/>
+                <a:ea typeface="Myriad Pro Light"/>
+                <a:cs typeface="Times New Roman" panose="02020603050405020304" pitchFamily="18" charset="0"/>
+              </a:rPr>
+              <a:t>Universidad </a:t>
+            </a:r>
+            <a:r>
+              <a:rPr kumimoji="0" lang="en-US" altLang="es-ES" sz="1100" b="0" i="0" u="none" strike="noStrike" cap="none" normalizeH="0" baseline="0" dirty="0" err="1">
+                <a:ln>
+                  <a:noFill/>
+                </a:ln>
+                <a:solidFill>
+                  <a:srgbClr val="F4A200"/>
+                </a:solidFill>
+                <a:effectLst/>
+                <a:latin typeface="Arial" panose="020B0604020202020204" pitchFamily="34" charset="0"/>
+                <a:ea typeface="Myriad Pro Light"/>
+                <a:cs typeface="Times New Roman" panose="02020603050405020304" pitchFamily="18" charset="0"/>
+              </a:rPr>
+              <a:t>Aut</a:t>
+            </a:r>
+            <a:r>
+              <a:rPr lang="en-US" altLang="es-ES" sz="1100" dirty="0" err="1">
+                <a:solidFill>
+                  <a:srgbClr val="F4A200"/>
+                </a:solidFill>
+                <a:latin typeface="Arial" panose="020B0604020202020204" pitchFamily="34" charset="0"/>
+                <a:ea typeface="Myriad Pro Light"/>
+                <a:cs typeface="Times New Roman" panose="02020603050405020304" pitchFamily="18" charset="0"/>
+              </a:rPr>
+              <a:t>ó</a:t>
+            </a:r>
+            <a:r>
+              <a:rPr kumimoji="0" lang="en-US" altLang="es-ES" sz="1100" b="0" i="0" u="none" strike="noStrike" cap="none" normalizeH="0" baseline="0" dirty="0" err="1">
+                <a:ln>
+                  <a:noFill/>
+                </a:ln>
+                <a:solidFill>
+                  <a:srgbClr val="F4A200"/>
+                </a:solidFill>
+                <a:effectLst/>
+                <a:latin typeface="Arial" panose="020B0604020202020204" pitchFamily="34" charset="0"/>
+                <a:ea typeface="Myriad Pro Light"/>
+                <a:cs typeface="Times New Roman" panose="02020603050405020304" pitchFamily="18" charset="0"/>
+              </a:rPr>
+              <a:t>noma</a:t>
+            </a:r>
+            <a:r>
+              <a:rPr kumimoji="0" lang="en-US" altLang="es-ES" sz="1100" b="0" i="0" u="none" strike="noStrike" cap="none" normalizeH="0" baseline="0" dirty="0">
+                <a:ln>
+                  <a:noFill/>
+                </a:ln>
+                <a:solidFill>
+                  <a:srgbClr val="F4A200"/>
+                </a:solidFill>
+                <a:effectLst/>
+                <a:latin typeface="Arial" panose="020B0604020202020204" pitchFamily="34" charset="0"/>
+                <a:ea typeface="Myriad Pro Light"/>
+                <a:cs typeface="Times New Roman" panose="02020603050405020304" pitchFamily="18" charset="0"/>
+              </a:rPr>
+              <a:t> de Madrid</a:t>
+            </a:r>
+            <a:endParaRPr kumimoji="0" lang="es-ES" altLang="es-ES" sz="300" b="0" i="0" u="none" strike="noStrike" cap="none" normalizeH="0" baseline="0" dirty="0">
+              <a:ln>
+                <a:noFill/>
+              </a:ln>
+              <a:solidFill>
+                <a:schemeClr val="tx1"/>
+              </a:solidFill>
+              <a:effectLst/>
+              <a:latin typeface="Arial" panose="020B0604020202020204" pitchFamily="34" charset="0"/>
+            </a:endParaRPr>
+          </a:p>
+        </p:txBody>
+      </p:sp>
+    </p:spTree>
+    <p:extLst>
+      <p:ext uri="{BB962C8B-B14F-4D97-AF65-F5344CB8AC3E}">
+        <p14:creationId xmlns:p14="http://schemas.microsoft.com/office/powerpoint/2010/main" val="2359205037"/>
+      </p:ext>
+    </p:extLst>
+  </p:cSld>
+  <p:clrMapOvr>
+    <a:masterClrMapping/>
+  </p:clrMapOvr>
+</p:sld>
+</file>
+
+<file path=ppt/slides/slide18.xml><?xml version="1.0" encoding="utf-8"?>
+<p:sld xmlns:a="http://schemas.openxmlformats.org/drawingml/2006/main" xmlns:r="http://schemas.openxmlformats.org/officeDocument/2006/relationships" xmlns:p="http://schemas.openxmlformats.org/presentationml/2006/main">
+  <p:cSld>
+    <p:spTree>
+      <p:nvGrpSpPr>
+        <p:cNvPr id="1" name=""/>
+        <p:cNvGrpSpPr/>
+        <p:nvPr/>
+      </p:nvGrpSpPr>
+      <p:grpSpPr>
+        <a:xfrm>
+          <a:off x="0" y="0"/>
+          <a:ext cx="0" cy="0"/>
+          <a:chOff x="0" y="0"/>
+          <a:chExt cx="0" cy="0"/>
+        </a:xfrm>
+      </p:grpSpPr>
+      <p:sp>
+        <p:nvSpPr>
+          <p:cNvPr id="2" name="Title 1">
+            <a:extLst>
+              <a:ext uri="{FF2B5EF4-FFF2-40B4-BE49-F238E27FC236}">
+                <a16:creationId xmlns:a16="http://schemas.microsoft.com/office/drawing/2014/main" id="{31C29F6F-54A2-5964-F2B2-982952460386}"/>
+              </a:ext>
+            </a:extLst>
+          </p:cNvPr>
+          <p:cNvSpPr>
+            <a:spLocks noGrp="1"/>
+          </p:cNvSpPr>
+          <p:nvPr>
+            <p:ph type="title"/>
+          </p:nvPr>
+        </p:nvSpPr>
+        <p:spPr/>
+        <p:txBody>
+          <a:bodyPr>
+            <a:normAutofit/>
+          </a:bodyPr>
+          <a:lstStyle/>
+          <a:p>
+            <a:r>
+              <a:rPr lang="en-US" sz="4000" dirty="0"/>
+              <a:t>Ensemble methods – Random Forest</a:t>
+            </a:r>
+          </a:p>
+        </p:txBody>
+      </p:sp>
+      <mc:AlternateContent xmlns:mc="http://schemas.openxmlformats.org/markup-compatibility/2006">
+        <mc:Choice xmlns:a14="http://schemas.microsoft.com/office/drawing/2010/main" Requires="a14">
+          <p:sp>
+            <p:nvSpPr>
+              <p:cNvPr id="3" name="Content Placeholder 2">
+                <a:extLst>
+                  <a:ext uri="{FF2B5EF4-FFF2-40B4-BE49-F238E27FC236}">
+                    <a16:creationId xmlns:a16="http://schemas.microsoft.com/office/drawing/2014/main" id="{068F0C39-44FF-99B2-7103-C6D38F774B5B}"/>
+                  </a:ext>
+                </a:extLst>
+              </p:cNvPr>
+              <p:cNvSpPr>
+                <a:spLocks noGrp="1"/>
+              </p:cNvSpPr>
+              <p:nvPr>
+                <p:ph idx="1"/>
+              </p:nvPr>
+            </p:nvSpPr>
+            <p:spPr>
+              <a:xfrm>
+                <a:off x="844778" y="1819047"/>
+                <a:ext cx="10515600" cy="4351338"/>
+              </a:xfrm>
+            </p:spPr>
+            <p:txBody>
+              <a:bodyPr>
+                <a:normAutofit lnSpcReduction="10000"/>
+              </a:bodyPr>
+              <a:lstStyle/>
+              <a:p>
+                <a:pPr>
+                  <a:lnSpc>
+                    <a:spcPct val="150000"/>
+                  </a:lnSpc>
+                  <a:buFont typeface="Wingdings" panose="05000000000000000000" pitchFamily="2" charset="2"/>
+                  <a:buChar char="§"/>
+                </a:pPr>
+                <a:r>
+                  <a:rPr lang="en-US" sz="2000" dirty="0">
+                    <a:latin typeface="+mj-lt"/>
+                  </a:rPr>
+                  <a:t>As in bagging, RF build a number of decision trees on bootstrapped samples. But when building them, each time a split in a tree is considered, a random sample of </a:t>
+                </a:r>
+                <a:r>
+                  <a:rPr lang="en-US" sz="2000" i="1" dirty="0">
+                    <a:latin typeface="+mj-lt"/>
+                  </a:rPr>
+                  <a:t>m</a:t>
+                </a:r>
+                <a:r>
+                  <a:rPr lang="en-US" sz="2000" dirty="0">
+                    <a:latin typeface="+mj-lt"/>
+                  </a:rPr>
+                  <a:t> (</a:t>
+                </a:r>
+                <a14:m>
+                  <m:oMath xmlns:m="http://schemas.openxmlformats.org/officeDocument/2006/math">
+                    <m:r>
+                      <a:rPr lang="en-US" sz="2000" b="0" i="1" smtClean="0">
+                        <a:latin typeface="Cambria Math" panose="02040503050406030204" pitchFamily="18" charset="0"/>
+                      </a:rPr>
+                      <m:t>𝑚</m:t>
+                    </m:r>
+                    <m:r>
+                      <a:rPr lang="en-US" sz="2000" b="0" i="1" smtClean="0">
+                        <a:latin typeface="Cambria Math" panose="02040503050406030204" pitchFamily="18" charset="0"/>
+                        <a:ea typeface="Cambria Math" panose="02040503050406030204" pitchFamily="18" charset="0"/>
+                      </a:rPr>
+                      <m:t>≈</m:t>
+                    </m:r>
+                    <m:rad>
+                      <m:radPr>
+                        <m:degHide m:val="on"/>
+                        <m:ctrlPr>
+                          <a:rPr lang="en-US" sz="2000" b="0" i="1" smtClean="0">
+                            <a:latin typeface="Cambria Math" panose="02040503050406030204" pitchFamily="18" charset="0"/>
+                            <a:ea typeface="Cambria Math" panose="02040503050406030204" pitchFamily="18" charset="0"/>
+                          </a:rPr>
+                        </m:ctrlPr>
+                      </m:radPr>
+                      <m:deg/>
+                      <m:e>
+                        <m:r>
+                          <a:rPr lang="en-US" sz="2000" b="0" i="1" smtClean="0">
+                            <a:latin typeface="Cambria Math" panose="02040503050406030204" pitchFamily="18" charset="0"/>
+                            <a:ea typeface="Cambria Math" panose="02040503050406030204" pitchFamily="18" charset="0"/>
+                          </a:rPr>
+                          <m:t>𝑝</m:t>
+                        </m:r>
+                      </m:e>
+                    </m:rad>
+                  </m:oMath>
+                </a14:m>
+                <a:r>
+                  <a:rPr lang="en-US" sz="2000" dirty="0">
+                    <a:latin typeface="+mj-lt"/>
+                  </a:rPr>
+                  <a:t>) predictors is chosen as split candidates from the full set of </a:t>
+                </a:r>
+                <a:r>
+                  <a:rPr lang="en-US" sz="2000" i="1" dirty="0">
+                    <a:latin typeface="+mj-lt"/>
+                  </a:rPr>
+                  <a:t>p</a:t>
+                </a:r>
+                <a:r>
+                  <a:rPr lang="en-US" sz="2000" dirty="0">
+                    <a:latin typeface="+mj-lt"/>
+                  </a:rPr>
+                  <a:t> predictors. </a:t>
+                </a:r>
+                <a:r>
+                  <a:rPr lang="en-US" sz="2000" b="1" dirty="0">
+                    <a:latin typeface="+mj-lt"/>
+                  </a:rPr>
+                  <a:t>The split is allowed to use only one of those </a:t>
+                </a:r>
+                <a:r>
+                  <a:rPr lang="en-US" sz="2000" b="1" i="1" dirty="0">
+                    <a:latin typeface="+mj-lt"/>
+                  </a:rPr>
+                  <a:t>m</a:t>
+                </a:r>
+                <a:r>
+                  <a:rPr lang="en-US" sz="2000" b="1" dirty="0">
+                    <a:latin typeface="+mj-lt"/>
+                  </a:rPr>
+                  <a:t> predictors</a:t>
+                </a:r>
+              </a:p>
+              <a:p>
+                <a:pPr>
+                  <a:lnSpc>
+                    <a:spcPct val="150000"/>
+                  </a:lnSpc>
+                  <a:buFont typeface="Wingdings" panose="05000000000000000000" pitchFamily="2" charset="2"/>
+                  <a:buChar char="§"/>
+                </a:pPr>
+                <a:r>
+                  <a:rPr lang="en-US" sz="2000" dirty="0">
+                    <a:latin typeface="+mj-lt"/>
+                  </a:rPr>
+                  <a:t>The rationale is that, if there is a very strong predictor most of the trees will use it in the top split. So, all bagged trees will look similar, and the predictions will be highly correlated</a:t>
+                </a:r>
+              </a:p>
+              <a:p>
+                <a:pPr>
+                  <a:lnSpc>
+                    <a:spcPct val="150000"/>
+                  </a:lnSpc>
+                  <a:buFont typeface="Wingdings" panose="05000000000000000000" pitchFamily="2" charset="2"/>
+                  <a:buChar char="§"/>
+                </a:pPr>
+                <a:r>
+                  <a:rPr lang="en-US" sz="2000" dirty="0">
+                    <a:latin typeface="+mj-lt"/>
+                  </a:rPr>
+                  <a:t>Additionally, it is easy in RF to measure the relative importance of each feature. It is done by evaluating how much the use of a feature in a tree node reduces impurity on average (across all trees in the forest). </a:t>
+                </a:r>
+              </a:p>
+            </p:txBody>
+          </p:sp>
+        </mc:Choice>
+        <mc:Fallback>
+          <p:sp>
+            <p:nvSpPr>
+              <p:cNvPr id="3" name="Content Placeholder 2">
+                <a:extLst>
+                  <a:ext uri="{FF2B5EF4-FFF2-40B4-BE49-F238E27FC236}">
+                    <a16:creationId xmlns:a16="http://schemas.microsoft.com/office/drawing/2014/main" id="{068F0C39-44FF-99B2-7103-C6D38F774B5B}"/>
+                  </a:ext>
+                </a:extLst>
+              </p:cNvPr>
+              <p:cNvSpPr>
+                <a:spLocks noGrp="1" noRot="1" noChangeAspect="1" noMove="1" noResize="1" noEditPoints="1" noAdjustHandles="1" noChangeArrowheads="1" noChangeShapeType="1" noTextEdit="1"/>
+              </p:cNvSpPr>
+              <p:nvPr>
+                <p:ph idx="1"/>
+              </p:nvPr>
+            </p:nvSpPr>
+            <p:spPr>
+              <a:xfrm>
+                <a:off x="844778" y="1819047"/>
+                <a:ext cx="10515600" cy="4351338"/>
+              </a:xfrm>
+              <a:blipFill>
+                <a:blip r:embed="rId2"/>
+                <a:stretch>
+                  <a:fillRect l="-522"/>
+                </a:stretch>
+              </a:blipFill>
+            </p:spPr>
+            <p:txBody>
+              <a:bodyPr/>
+              <a:lstStyle/>
+              <a:p>
+                <a:r>
+                  <a:rPr lang="en-US">
+                    <a:noFill/>
+                  </a:rPr>
+                  <a:t> </a:t>
+                </a:r>
+              </a:p>
+            </p:txBody>
+          </p:sp>
+        </mc:Fallback>
+      </mc:AlternateContent>
+      <p:sp>
+        <p:nvSpPr>
+          <p:cNvPr id="4" name="Rectángulo 3">
+            <a:extLst>
+              <a:ext uri="{FF2B5EF4-FFF2-40B4-BE49-F238E27FC236}">
+                <a16:creationId xmlns:a16="http://schemas.microsoft.com/office/drawing/2014/main" id="{7BF95E35-4D9C-7F59-F308-C61FF9CD1B58}"/>
+              </a:ext>
+            </a:extLst>
+          </p:cNvPr>
+          <p:cNvSpPr/>
+          <p:nvPr/>
+        </p:nvSpPr>
+        <p:spPr>
+          <a:xfrm>
+            <a:off x="0" y="0"/>
+            <a:ext cx="374469" cy="6858000"/>
+          </a:xfrm>
+          <a:prstGeom prst="rect">
+            <a:avLst/>
+          </a:prstGeom>
+        </p:spPr>
+        <p:style>
+          <a:lnRef idx="2">
+            <a:schemeClr val="accent2">
+              <a:shade val="50000"/>
+            </a:schemeClr>
+          </a:lnRef>
+          <a:fillRef idx="1">
+            <a:schemeClr val="accent2"/>
+          </a:fillRef>
+          <a:effectRef idx="0">
+            <a:schemeClr val="accent2"/>
+          </a:effectRef>
+          <a:fontRef idx="minor">
+            <a:schemeClr val="lt1"/>
+          </a:fontRef>
+        </p:style>
+        <p:txBody>
+          <a:bodyPr rtlCol="0" anchor="ctr"/>
+          <a:lstStyle/>
+          <a:p>
+            <a:pPr algn="ctr"/>
+            <a:endParaRPr lang="es-ES"/>
+          </a:p>
+        </p:txBody>
+      </p:sp>
+      <p:sp>
+        <p:nvSpPr>
+          <p:cNvPr id="6" name="Rectangle 143">
+            <a:extLst>
+              <a:ext uri="{FF2B5EF4-FFF2-40B4-BE49-F238E27FC236}">
+                <a16:creationId xmlns:a16="http://schemas.microsoft.com/office/drawing/2014/main" id="{C9A975F5-C7DC-9274-20CA-B5939A2A86BD}"/>
+              </a:ext>
+            </a:extLst>
+          </p:cNvPr>
+          <p:cNvSpPr>
+            <a:spLocks noChangeArrowheads="1"/>
+          </p:cNvSpPr>
+          <p:nvPr/>
+        </p:nvSpPr>
+        <p:spPr bwMode="auto">
+          <a:xfrm>
+            <a:off x="448342" y="6549317"/>
+            <a:ext cx="5730175" cy="261610"/>
+          </a:xfrm>
+          <a:prstGeom prst="rect">
+            <a:avLst/>
+          </a:prstGeom>
+          <a:noFill/>
+          <a:ln>
+            <a:noFill/>
+          </a:ln>
+          <a:effectLst/>
+          <a:extLst>
+            <a:ext uri="{909E8E84-426E-40DD-AFC4-6F175D3DCCD1}">
+              <a14:hiddenFill xmlns:a14="http://schemas.microsoft.com/office/drawing/2010/main">
+                <a:solidFill>
+                  <a:schemeClr val="accent1"/>
+                </a:solidFill>
+              </a14:hiddenFill>
+            </a:ext>
+            <a:ext uri="{91240B29-F687-4F45-9708-019B960494DF}">
+              <a14:hiddenLine xmlns:a14="http://schemas.microsoft.com/office/drawing/2010/main" w="9525">
+                <a:solidFill>
+                  <a:schemeClr val="tx1"/>
+                </a:solidFill>
+                <a:miter lim="800000"/>
+                <a:headEnd/>
+                <a:tailEnd/>
+              </a14:hiddenLine>
+            </a:ext>
+            <a:ext uri="{AF507438-7753-43E0-B8FC-AC1667EBCBE1}">
+              <a14:hiddenEffects xmlns:a14="http://schemas.microsoft.com/office/drawing/2010/main">
+                <a:effectLst>
+                  <a:outerShdw dist="35921" dir="2700000" algn="ctr" rotWithShape="0">
+                    <a:schemeClr val="bg2"/>
+                  </a:outerShdw>
+                </a:effectLst>
+              </a14:hiddenEffects>
+            </a:ext>
+          </a:extLst>
+        </p:spPr>
+        <p:txBody>
+          <a:bodyPr vert="horz" wrap="square" lIns="91440" tIns="45720" rIns="91440" bIns="45720" numCol="1" anchor="ctr" anchorCtr="0" compatLnSpc="1">
+            <a:prstTxWarp prst="textNoShape">
+              <a:avLst/>
+            </a:prstTxWarp>
+            <a:spAutoFit/>
+          </a:bodyPr>
+          <a:lstStyle/>
+          <a:p>
+            <a:pPr marL="0" marR="0" lvl="0" indent="0" algn="l" defTabSz="914400" rtl="0" eaLnBrk="0" fontAlgn="base" latinLnBrk="0" hangingPunct="0">
+              <a:lnSpc>
+                <a:spcPct val="100000"/>
+              </a:lnSpc>
+              <a:spcBef>
+                <a:spcPct val="0"/>
+              </a:spcBef>
+              <a:spcAft>
+                <a:spcPct val="0"/>
+              </a:spcAft>
+              <a:buClrTx/>
+              <a:buSzTx/>
+              <a:buFontTx/>
+              <a:buNone/>
+              <a:tabLst/>
+            </a:pPr>
+            <a:r>
+              <a:rPr kumimoji="0" lang="en-US" altLang="es-ES" sz="1100" b="0" i="0" u="none" strike="noStrike" cap="none" normalizeH="0" baseline="0" dirty="0">
+                <a:ln>
+                  <a:noFill/>
+                </a:ln>
+                <a:solidFill>
+                  <a:srgbClr val="F4A200"/>
+                </a:solidFill>
+                <a:effectLst/>
+                <a:latin typeface="Arial" panose="020B0604020202020204" pitchFamily="34" charset="0"/>
+                <a:ea typeface="Myriad Pro Light"/>
+                <a:cs typeface="Times New Roman" panose="02020603050405020304" pitchFamily="18" charset="0"/>
+              </a:rPr>
+              <a:t>Master in Quantitative Economic Analysis </a:t>
+            </a:r>
+            <a:r>
+              <a:rPr kumimoji="0" lang="en-US" altLang="es-ES" sz="1100" b="0" i="0" u="none" strike="noStrike" cap="none" normalizeH="0" baseline="0" dirty="0" err="1">
+                <a:ln>
+                  <a:noFill/>
+                </a:ln>
+                <a:solidFill>
+                  <a:srgbClr val="F4A200"/>
+                </a:solidFill>
+                <a:effectLst/>
+                <a:latin typeface="Arial" panose="020B0604020202020204" pitchFamily="34" charset="0"/>
+                <a:ea typeface="Myriad Pro Light"/>
+                <a:cs typeface="Times New Roman" panose="02020603050405020304" pitchFamily="18" charset="0"/>
+              </a:rPr>
+              <a:t>MQuEA</a:t>
+            </a:r>
+            <a:endParaRPr kumimoji="0" lang="es-ES" altLang="es-ES" sz="300" b="0" i="0" u="none" strike="noStrike" cap="none" normalizeH="0" baseline="0" dirty="0">
+              <a:ln>
+                <a:noFill/>
+              </a:ln>
+              <a:solidFill>
+                <a:schemeClr val="tx1"/>
+              </a:solidFill>
+              <a:effectLst/>
+              <a:latin typeface="Arial" panose="020B0604020202020204" pitchFamily="34" charset="0"/>
+            </a:endParaRPr>
+          </a:p>
+        </p:txBody>
+      </p:sp>
+      <p:sp>
+        <p:nvSpPr>
+          <p:cNvPr id="7" name="Rectangle 143">
+            <a:extLst>
+              <a:ext uri="{FF2B5EF4-FFF2-40B4-BE49-F238E27FC236}">
+                <a16:creationId xmlns:a16="http://schemas.microsoft.com/office/drawing/2014/main" id="{2BE2E3EB-749E-E562-030D-C3F46E714169}"/>
+              </a:ext>
+            </a:extLst>
+          </p:cNvPr>
+          <p:cNvSpPr>
+            <a:spLocks noChangeArrowheads="1"/>
+          </p:cNvSpPr>
+          <p:nvPr/>
+        </p:nvSpPr>
+        <p:spPr bwMode="auto">
+          <a:xfrm>
+            <a:off x="6186394" y="6559955"/>
+            <a:ext cx="5730175" cy="261610"/>
+          </a:xfrm>
+          <a:prstGeom prst="rect">
+            <a:avLst/>
+          </a:prstGeom>
+          <a:noFill/>
+          <a:ln>
+            <a:noFill/>
+          </a:ln>
+          <a:effectLst/>
+          <a:extLst>
+            <a:ext uri="{909E8E84-426E-40DD-AFC4-6F175D3DCCD1}">
+              <a14:hiddenFill xmlns:a14="http://schemas.microsoft.com/office/drawing/2010/main">
+                <a:solidFill>
+                  <a:schemeClr val="accent1"/>
+                </a:solidFill>
+              </a14:hiddenFill>
+            </a:ext>
+            <a:ext uri="{91240B29-F687-4F45-9708-019B960494DF}">
+              <a14:hiddenLine xmlns:a14="http://schemas.microsoft.com/office/drawing/2010/main" w="9525">
+                <a:solidFill>
+                  <a:schemeClr val="tx1"/>
+                </a:solidFill>
+                <a:miter lim="800000"/>
+                <a:headEnd/>
+                <a:tailEnd/>
+              </a14:hiddenLine>
+            </a:ext>
+            <a:ext uri="{AF507438-7753-43E0-B8FC-AC1667EBCBE1}">
+              <a14:hiddenEffects xmlns:a14="http://schemas.microsoft.com/office/drawing/2010/main">
+                <a:effectLst>
+                  <a:outerShdw dist="35921" dir="2700000" algn="ctr" rotWithShape="0">
+                    <a:schemeClr val="bg2"/>
+                  </a:outerShdw>
+                </a:effectLst>
+              </a14:hiddenEffects>
+            </a:ext>
+          </a:extLst>
+        </p:spPr>
+        <p:txBody>
+          <a:bodyPr vert="horz" wrap="square" lIns="91440" tIns="45720" rIns="91440" bIns="45720" numCol="1" anchor="ctr" anchorCtr="0" compatLnSpc="1">
+            <a:prstTxWarp prst="textNoShape">
+              <a:avLst/>
+            </a:prstTxWarp>
+            <a:spAutoFit/>
+          </a:bodyPr>
+          <a:lstStyle/>
+          <a:p>
+            <a:pPr marL="0" marR="0" lvl="0" indent="0" algn="r" defTabSz="914400" rtl="0" eaLnBrk="0" fontAlgn="base" latinLnBrk="0" hangingPunct="0">
+              <a:lnSpc>
+                <a:spcPct val="100000"/>
+              </a:lnSpc>
+              <a:spcBef>
+                <a:spcPct val="0"/>
+              </a:spcBef>
+              <a:spcAft>
+                <a:spcPct val="0"/>
+              </a:spcAft>
+              <a:buClrTx/>
+              <a:buSzTx/>
+              <a:buFontTx/>
+              <a:buNone/>
+              <a:tabLst/>
+            </a:pPr>
+            <a:r>
+              <a:rPr kumimoji="0" lang="en-US" altLang="es-ES" sz="1100" b="0" i="0" u="none" strike="noStrike" cap="none" normalizeH="0" baseline="0" dirty="0">
+                <a:ln>
+                  <a:noFill/>
+                </a:ln>
+                <a:solidFill>
+                  <a:srgbClr val="F4A200"/>
+                </a:solidFill>
+                <a:effectLst/>
+                <a:latin typeface="Arial" panose="020B0604020202020204" pitchFamily="34" charset="0"/>
+                <a:ea typeface="Myriad Pro Light"/>
+                <a:cs typeface="Times New Roman" panose="02020603050405020304" pitchFamily="18" charset="0"/>
+              </a:rPr>
+              <a:t>Universidad </a:t>
+            </a:r>
+            <a:r>
+              <a:rPr kumimoji="0" lang="en-US" altLang="es-ES" sz="1100" b="0" i="0" u="none" strike="noStrike" cap="none" normalizeH="0" baseline="0" dirty="0" err="1">
+                <a:ln>
+                  <a:noFill/>
+                </a:ln>
+                <a:solidFill>
+                  <a:srgbClr val="F4A200"/>
+                </a:solidFill>
+                <a:effectLst/>
+                <a:latin typeface="Arial" panose="020B0604020202020204" pitchFamily="34" charset="0"/>
+                <a:ea typeface="Myriad Pro Light"/>
+                <a:cs typeface="Times New Roman" panose="02020603050405020304" pitchFamily="18" charset="0"/>
+              </a:rPr>
+              <a:t>Aut</a:t>
+            </a:r>
+            <a:r>
+              <a:rPr lang="en-US" altLang="es-ES" sz="1100" dirty="0" err="1">
+                <a:solidFill>
+                  <a:srgbClr val="F4A200"/>
+                </a:solidFill>
+                <a:latin typeface="Arial" panose="020B0604020202020204" pitchFamily="34" charset="0"/>
+                <a:ea typeface="Myriad Pro Light"/>
+                <a:cs typeface="Times New Roman" panose="02020603050405020304" pitchFamily="18" charset="0"/>
+              </a:rPr>
+              <a:t>ó</a:t>
+            </a:r>
+            <a:r>
+              <a:rPr kumimoji="0" lang="en-US" altLang="es-ES" sz="1100" b="0" i="0" u="none" strike="noStrike" cap="none" normalizeH="0" baseline="0" dirty="0" err="1">
+                <a:ln>
+                  <a:noFill/>
+                </a:ln>
+                <a:solidFill>
+                  <a:srgbClr val="F4A200"/>
+                </a:solidFill>
+                <a:effectLst/>
+                <a:latin typeface="Arial" panose="020B0604020202020204" pitchFamily="34" charset="0"/>
+                <a:ea typeface="Myriad Pro Light"/>
+                <a:cs typeface="Times New Roman" panose="02020603050405020304" pitchFamily="18" charset="0"/>
+              </a:rPr>
+              <a:t>noma</a:t>
+            </a:r>
+            <a:r>
+              <a:rPr kumimoji="0" lang="en-US" altLang="es-ES" sz="1100" b="0" i="0" u="none" strike="noStrike" cap="none" normalizeH="0" baseline="0" dirty="0">
+                <a:ln>
+                  <a:noFill/>
+                </a:ln>
+                <a:solidFill>
+                  <a:srgbClr val="F4A200"/>
+                </a:solidFill>
+                <a:effectLst/>
+                <a:latin typeface="Arial" panose="020B0604020202020204" pitchFamily="34" charset="0"/>
+                <a:ea typeface="Myriad Pro Light"/>
+                <a:cs typeface="Times New Roman" panose="02020603050405020304" pitchFamily="18" charset="0"/>
+              </a:rPr>
+              <a:t> de Madrid</a:t>
+            </a:r>
+            <a:endParaRPr kumimoji="0" lang="es-ES" altLang="es-ES" sz="300" b="0" i="0" u="none" strike="noStrike" cap="none" normalizeH="0" baseline="0" dirty="0">
+              <a:ln>
+                <a:noFill/>
+              </a:ln>
+              <a:solidFill>
+                <a:schemeClr val="tx1"/>
+              </a:solidFill>
+              <a:effectLst/>
+              <a:latin typeface="Arial" panose="020B0604020202020204" pitchFamily="34" charset="0"/>
+            </a:endParaRPr>
+          </a:p>
+        </p:txBody>
+      </p:sp>
+    </p:spTree>
+    <p:extLst>
+      <p:ext uri="{BB962C8B-B14F-4D97-AF65-F5344CB8AC3E}">
+        <p14:creationId xmlns:p14="http://schemas.microsoft.com/office/powerpoint/2010/main" val="3083369725"/>
+      </p:ext>
+    </p:extLst>
+  </p:cSld>
+  <p:clrMapOvr>
+    <a:masterClrMapping/>
+  </p:clrMapOvr>
+</p:sld>
+</file>
+
+<file path=ppt/slides/slide19.xml><?xml version="1.0" encoding="utf-8"?>
+<p:sld xmlns:a="http://schemas.openxmlformats.org/drawingml/2006/main" xmlns:r="http://schemas.openxmlformats.org/officeDocument/2006/relationships" xmlns:p="http://schemas.openxmlformats.org/presentationml/2006/main">
+  <p:cSld>
+    <p:spTree>
+      <p:nvGrpSpPr>
+        <p:cNvPr id="1" name=""/>
+        <p:cNvGrpSpPr/>
+        <p:nvPr/>
+      </p:nvGrpSpPr>
+      <p:grpSpPr>
+        <a:xfrm>
+          <a:off x="0" y="0"/>
+          <a:ext cx="0" cy="0"/>
+          <a:chOff x="0" y="0"/>
+          <a:chExt cx="0" cy="0"/>
+        </a:xfrm>
+      </p:grpSpPr>
+      <p:sp>
+        <p:nvSpPr>
+          <p:cNvPr id="2" name="Title 1">
+            <a:extLst>
+              <a:ext uri="{FF2B5EF4-FFF2-40B4-BE49-F238E27FC236}">
+                <a16:creationId xmlns:a16="http://schemas.microsoft.com/office/drawing/2014/main" id="{31C29F6F-54A2-5964-F2B2-982952460386}"/>
+              </a:ext>
+            </a:extLst>
+          </p:cNvPr>
+          <p:cNvSpPr>
+            <a:spLocks noGrp="1"/>
+          </p:cNvSpPr>
+          <p:nvPr>
+            <p:ph type="title"/>
+          </p:nvPr>
+        </p:nvSpPr>
+        <p:spPr/>
+        <p:txBody>
+          <a:bodyPr>
+            <a:normAutofit/>
+          </a:bodyPr>
+          <a:lstStyle/>
+          <a:p>
+            <a:r>
+              <a:rPr lang="en-US" sz="4000" dirty="0"/>
+              <a:t>Ensemble methods – Extremely </a:t>
+            </a:r>
+            <a:r>
+              <a:rPr lang="en-US" sz="4000" dirty="0" err="1"/>
+              <a:t>Radomized</a:t>
+            </a:r>
+            <a:r>
+              <a:rPr lang="en-US" sz="4000" dirty="0"/>
+              <a:t> Forests</a:t>
+            </a:r>
+          </a:p>
+        </p:txBody>
+      </p:sp>
+      <p:sp>
+        <p:nvSpPr>
+          <p:cNvPr id="3" name="Content Placeholder 2">
+            <a:extLst>
+              <a:ext uri="{FF2B5EF4-FFF2-40B4-BE49-F238E27FC236}">
+                <a16:creationId xmlns:a16="http://schemas.microsoft.com/office/drawing/2014/main" id="{068F0C39-44FF-99B2-7103-C6D38F774B5B}"/>
+              </a:ext>
+            </a:extLst>
+          </p:cNvPr>
+          <p:cNvSpPr>
+            <a:spLocks noGrp="1"/>
+          </p:cNvSpPr>
+          <p:nvPr>
+            <p:ph idx="1"/>
+          </p:nvPr>
+        </p:nvSpPr>
+        <p:spPr>
+          <a:xfrm>
+            <a:off x="844778" y="1819047"/>
+            <a:ext cx="10515600" cy="4351338"/>
+          </a:xfrm>
+        </p:spPr>
+        <p:txBody>
+          <a:bodyPr>
+            <a:normAutofit/>
+          </a:bodyPr>
+          <a:lstStyle/>
+          <a:p>
+            <a:pPr>
+              <a:lnSpc>
+                <a:spcPct val="150000"/>
+              </a:lnSpc>
+              <a:buFont typeface="Wingdings" panose="05000000000000000000" pitchFamily="2" charset="2"/>
+              <a:buChar char="§"/>
+            </a:pPr>
+            <a:r>
+              <a:rPr lang="en-US" sz="2000" dirty="0">
+                <a:latin typeface="+mj-lt"/>
+              </a:rPr>
+              <a:t>When growing a tree in a RF, at each node only a random subset of the features is considered for splitting. </a:t>
+            </a:r>
+          </a:p>
+          <a:p>
+            <a:pPr>
+              <a:lnSpc>
+                <a:spcPct val="150000"/>
+              </a:lnSpc>
+              <a:buFont typeface="Wingdings" panose="05000000000000000000" pitchFamily="2" charset="2"/>
+              <a:buChar char="§"/>
+            </a:pPr>
+            <a:r>
+              <a:rPr lang="en-US" sz="2000" dirty="0">
+                <a:latin typeface="+mj-lt"/>
+              </a:rPr>
+              <a:t>It is possible to make trees even more random by also using random thresholds for each feature (remember that splits are selected to minimize </a:t>
+            </a:r>
+            <a:r>
+              <a:rPr lang="en-US" sz="2000" dirty="0" err="1">
+                <a:latin typeface="+mj-lt"/>
+              </a:rPr>
+              <a:t>resids</a:t>
+            </a:r>
+            <a:r>
+              <a:rPr lang="en-US" sz="2000" dirty="0">
+                <a:latin typeface="+mj-lt"/>
+              </a:rPr>
+              <a:t>) rather than searching for the best possible thresholds. </a:t>
+            </a:r>
+          </a:p>
+          <a:p>
+            <a:pPr>
+              <a:lnSpc>
+                <a:spcPct val="150000"/>
+              </a:lnSpc>
+              <a:buFont typeface="Wingdings" panose="05000000000000000000" pitchFamily="2" charset="2"/>
+              <a:buChar char="§"/>
+            </a:pPr>
+            <a:r>
+              <a:rPr lang="en-US" sz="2000" dirty="0">
+                <a:latin typeface="+mj-lt"/>
+              </a:rPr>
+              <a:t>This technique trades more bias for lower variance and makes XRF faster to estimate.</a:t>
+            </a:r>
+          </a:p>
+        </p:txBody>
+      </p:sp>
+      <p:sp>
+        <p:nvSpPr>
+          <p:cNvPr id="4" name="Rectángulo 3">
+            <a:extLst>
+              <a:ext uri="{FF2B5EF4-FFF2-40B4-BE49-F238E27FC236}">
+                <a16:creationId xmlns:a16="http://schemas.microsoft.com/office/drawing/2014/main" id="{7BF95E35-4D9C-7F59-F308-C61FF9CD1B58}"/>
+              </a:ext>
+            </a:extLst>
+          </p:cNvPr>
+          <p:cNvSpPr/>
+          <p:nvPr/>
+        </p:nvSpPr>
+        <p:spPr>
+          <a:xfrm>
+            <a:off x="0" y="0"/>
+            <a:ext cx="374469" cy="6858000"/>
+          </a:xfrm>
+          <a:prstGeom prst="rect">
+            <a:avLst/>
+          </a:prstGeom>
+        </p:spPr>
+        <p:style>
+          <a:lnRef idx="2">
+            <a:schemeClr val="accent2">
+              <a:shade val="50000"/>
+            </a:schemeClr>
+          </a:lnRef>
+          <a:fillRef idx="1">
+            <a:schemeClr val="accent2"/>
+          </a:fillRef>
+          <a:effectRef idx="0">
+            <a:schemeClr val="accent2"/>
+          </a:effectRef>
+          <a:fontRef idx="minor">
+            <a:schemeClr val="lt1"/>
+          </a:fontRef>
+        </p:style>
+        <p:txBody>
+          <a:bodyPr rtlCol="0" anchor="ctr"/>
+          <a:lstStyle/>
+          <a:p>
+            <a:pPr algn="ctr"/>
+            <a:endParaRPr lang="es-ES"/>
+          </a:p>
+        </p:txBody>
+      </p:sp>
+      <p:sp>
+        <p:nvSpPr>
+          <p:cNvPr id="6" name="Rectangle 143">
+            <a:extLst>
+              <a:ext uri="{FF2B5EF4-FFF2-40B4-BE49-F238E27FC236}">
+                <a16:creationId xmlns:a16="http://schemas.microsoft.com/office/drawing/2014/main" id="{C9A975F5-C7DC-9274-20CA-B5939A2A86BD}"/>
+              </a:ext>
+            </a:extLst>
+          </p:cNvPr>
+          <p:cNvSpPr>
+            <a:spLocks noChangeArrowheads="1"/>
+          </p:cNvSpPr>
+          <p:nvPr/>
+        </p:nvSpPr>
+        <p:spPr bwMode="auto">
+          <a:xfrm>
+            <a:off x="448342" y="6549317"/>
+            <a:ext cx="5730175" cy="261610"/>
+          </a:xfrm>
+          <a:prstGeom prst="rect">
+            <a:avLst/>
+          </a:prstGeom>
+          <a:noFill/>
+          <a:ln>
+            <a:noFill/>
+          </a:ln>
+          <a:effectLst/>
+          <a:extLst>
+            <a:ext uri="{909E8E84-426E-40DD-AFC4-6F175D3DCCD1}">
+              <a14:hiddenFill xmlns:a14="http://schemas.microsoft.com/office/drawing/2010/main">
+                <a:solidFill>
+                  <a:schemeClr val="accent1"/>
+                </a:solidFill>
+              </a14:hiddenFill>
+            </a:ext>
+            <a:ext uri="{91240B29-F687-4F45-9708-019B960494DF}">
+              <a14:hiddenLine xmlns:a14="http://schemas.microsoft.com/office/drawing/2010/main" w="9525">
+                <a:solidFill>
+                  <a:schemeClr val="tx1"/>
+                </a:solidFill>
+                <a:miter lim="800000"/>
+                <a:headEnd/>
+                <a:tailEnd/>
+              </a14:hiddenLine>
+            </a:ext>
+            <a:ext uri="{AF507438-7753-43E0-B8FC-AC1667EBCBE1}">
+              <a14:hiddenEffects xmlns:a14="http://schemas.microsoft.com/office/drawing/2010/main">
+                <a:effectLst>
+                  <a:outerShdw dist="35921" dir="2700000" algn="ctr" rotWithShape="0">
+                    <a:schemeClr val="bg2"/>
+                  </a:outerShdw>
+                </a:effectLst>
+              </a14:hiddenEffects>
+            </a:ext>
+          </a:extLst>
+        </p:spPr>
+        <p:txBody>
+          <a:bodyPr vert="horz" wrap="square" lIns="91440" tIns="45720" rIns="91440" bIns="45720" numCol="1" anchor="ctr" anchorCtr="0" compatLnSpc="1">
+            <a:prstTxWarp prst="textNoShape">
+              <a:avLst/>
+            </a:prstTxWarp>
+            <a:spAutoFit/>
+          </a:bodyPr>
+          <a:lstStyle/>
+          <a:p>
+            <a:pPr marL="0" marR="0" lvl="0" indent="0" algn="l" defTabSz="914400" rtl="0" eaLnBrk="0" fontAlgn="base" latinLnBrk="0" hangingPunct="0">
+              <a:lnSpc>
+                <a:spcPct val="100000"/>
+              </a:lnSpc>
+              <a:spcBef>
+                <a:spcPct val="0"/>
+              </a:spcBef>
+              <a:spcAft>
+                <a:spcPct val="0"/>
+              </a:spcAft>
+              <a:buClrTx/>
+              <a:buSzTx/>
+              <a:buFontTx/>
+              <a:buNone/>
+              <a:tabLst/>
+            </a:pPr>
+            <a:r>
+              <a:rPr kumimoji="0" lang="en-US" altLang="es-ES" sz="1100" b="0" i="0" u="none" strike="noStrike" cap="none" normalizeH="0" baseline="0" dirty="0">
+                <a:ln>
+                  <a:noFill/>
+                </a:ln>
+                <a:solidFill>
+                  <a:srgbClr val="F4A200"/>
+                </a:solidFill>
+                <a:effectLst/>
+                <a:latin typeface="Arial" panose="020B0604020202020204" pitchFamily="34" charset="0"/>
+                <a:ea typeface="Myriad Pro Light"/>
+                <a:cs typeface="Times New Roman" panose="02020603050405020304" pitchFamily="18" charset="0"/>
+              </a:rPr>
+              <a:t>Master in Quantitative Economic Analysis </a:t>
+            </a:r>
+            <a:r>
+              <a:rPr kumimoji="0" lang="en-US" altLang="es-ES" sz="1100" b="0" i="0" u="none" strike="noStrike" cap="none" normalizeH="0" baseline="0" dirty="0" err="1">
+                <a:ln>
+                  <a:noFill/>
+                </a:ln>
+                <a:solidFill>
+                  <a:srgbClr val="F4A200"/>
+                </a:solidFill>
+                <a:effectLst/>
+                <a:latin typeface="Arial" panose="020B0604020202020204" pitchFamily="34" charset="0"/>
+                <a:ea typeface="Myriad Pro Light"/>
+                <a:cs typeface="Times New Roman" panose="02020603050405020304" pitchFamily="18" charset="0"/>
+              </a:rPr>
+              <a:t>MQuEA</a:t>
+            </a:r>
+            <a:endParaRPr kumimoji="0" lang="es-ES" altLang="es-ES" sz="300" b="0" i="0" u="none" strike="noStrike" cap="none" normalizeH="0" baseline="0" dirty="0">
+              <a:ln>
+                <a:noFill/>
+              </a:ln>
+              <a:solidFill>
+                <a:schemeClr val="tx1"/>
+              </a:solidFill>
+              <a:effectLst/>
+              <a:latin typeface="Arial" panose="020B0604020202020204" pitchFamily="34" charset="0"/>
+            </a:endParaRPr>
+          </a:p>
+        </p:txBody>
+      </p:sp>
+      <p:sp>
+        <p:nvSpPr>
+          <p:cNvPr id="7" name="Rectangle 143">
+            <a:extLst>
+              <a:ext uri="{FF2B5EF4-FFF2-40B4-BE49-F238E27FC236}">
+                <a16:creationId xmlns:a16="http://schemas.microsoft.com/office/drawing/2014/main" id="{2BE2E3EB-749E-E562-030D-C3F46E714169}"/>
+              </a:ext>
+            </a:extLst>
+          </p:cNvPr>
+          <p:cNvSpPr>
+            <a:spLocks noChangeArrowheads="1"/>
+          </p:cNvSpPr>
+          <p:nvPr/>
+        </p:nvSpPr>
+        <p:spPr bwMode="auto">
+          <a:xfrm>
+            <a:off x="6186394" y="6559955"/>
+            <a:ext cx="5730175" cy="261610"/>
+          </a:xfrm>
+          <a:prstGeom prst="rect">
+            <a:avLst/>
+          </a:prstGeom>
+          <a:noFill/>
+          <a:ln>
+            <a:noFill/>
+          </a:ln>
+          <a:effectLst/>
+          <a:extLst>
+            <a:ext uri="{909E8E84-426E-40DD-AFC4-6F175D3DCCD1}">
+              <a14:hiddenFill xmlns:a14="http://schemas.microsoft.com/office/drawing/2010/main">
+                <a:solidFill>
+                  <a:schemeClr val="accent1"/>
+                </a:solidFill>
+              </a14:hiddenFill>
+            </a:ext>
+            <a:ext uri="{91240B29-F687-4F45-9708-019B960494DF}">
+              <a14:hiddenLine xmlns:a14="http://schemas.microsoft.com/office/drawing/2010/main" w="9525">
+                <a:solidFill>
+                  <a:schemeClr val="tx1"/>
+                </a:solidFill>
+                <a:miter lim="800000"/>
+                <a:headEnd/>
+                <a:tailEnd/>
+              </a14:hiddenLine>
+            </a:ext>
+            <a:ext uri="{AF507438-7753-43E0-B8FC-AC1667EBCBE1}">
+              <a14:hiddenEffects xmlns:a14="http://schemas.microsoft.com/office/drawing/2010/main">
+                <a:effectLst>
+                  <a:outerShdw dist="35921" dir="2700000" algn="ctr" rotWithShape="0">
+                    <a:schemeClr val="bg2"/>
+                  </a:outerShdw>
+                </a:effectLst>
+              </a14:hiddenEffects>
+            </a:ext>
+          </a:extLst>
+        </p:spPr>
+        <p:txBody>
+          <a:bodyPr vert="horz" wrap="square" lIns="91440" tIns="45720" rIns="91440" bIns="45720" numCol="1" anchor="ctr" anchorCtr="0" compatLnSpc="1">
+            <a:prstTxWarp prst="textNoShape">
+              <a:avLst/>
+            </a:prstTxWarp>
+            <a:spAutoFit/>
+          </a:bodyPr>
+          <a:lstStyle/>
+          <a:p>
+            <a:pPr marL="0" marR="0" lvl="0" indent="0" algn="r" defTabSz="914400" rtl="0" eaLnBrk="0" fontAlgn="base" latinLnBrk="0" hangingPunct="0">
+              <a:lnSpc>
+                <a:spcPct val="100000"/>
+              </a:lnSpc>
+              <a:spcBef>
+                <a:spcPct val="0"/>
+              </a:spcBef>
+              <a:spcAft>
+                <a:spcPct val="0"/>
+              </a:spcAft>
+              <a:buClrTx/>
+              <a:buSzTx/>
+              <a:buFontTx/>
+              <a:buNone/>
+              <a:tabLst/>
+            </a:pPr>
+            <a:r>
+              <a:rPr kumimoji="0" lang="en-US" altLang="es-ES" sz="1100" b="0" i="0" u="none" strike="noStrike" cap="none" normalizeH="0" baseline="0" dirty="0">
+                <a:ln>
+                  <a:noFill/>
+                </a:ln>
+                <a:solidFill>
+                  <a:srgbClr val="F4A200"/>
+                </a:solidFill>
+                <a:effectLst/>
+                <a:latin typeface="Arial" panose="020B0604020202020204" pitchFamily="34" charset="0"/>
+                <a:ea typeface="Myriad Pro Light"/>
+                <a:cs typeface="Times New Roman" panose="02020603050405020304" pitchFamily="18" charset="0"/>
+              </a:rPr>
+              <a:t>Universidad </a:t>
+            </a:r>
+            <a:r>
+              <a:rPr kumimoji="0" lang="en-US" altLang="es-ES" sz="1100" b="0" i="0" u="none" strike="noStrike" cap="none" normalizeH="0" baseline="0" dirty="0" err="1">
+                <a:ln>
+                  <a:noFill/>
+                </a:ln>
+                <a:solidFill>
+                  <a:srgbClr val="F4A200"/>
+                </a:solidFill>
+                <a:effectLst/>
+                <a:latin typeface="Arial" panose="020B0604020202020204" pitchFamily="34" charset="0"/>
+                <a:ea typeface="Myriad Pro Light"/>
+                <a:cs typeface="Times New Roman" panose="02020603050405020304" pitchFamily="18" charset="0"/>
+              </a:rPr>
+              <a:t>Aut</a:t>
+            </a:r>
+            <a:r>
+              <a:rPr lang="en-US" altLang="es-ES" sz="1100" dirty="0" err="1">
+                <a:solidFill>
+                  <a:srgbClr val="F4A200"/>
+                </a:solidFill>
+                <a:latin typeface="Arial" panose="020B0604020202020204" pitchFamily="34" charset="0"/>
+                <a:ea typeface="Myriad Pro Light"/>
+                <a:cs typeface="Times New Roman" panose="02020603050405020304" pitchFamily="18" charset="0"/>
+              </a:rPr>
+              <a:t>ó</a:t>
+            </a:r>
+            <a:r>
+              <a:rPr kumimoji="0" lang="en-US" altLang="es-ES" sz="1100" b="0" i="0" u="none" strike="noStrike" cap="none" normalizeH="0" baseline="0" dirty="0" err="1">
+                <a:ln>
+                  <a:noFill/>
+                </a:ln>
+                <a:solidFill>
+                  <a:srgbClr val="F4A200"/>
+                </a:solidFill>
+                <a:effectLst/>
+                <a:latin typeface="Arial" panose="020B0604020202020204" pitchFamily="34" charset="0"/>
+                <a:ea typeface="Myriad Pro Light"/>
+                <a:cs typeface="Times New Roman" panose="02020603050405020304" pitchFamily="18" charset="0"/>
+              </a:rPr>
+              <a:t>noma</a:t>
+            </a:r>
+            <a:r>
+              <a:rPr kumimoji="0" lang="en-US" altLang="es-ES" sz="1100" b="0" i="0" u="none" strike="noStrike" cap="none" normalizeH="0" baseline="0" dirty="0">
+                <a:ln>
+                  <a:noFill/>
+                </a:ln>
+                <a:solidFill>
+                  <a:srgbClr val="F4A200"/>
+                </a:solidFill>
+                <a:effectLst/>
+                <a:latin typeface="Arial" panose="020B0604020202020204" pitchFamily="34" charset="0"/>
+                <a:ea typeface="Myriad Pro Light"/>
+                <a:cs typeface="Times New Roman" panose="02020603050405020304" pitchFamily="18" charset="0"/>
+              </a:rPr>
+              <a:t> de Madrid</a:t>
+            </a:r>
+            <a:endParaRPr kumimoji="0" lang="es-ES" altLang="es-ES" sz="300" b="0" i="0" u="none" strike="noStrike" cap="none" normalizeH="0" baseline="0" dirty="0">
+              <a:ln>
+                <a:noFill/>
+              </a:ln>
+              <a:solidFill>
+                <a:schemeClr val="tx1"/>
+              </a:solidFill>
+              <a:effectLst/>
+              <a:latin typeface="Arial" panose="020B0604020202020204" pitchFamily="34" charset="0"/>
+            </a:endParaRPr>
+          </a:p>
+        </p:txBody>
+      </p:sp>
+    </p:spTree>
+    <p:extLst>
+      <p:ext uri="{BB962C8B-B14F-4D97-AF65-F5344CB8AC3E}">
+        <p14:creationId xmlns:p14="http://schemas.microsoft.com/office/powerpoint/2010/main" val="3065630727"/>
+      </p:ext>
+    </p:extLst>
+  </p:cSld>
+  <p:clrMapOvr>
+    <a:masterClrMapping/>
+  </p:clrMapOvr>
+</p:sld>
+</file>
+
 <file path=ppt/slides/slide2.xml><?xml version="1.0" encoding="utf-8"?>
 <p:sld xmlns:a="http://schemas.openxmlformats.org/drawingml/2006/main" xmlns:r="http://schemas.openxmlformats.org/officeDocument/2006/relationships" xmlns:p="http://schemas.openxmlformats.org/presentationml/2006/main">
   <p:cSld>
@@ -24527,7 +28271,7 @@
         </p:spPr>
         <p:txBody>
           <a:bodyPr vert="horz" lIns="91440" tIns="45720" rIns="91440" bIns="45720" rtlCol="0">
-            <a:normAutofit fontScale="77500" lnSpcReduction="20000"/>
+            <a:normAutofit fontScale="92500" lnSpcReduction="10000"/>
           </a:bodyPr>
           <a:lstStyle>
             <a:lvl1pPr marL="0" indent="0" algn="ctr" defTabSz="914400" rtl="0" eaLnBrk="1" latinLnBrk="0" hangingPunct="1">
@@ -24738,34 +28482,7 @@
                 <a:latin typeface="+mj-lt"/>
                 <a:cs typeface="Times New Roman" panose="02020603050405020304" pitchFamily="18" charset="0"/>
               </a:rPr>
-              <a:t>Decision </a:t>
-            </a:r>
-            <a:r>
-              <a:rPr lang="en-US" sz="2400">
-                <a:latin typeface="+mj-lt"/>
-                <a:cs typeface="Times New Roman" panose="02020603050405020304" pitchFamily="18" charset="0"/>
-              </a:rPr>
-              <a:t>trees classification</a:t>
-            </a:r>
-            <a:endParaRPr lang="en-US" sz="2400" dirty="0">
-              <a:latin typeface="+mj-lt"/>
-              <a:cs typeface="Times New Roman" panose="02020603050405020304" pitchFamily="18" charset="0"/>
-            </a:endParaRPr>
-          </a:p>
-          <a:p>
-            <a:pPr marL="914400" lvl="1" indent="-457200" algn="l">
-              <a:lnSpc>
-                <a:spcPct val="100000"/>
-              </a:lnSpc>
-              <a:buFont typeface="Wingdings" panose="05000000000000000000" pitchFamily="2" charset="2"/>
-              <a:buChar char="§"/>
-            </a:pPr>
-            <a:r>
-              <a:rPr lang="en-US" sz="2400" dirty="0">
-                <a:latin typeface="+mj-lt"/>
-                <a:cs typeface="Times New Roman" panose="02020603050405020304" pitchFamily="18" charset="0"/>
-              </a:rPr>
-              <a:t>Training and the CART algorithm</a:t>
+              <a:t>Decision trees classification</a:t>
             </a:r>
           </a:p>
           <a:p>
@@ -24797,23 +28514,7 @@
                 <a:latin typeface="+mj-lt"/>
                 <a:cs typeface="Times New Roman" panose="02020603050405020304" pitchFamily="18" charset="0"/>
               </a:rPr>
-              <a:t>Regression</a:t>
-            </a:r>
-          </a:p>
-          <a:p>
-            <a:pPr marL="914400" lvl="1" indent="-457200" algn="l">
-              <a:lnSpc>
-                <a:spcPct val="100000"/>
-              </a:lnSpc>
-              <a:buFont typeface="Wingdings" panose="05000000000000000000" pitchFamily="2" charset="2"/>
-              <a:buChar char="§"/>
-            </a:pPr>
-            <a:r>
-              <a:rPr lang="en-US" sz="2400" dirty="0">
-                <a:latin typeface="+mj-lt"/>
-                <a:cs typeface="Times New Roman" panose="02020603050405020304" pitchFamily="18" charset="0"/>
-              </a:rPr>
-              <a:t>Instability</a:t>
+              <a:t>Trees vs. Linear models</a:t>
             </a:r>
           </a:p>
           <a:p>
@@ -24910,22 +28611,6 @@
                 <a:cs typeface="Times New Roman" panose="02020603050405020304" pitchFamily="18" charset="0"/>
               </a:rPr>
               <a:t>Boosting</a:t>
-            </a:r>
-          </a:p>
-          <a:p>
-            <a:pPr marL="914400" lvl="1" indent="-457200" algn="l">
-              <a:lnSpc>
-                <a:spcPct val="100000"/>
-              </a:lnSpc>
-              <a:buFont typeface="Wingdings" panose="05000000000000000000" pitchFamily="2" charset="2"/>
-              <a:buChar char="§"/>
-            </a:pPr>
-            <a:r>
-              <a:rPr lang="en-US" sz="2400" dirty="0">
-                <a:latin typeface="+mj-lt"/>
-                <a:cs typeface="Times New Roman" panose="02020603050405020304" pitchFamily="18" charset="0"/>
-              </a:rPr>
-              <a:t>Stacking</a:t>
             </a:r>
           </a:p>
         </p:txBody>
@@ -25278,6 +28963,577 @@
     <p:extLst>
       <p:ext uri="{BB962C8B-B14F-4D97-AF65-F5344CB8AC3E}">
         <p14:creationId xmlns:p14="http://schemas.microsoft.com/office/powerpoint/2010/main" val="3676436470"/>
+      </p:ext>
+    </p:extLst>
+  </p:cSld>
+  <p:clrMapOvr>
+    <a:masterClrMapping/>
+  </p:clrMapOvr>
+</p:sld>
+</file>
+
+<file path=ppt/slides/slide20.xml><?xml version="1.0" encoding="utf-8"?>
+<p:sld xmlns:a="http://schemas.openxmlformats.org/drawingml/2006/main" xmlns:r="http://schemas.openxmlformats.org/officeDocument/2006/relationships" xmlns:p="http://schemas.openxmlformats.org/presentationml/2006/main">
+  <p:cSld>
+    <p:spTree>
+      <p:nvGrpSpPr>
+        <p:cNvPr id="1" name=""/>
+        <p:cNvGrpSpPr/>
+        <p:nvPr/>
+      </p:nvGrpSpPr>
+      <p:grpSpPr>
+        <a:xfrm>
+          <a:off x="0" y="0"/>
+          <a:ext cx="0" cy="0"/>
+          <a:chOff x="0" y="0"/>
+          <a:chExt cx="0" cy="0"/>
+        </a:xfrm>
+      </p:grpSpPr>
+      <p:sp>
+        <p:nvSpPr>
+          <p:cNvPr id="2" name="Title 1">
+            <a:extLst>
+              <a:ext uri="{FF2B5EF4-FFF2-40B4-BE49-F238E27FC236}">
+                <a16:creationId xmlns:a16="http://schemas.microsoft.com/office/drawing/2014/main" id="{31C29F6F-54A2-5964-F2B2-982952460386}"/>
+              </a:ext>
+            </a:extLst>
+          </p:cNvPr>
+          <p:cNvSpPr>
+            <a:spLocks noGrp="1"/>
+          </p:cNvSpPr>
+          <p:nvPr>
+            <p:ph type="title"/>
+          </p:nvPr>
+        </p:nvSpPr>
+        <p:spPr/>
+        <p:txBody>
+          <a:bodyPr>
+            <a:normAutofit/>
+          </a:bodyPr>
+          <a:lstStyle/>
+          <a:p>
+            <a:r>
+              <a:rPr lang="en-US" sz="4000" dirty="0"/>
+              <a:t>Ensemble methods – Boosting</a:t>
+            </a:r>
+          </a:p>
+        </p:txBody>
+      </p:sp>
+      <p:sp>
+        <p:nvSpPr>
+          <p:cNvPr id="3" name="Content Placeholder 2">
+            <a:extLst>
+              <a:ext uri="{FF2B5EF4-FFF2-40B4-BE49-F238E27FC236}">
+                <a16:creationId xmlns:a16="http://schemas.microsoft.com/office/drawing/2014/main" id="{068F0C39-44FF-99B2-7103-C6D38F774B5B}"/>
+              </a:ext>
+            </a:extLst>
+          </p:cNvPr>
+          <p:cNvSpPr>
+            <a:spLocks noGrp="1"/>
+          </p:cNvSpPr>
+          <p:nvPr>
+            <p:ph idx="1"/>
+          </p:nvPr>
+        </p:nvSpPr>
+        <p:spPr>
+          <a:xfrm>
+            <a:off x="844778" y="1819047"/>
+            <a:ext cx="10515600" cy="4351338"/>
+          </a:xfrm>
+        </p:spPr>
+        <p:txBody>
+          <a:bodyPr>
+            <a:normAutofit/>
+          </a:bodyPr>
+          <a:lstStyle/>
+          <a:p>
+            <a:pPr>
+              <a:lnSpc>
+                <a:spcPct val="150000"/>
+              </a:lnSpc>
+              <a:buFont typeface="Wingdings" panose="05000000000000000000" pitchFamily="2" charset="2"/>
+              <a:buChar char="§"/>
+            </a:pPr>
+            <a:r>
+              <a:rPr lang="en-US" sz="2000" i="1" dirty="0">
+                <a:latin typeface="+mj-lt"/>
+              </a:rPr>
+              <a:t>Boosting</a:t>
+            </a:r>
+            <a:r>
+              <a:rPr lang="en-US" sz="2000" dirty="0">
+                <a:latin typeface="+mj-lt"/>
+              </a:rPr>
+              <a:t> works in a similar way than </a:t>
+            </a:r>
+            <a:r>
+              <a:rPr lang="en-US" sz="2000" i="1" dirty="0">
+                <a:latin typeface="+mj-lt"/>
+              </a:rPr>
+              <a:t>Bagging, </a:t>
+            </a:r>
+            <a:r>
+              <a:rPr lang="en-US" sz="2000" dirty="0">
+                <a:latin typeface="+mj-lt"/>
+              </a:rPr>
+              <a:t>but the </a:t>
+            </a:r>
+            <a:r>
+              <a:rPr lang="en-US" sz="2000" b="1" dirty="0">
+                <a:latin typeface="+mj-lt"/>
+              </a:rPr>
+              <a:t>trees are grown sequentially</a:t>
+            </a:r>
+            <a:r>
+              <a:rPr lang="en-US" sz="2000" dirty="0">
+                <a:latin typeface="+mj-lt"/>
+              </a:rPr>
+              <a:t>: each tree is built using information from previously grown trees</a:t>
+            </a:r>
+          </a:p>
+          <a:p>
+            <a:pPr>
+              <a:lnSpc>
+                <a:spcPct val="150000"/>
+              </a:lnSpc>
+              <a:buFont typeface="Wingdings" panose="05000000000000000000" pitchFamily="2" charset="2"/>
+              <a:buChar char="§"/>
+            </a:pPr>
+            <a:r>
+              <a:rPr lang="en-US" sz="2000" dirty="0">
+                <a:latin typeface="+mj-lt"/>
+              </a:rPr>
+              <a:t>Boosting does not involve bootstrap sampling; instead, each tree is fit on a modified version of the original dataset, trying to improve it</a:t>
+            </a:r>
+          </a:p>
+          <a:p>
+            <a:pPr>
+              <a:lnSpc>
+                <a:spcPct val="150000"/>
+              </a:lnSpc>
+              <a:buFont typeface="Wingdings" panose="05000000000000000000" pitchFamily="2" charset="2"/>
+              <a:buChar char="§"/>
+            </a:pPr>
+            <a:r>
+              <a:rPr lang="en-US" sz="2000" b="1" i="1" dirty="0" err="1">
+                <a:latin typeface="+mj-lt"/>
+              </a:rPr>
+              <a:t>Adaboost</a:t>
+            </a:r>
+            <a:r>
+              <a:rPr lang="en-US" sz="2000" b="1" i="1" dirty="0">
+                <a:latin typeface="+mj-lt"/>
+              </a:rPr>
+              <a:t> </a:t>
+            </a:r>
+            <a:r>
+              <a:rPr lang="en-US" sz="2000" dirty="0">
+                <a:latin typeface="+mj-lt"/>
+              </a:rPr>
+              <a:t>and</a:t>
+            </a:r>
+            <a:r>
+              <a:rPr lang="en-US" sz="2000" b="1" i="1" dirty="0">
+                <a:latin typeface="+mj-lt"/>
+              </a:rPr>
+              <a:t> Gradient Boosting </a:t>
+            </a:r>
+            <a:r>
+              <a:rPr lang="en-US" sz="2000" dirty="0">
+                <a:latin typeface="+mj-lt"/>
+              </a:rPr>
+              <a:t>are the most popular boosting methods</a:t>
+            </a:r>
+          </a:p>
+          <a:p>
+            <a:pPr lvl="1">
+              <a:lnSpc>
+                <a:spcPct val="150000"/>
+              </a:lnSpc>
+              <a:buFont typeface="Wingdings" panose="05000000000000000000" pitchFamily="2" charset="2"/>
+              <a:buChar char="§"/>
+            </a:pPr>
+            <a:r>
+              <a:rPr lang="en-US" sz="1600" dirty="0" err="1">
+                <a:latin typeface="+mj-lt"/>
+              </a:rPr>
+              <a:t>Adaboost</a:t>
+            </a:r>
+            <a:r>
+              <a:rPr lang="en-US" sz="1600" dirty="0">
+                <a:latin typeface="+mj-lt"/>
+              </a:rPr>
+              <a:t>: A first model is trained and used to make predictions. Then the relative weight of misclassified training instances is increased, to train a second classifier using the updated weights… and so on</a:t>
+            </a:r>
+          </a:p>
+          <a:p>
+            <a:pPr lvl="1">
+              <a:lnSpc>
+                <a:spcPct val="150000"/>
+              </a:lnSpc>
+              <a:buFont typeface="Wingdings" panose="05000000000000000000" pitchFamily="2" charset="2"/>
+              <a:buChar char="§"/>
+            </a:pPr>
+            <a:r>
+              <a:rPr lang="en-US" sz="1600" dirty="0">
+                <a:latin typeface="+mj-lt"/>
+              </a:rPr>
+              <a:t>Gradient boosting: Instead of tweaking the instance weights at every iteration, this method fits the new tree to the residual errors made by the previous tree</a:t>
+            </a:r>
+          </a:p>
+          <a:p>
+            <a:pPr>
+              <a:lnSpc>
+                <a:spcPct val="150000"/>
+              </a:lnSpc>
+              <a:buFont typeface="Wingdings" panose="05000000000000000000" pitchFamily="2" charset="2"/>
+              <a:buChar char="§"/>
+            </a:pPr>
+            <a:endParaRPr lang="en-US" sz="2000" dirty="0">
+              <a:latin typeface="+mj-lt"/>
+            </a:endParaRPr>
+          </a:p>
+        </p:txBody>
+      </p:sp>
+      <p:sp>
+        <p:nvSpPr>
+          <p:cNvPr id="4" name="Rectángulo 3">
+            <a:extLst>
+              <a:ext uri="{FF2B5EF4-FFF2-40B4-BE49-F238E27FC236}">
+                <a16:creationId xmlns:a16="http://schemas.microsoft.com/office/drawing/2014/main" id="{7BF95E35-4D9C-7F59-F308-C61FF9CD1B58}"/>
+              </a:ext>
+            </a:extLst>
+          </p:cNvPr>
+          <p:cNvSpPr/>
+          <p:nvPr/>
+        </p:nvSpPr>
+        <p:spPr>
+          <a:xfrm>
+            <a:off x="0" y="0"/>
+            <a:ext cx="374469" cy="6858000"/>
+          </a:xfrm>
+          <a:prstGeom prst="rect">
+            <a:avLst/>
+          </a:prstGeom>
+        </p:spPr>
+        <p:style>
+          <a:lnRef idx="2">
+            <a:schemeClr val="accent2">
+              <a:shade val="50000"/>
+            </a:schemeClr>
+          </a:lnRef>
+          <a:fillRef idx="1">
+            <a:schemeClr val="accent2"/>
+          </a:fillRef>
+          <a:effectRef idx="0">
+            <a:schemeClr val="accent2"/>
+          </a:effectRef>
+          <a:fontRef idx="minor">
+            <a:schemeClr val="lt1"/>
+          </a:fontRef>
+        </p:style>
+        <p:txBody>
+          <a:bodyPr rtlCol="0" anchor="ctr"/>
+          <a:lstStyle/>
+          <a:p>
+            <a:pPr algn="ctr"/>
+            <a:endParaRPr lang="es-ES"/>
+          </a:p>
+        </p:txBody>
+      </p:sp>
+      <p:sp>
+        <p:nvSpPr>
+          <p:cNvPr id="6" name="Rectangle 143">
+            <a:extLst>
+              <a:ext uri="{FF2B5EF4-FFF2-40B4-BE49-F238E27FC236}">
+                <a16:creationId xmlns:a16="http://schemas.microsoft.com/office/drawing/2014/main" id="{C9A975F5-C7DC-9274-20CA-B5939A2A86BD}"/>
+              </a:ext>
+            </a:extLst>
+          </p:cNvPr>
+          <p:cNvSpPr>
+            <a:spLocks noChangeArrowheads="1"/>
+          </p:cNvSpPr>
+          <p:nvPr/>
+        </p:nvSpPr>
+        <p:spPr bwMode="auto">
+          <a:xfrm>
+            <a:off x="448342" y="6549317"/>
+            <a:ext cx="5730175" cy="261610"/>
+          </a:xfrm>
+          <a:prstGeom prst="rect">
+            <a:avLst/>
+          </a:prstGeom>
+          <a:noFill/>
+          <a:ln>
+            <a:noFill/>
+          </a:ln>
+          <a:effectLst/>
+          <a:extLst>
+            <a:ext uri="{909E8E84-426E-40DD-AFC4-6F175D3DCCD1}">
+              <a14:hiddenFill xmlns:a14="http://schemas.microsoft.com/office/drawing/2010/main">
+                <a:solidFill>
+                  <a:schemeClr val="accent1"/>
+                </a:solidFill>
+              </a14:hiddenFill>
+            </a:ext>
+            <a:ext uri="{91240B29-F687-4F45-9708-019B960494DF}">
+              <a14:hiddenLine xmlns:a14="http://schemas.microsoft.com/office/drawing/2010/main" w="9525">
+                <a:solidFill>
+                  <a:schemeClr val="tx1"/>
+                </a:solidFill>
+                <a:miter lim="800000"/>
+                <a:headEnd/>
+                <a:tailEnd/>
+              </a14:hiddenLine>
+            </a:ext>
+            <a:ext uri="{AF507438-7753-43E0-B8FC-AC1667EBCBE1}">
+              <a14:hiddenEffects xmlns:a14="http://schemas.microsoft.com/office/drawing/2010/main">
+                <a:effectLst>
+                  <a:outerShdw dist="35921" dir="2700000" algn="ctr" rotWithShape="0">
+                    <a:schemeClr val="bg2"/>
+                  </a:outerShdw>
+                </a:effectLst>
+              </a14:hiddenEffects>
+            </a:ext>
+          </a:extLst>
+        </p:spPr>
+        <p:txBody>
+          <a:bodyPr vert="horz" wrap="square" lIns="91440" tIns="45720" rIns="91440" bIns="45720" numCol="1" anchor="ctr" anchorCtr="0" compatLnSpc="1">
+            <a:prstTxWarp prst="textNoShape">
+              <a:avLst/>
+            </a:prstTxWarp>
+            <a:spAutoFit/>
+          </a:bodyPr>
+          <a:lstStyle/>
+          <a:p>
+            <a:pPr marL="0" marR="0" lvl="0" indent="0" algn="l" defTabSz="914400" rtl="0" eaLnBrk="0" fontAlgn="base" latinLnBrk="0" hangingPunct="0">
+              <a:lnSpc>
+                <a:spcPct val="100000"/>
+              </a:lnSpc>
+              <a:spcBef>
+                <a:spcPct val="0"/>
+              </a:spcBef>
+              <a:spcAft>
+                <a:spcPct val="0"/>
+              </a:spcAft>
+              <a:buClrTx/>
+              <a:buSzTx/>
+              <a:buFontTx/>
+              <a:buNone/>
+              <a:tabLst/>
+            </a:pPr>
+            <a:r>
+              <a:rPr kumimoji="0" lang="en-US" altLang="es-ES" sz="1100" b="0" i="0" u="none" strike="noStrike" cap="none" normalizeH="0" baseline="0" dirty="0">
+                <a:ln>
+                  <a:noFill/>
+                </a:ln>
+                <a:solidFill>
+                  <a:srgbClr val="F4A200"/>
+                </a:solidFill>
+                <a:effectLst/>
+                <a:latin typeface="Arial" panose="020B0604020202020204" pitchFamily="34" charset="0"/>
+                <a:ea typeface="Myriad Pro Light"/>
+                <a:cs typeface="Times New Roman" panose="02020603050405020304" pitchFamily="18" charset="0"/>
+              </a:rPr>
+              <a:t>Master in Quantitative Economic Analysis </a:t>
+            </a:r>
+            <a:r>
+              <a:rPr kumimoji="0" lang="en-US" altLang="es-ES" sz="1100" b="0" i="0" u="none" strike="noStrike" cap="none" normalizeH="0" baseline="0" dirty="0" err="1">
+                <a:ln>
+                  <a:noFill/>
+                </a:ln>
+                <a:solidFill>
+                  <a:srgbClr val="F4A200"/>
+                </a:solidFill>
+                <a:effectLst/>
+                <a:latin typeface="Arial" panose="020B0604020202020204" pitchFamily="34" charset="0"/>
+                <a:ea typeface="Myriad Pro Light"/>
+                <a:cs typeface="Times New Roman" panose="02020603050405020304" pitchFamily="18" charset="0"/>
+              </a:rPr>
+              <a:t>MQuEA</a:t>
+            </a:r>
+            <a:endParaRPr kumimoji="0" lang="es-ES" altLang="es-ES" sz="300" b="0" i="0" u="none" strike="noStrike" cap="none" normalizeH="0" baseline="0" dirty="0">
+              <a:ln>
+                <a:noFill/>
+              </a:ln>
+              <a:solidFill>
+                <a:schemeClr val="tx1"/>
+              </a:solidFill>
+              <a:effectLst/>
+              <a:latin typeface="Arial" panose="020B0604020202020204" pitchFamily="34" charset="0"/>
+            </a:endParaRPr>
+          </a:p>
+        </p:txBody>
+      </p:sp>
+      <p:sp>
+        <p:nvSpPr>
+          <p:cNvPr id="7" name="Rectangle 143">
+            <a:extLst>
+              <a:ext uri="{FF2B5EF4-FFF2-40B4-BE49-F238E27FC236}">
+                <a16:creationId xmlns:a16="http://schemas.microsoft.com/office/drawing/2014/main" id="{2BE2E3EB-749E-E562-030D-C3F46E714169}"/>
+              </a:ext>
+            </a:extLst>
+          </p:cNvPr>
+          <p:cNvSpPr>
+            <a:spLocks noChangeArrowheads="1"/>
+          </p:cNvSpPr>
+          <p:nvPr/>
+        </p:nvSpPr>
+        <p:spPr bwMode="auto">
+          <a:xfrm>
+            <a:off x="6186394" y="6559955"/>
+            <a:ext cx="5730175" cy="261610"/>
+          </a:xfrm>
+          <a:prstGeom prst="rect">
+            <a:avLst/>
+          </a:prstGeom>
+          <a:noFill/>
+          <a:ln>
+            <a:noFill/>
+          </a:ln>
+          <a:effectLst/>
+          <a:extLst>
+            <a:ext uri="{909E8E84-426E-40DD-AFC4-6F175D3DCCD1}">
+              <a14:hiddenFill xmlns:a14="http://schemas.microsoft.com/office/drawing/2010/main">
+                <a:solidFill>
+                  <a:schemeClr val="accent1"/>
+                </a:solidFill>
+              </a14:hiddenFill>
+            </a:ext>
+            <a:ext uri="{91240B29-F687-4F45-9708-019B960494DF}">
+              <a14:hiddenLine xmlns:a14="http://schemas.microsoft.com/office/drawing/2010/main" w="9525">
+                <a:solidFill>
+                  <a:schemeClr val="tx1"/>
+                </a:solidFill>
+                <a:miter lim="800000"/>
+                <a:headEnd/>
+                <a:tailEnd/>
+              </a14:hiddenLine>
+            </a:ext>
+            <a:ext uri="{AF507438-7753-43E0-B8FC-AC1667EBCBE1}">
+              <a14:hiddenEffects xmlns:a14="http://schemas.microsoft.com/office/drawing/2010/main">
+                <a:effectLst>
+                  <a:outerShdw dist="35921" dir="2700000" algn="ctr" rotWithShape="0">
+                    <a:schemeClr val="bg2"/>
+                  </a:outerShdw>
+                </a:effectLst>
+              </a14:hiddenEffects>
+            </a:ext>
+          </a:extLst>
+        </p:spPr>
+        <p:txBody>
+          <a:bodyPr vert="horz" wrap="square" lIns="91440" tIns="45720" rIns="91440" bIns="45720" numCol="1" anchor="ctr" anchorCtr="0" compatLnSpc="1">
+            <a:prstTxWarp prst="textNoShape">
+              <a:avLst/>
+            </a:prstTxWarp>
+            <a:spAutoFit/>
+          </a:bodyPr>
+          <a:lstStyle/>
+          <a:p>
+            <a:pPr marL="0" marR="0" lvl="0" indent="0" algn="r" defTabSz="914400" rtl="0" eaLnBrk="0" fontAlgn="base" latinLnBrk="0" hangingPunct="0">
+              <a:lnSpc>
+                <a:spcPct val="100000"/>
+              </a:lnSpc>
+              <a:spcBef>
+                <a:spcPct val="0"/>
+              </a:spcBef>
+              <a:spcAft>
+                <a:spcPct val="0"/>
+              </a:spcAft>
+              <a:buClrTx/>
+              <a:buSzTx/>
+              <a:buFontTx/>
+              <a:buNone/>
+              <a:tabLst/>
+            </a:pPr>
+            <a:r>
+              <a:rPr kumimoji="0" lang="en-US" altLang="es-ES" sz="1100" b="0" i="0" u="none" strike="noStrike" cap="none" normalizeH="0" baseline="0" dirty="0">
+                <a:ln>
+                  <a:noFill/>
+                </a:ln>
+                <a:solidFill>
+                  <a:srgbClr val="F4A200"/>
+                </a:solidFill>
+                <a:effectLst/>
+                <a:latin typeface="Arial" panose="020B0604020202020204" pitchFamily="34" charset="0"/>
+                <a:ea typeface="Myriad Pro Light"/>
+                <a:cs typeface="Times New Roman" panose="02020603050405020304" pitchFamily="18" charset="0"/>
+              </a:rPr>
+              <a:t>Universidad </a:t>
+            </a:r>
+            <a:r>
+              <a:rPr kumimoji="0" lang="en-US" altLang="es-ES" sz="1100" b="0" i="0" u="none" strike="noStrike" cap="none" normalizeH="0" baseline="0" dirty="0" err="1">
+                <a:ln>
+                  <a:noFill/>
+                </a:ln>
+                <a:solidFill>
+                  <a:srgbClr val="F4A200"/>
+                </a:solidFill>
+                <a:effectLst/>
+                <a:latin typeface="Arial" panose="020B0604020202020204" pitchFamily="34" charset="0"/>
+                <a:ea typeface="Myriad Pro Light"/>
+                <a:cs typeface="Times New Roman" panose="02020603050405020304" pitchFamily="18" charset="0"/>
+              </a:rPr>
+              <a:t>Aut</a:t>
+            </a:r>
+            <a:r>
+              <a:rPr lang="en-US" altLang="es-ES" sz="1100" dirty="0" err="1">
+                <a:solidFill>
+                  <a:srgbClr val="F4A200"/>
+                </a:solidFill>
+                <a:latin typeface="Arial" panose="020B0604020202020204" pitchFamily="34" charset="0"/>
+                <a:ea typeface="Myriad Pro Light"/>
+                <a:cs typeface="Times New Roman" panose="02020603050405020304" pitchFamily="18" charset="0"/>
+              </a:rPr>
+              <a:t>ó</a:t>
+            </a:r>
+            <a:r>
+              <a:rPr kumimoji="0" lang="en-US" altLang="es-ES" sz="1100" b="0" i="0" u="none" strike="noStrike" cap="none" normalizeH="0" baseline="0" dirty="0" err="1">
+                <a:ln>
+                  <a:noFill/>
+                </a:ln>
+                <a:solidFill>
+                  <a:srgbClr val="F4A200"/>
+                </a:solidFill>
+                <a:effectLst/>
+                <a:latin typeface="Arial" panose="020B0604020202020204" pitchFamily="34" charset="0"/>
+                <a:ea typeface="Myriad Pro Light"/>
+                <a:cs typeface="Times New Roman" panose="02020603050405020304" pitchFamily="18" charset="0"/>
+              </a:rPr>
+              <a:t>noma</a:t>
+            </a:r>
+            <a:r>
+              <a:rPr kumimoji="0" lang="en-US" altLang="es-ES" sz="1100" b="0" i="0" u="none" strike="noStrike" cap="none" normalizeH="0" baseline="0" dirty="0">
+                <a:ln>
+                  <a:noFill/>
+                </a:ln>
+                <a:solidFill>
+                  <a:srgbClr val="F4A200"/>
+                </a:solidFill>
+                <a:effectLst/>
+                <a:latin typeface="Arial" panose="020B0604020202020204" pitchFamily="34" charset="0"/>
+                <a:ea typeface="Myriad Pro Light"/>
+                <a:cs typeface="Times New Roman" panose="02020603050405020304" pitchFamily="18" charset="0"/>
+              </a:rPr>
+              <a:t> de Madrid</a:t>
+            </a:r>
+            <a:endParaRPr kumimoji="0" lang="es-ES" altLang="es-ES" sz="300" b="0" i="0" u="none" strike="noStrike" cap="none" normalizeH="0" baseline="0" dirty="0">
+              <a:ln>
+                <a:noFill/>
+              </a:ln>
+              <a:solidFill>
+                <a:schemeClr val="tx1"/>
+              </a:solidFill>
+              <a:effectLst/>
+              <a:latin typeface="Arial" panose="020B0604020202020204" pitchFamily="34" charset="0"/>
+            </a:endParaRPr>
+          </a:p>
+        </p:txBody>
+      </p:sp>
+    </p:spTree>
+    <p:extLst>
+      <p:ext uri="{BB962C8B-B14F-4D97-AF65-F5344CB8AC3E}">
+        <p14:creationId xmlns:p14="http://schemas.microsoft.com/office/powerpoint/2010/main" val="1124763270"/>
       </p:ext>
     </p:extLst>
   </p:cSld>
@@ -28341,8 +32597,8 @@
           </a:p>
         </p:txBody>
       </p:sp>
-      <mc:AlternateContent xmlns:mc="http://schemas.openxmlformats.org/markup-compatibility/2006" xmlns:a14="http://schemas.microsoft.com/office/drawing/2010/main">
-        <mc:Choice Requires="a14">
+      <mc:AlternateContent xmlns:mc="http://schemas.openxmlformats.org/markup-compatibility/2006">
+        <mc:Choice xmlns:a14="http://schemas.microsoft.com/office/drawing/2010/main" Requires="a14">
           <p:sp>
             <p:nvSpPr>
               <p:cNvPr id="3" name="Content Placeholder 2">
@@ -28829,23 +33085,7 @@
                   <a:rPr lang="en-US" sz="2000" dirty="0">
                     <a:latin typeface="+mj-lt"/>
                   </a:rPr>
-                  <a:t>However, it is computationally infeasible to consider every possible partition of the feature space into  </a:t>
-                </a:r>
-                <a14:m>
-                  <m:oMath xmlns:m="http://schemas.openxmlformats.org/officeDocument/2006/math">
-                    <m:r>
-                      <a:rPr lang="en-US" sz="2000" b="0" i="1" smtClean="0">
-                        <a:latin typeface="Cambria Math" panose="02040503050406030204" pitchFamily="18" charset="0"/>
-                      </a:rPr>
-                      <m:t>𝐽</m:t>
-                    </m:r>
-                  </m:oMath>
-                </a14:m>
-                <a:r>
-                  <a:rPr lang="en-US" sz="2000" dirty="0">
-                    <a:latin typeface="+mj-lt"/>
-                  </a:rPr>
-                  <a:t> rectangles. Thus, a </a:t>
+                  <a:t>A </a:t>
                 </a:r>
                 <a:r>
                   <a:rPr lang="en-US" sz="2000" i="1" dirty="0">
@@ -28857,7 +33097,7 @@
                   <a:rPr lang="en-US" sz="2000" dirty="0">
                     <a:latin typeface="+mj-lt"/>
                   </a:rPr>
-                  <a:t> approach is taken, know as </a:t>
+                  <a:t> approach is taken for splitting the feature space, also known as </a:t>
                 </a:r>
                 <a:r>
                   <a:rPr lang="en-US" sz="2000" i="1" dirty="0">
@@ -28934,7 +33174,7 @@
             </p:txBody>
           </p:sp>
         </mc:Choice>
-        <mc:Fallback xmlns="">
+        <mc:Fallback>
           <p:sp>
             <p:nvSpPr>
               <p:cNvPr id="3" name="Content Placeholder 2">
@@ -28959,7 +33199,7 @@
               <a:blipFill>
                 <a:blip r:embed="rId2"/>
                 <a:stretch>
-                  <a:fillRect l="-522" t="-700"/>
+                  <a:fillRect l="-522" t="-700" r="-348"/>
                 </a:stretch>
               </a:blipFill>
             </p:spPr>
@@ -29368,7 +33608,7 @@
           <a:p>
             <a:r>
               <a:rPr lang="en-US" sz="4000" dirty="0"/>
-              <a:t>Decision Trees</a:t>
+              <a:t>Decision Trees - Regression</a:t>
             </a:r>
           </a:p>
         </p:txBody>
@@ -29477,19 +33717,7 @@
                   <a:rPr lang="en-US" sz="2000" dirty="0">
                     <a:latin typeface="+mj-lt"/>
                   </a:rPr>
-                  <a:t> such </a:t>
-                </a:r>
-                <a:r>
-                  <a:rPr lang="en-US" sz="2000" dirty="0" err="1">
-                    <a:latin typeface="+mj-lt"/>
-                  </a:rPr>
-                  <a:t>tht</a:t>
-                </a:r>
-                <a:r>
-                  <a:rPr lang="en-US" sz="2000" dirty="0">
-                    <a:latin typeface="+mj-lt"/>
-                  </a:rPr>
-                  <a:t> splitting the predictor space into the regions </a:t>
+                  <a:t> such that splitting the predictor space into the regions </a:t>
                 </a:r>
                 <a14:m>
                   <m:oMath xmlns:m="http://schemas.openxmlformats.org/officeDocument/2006/math">
@@ -30117,7 +34345,7 @@
                   <a:rPr lang="en-US" sz="2000" i="1" dirty="0">
                     <a:latin typeface="+mj-lt"/>
                   </a:rPr>
-                  <a:t>Looking for the value of j and s that minimize:</a:t>
+                  <a:t>Looking for the values of j and s that minimize:</a:t>
                 </a:r>
               </a:p>
               <a:p>
@@ -31694,7 +35922,7 @@
               <a:rPr lang="en-US" sz="2000" dirty="0">
                 <a:latin typeface="+mj-lt"/>
               </a:rPr>
-              <a:t> is carried out</a:t>
+              <a:t> is carried out </a:t>
             </a:r>
           </a:p>
           <a:p>
@@ -32186,8 +36414,8 @@
         </p:nvSpPr>
         <p:spPr>
           <a:xfrm>
-            <a:off x="747934" y="4487818"/>
-            <a:ext cx="1338773" cy="307777"/>
+            <a:off x="456061" y="4081684"/>
+            <a:ext cx="1619915" cy="738664"/>
           </a:xfrm>
           <a:prstGeom prst="rect">
             <a:avLst/>
@@ -32200,14 +36428,66 @@
           </a:bodyPr>
           <a:lstStyle/>
           <a:p>
+            <a:pPr algn="ctr"/>
             <a:r>
               <a:rPr lang="en-US" sz="1400" dirty="0">
                 <a:solidFill>
                   <a:srgbClr val="FF0000"/>
                 </a:solidFill>
               </a:rPr>
-              <a:t>unpruned tree</a:t>
+              <a:t>Unpruned tree (pruned one is in the first slide)</a:t>
             </a:r>
+          </a:p>
+        </p:txBody>
+      </p:sp>
+      <p:sp>
+        <p:nvSpPr>
+          <p:cNvPr id="9" name="TextBox 8">
+            <a:extLst>
+              <a:ext uri="{FF2B5EF4-FFF2-40B4-BE49-F238E27FC236}">
+                <a16:creationId xmlns:a16="http://schemas.microsoft.com/office/drawing/2014/main" id="{CFD1666B-DB69-21F2-DAD7-1D99FE0F64A0}"/>
+              </a:ext>
+            </a:extLst>
+          </p:cNvPr>
+          <p:cNvSpPr txBox="1"/>
+          <p:nvPr/>
+        </p:nvSpPr>
+        <p:spPr>
+          <a:xfrm rot="20802546">
+            <a:off x="9173091" y="1570977"/>
+            <a:ext cx="3129336" cy="584775"/>
+          </a:xfrm>
+          <a:prstGeom prst="rect">
+            <a:avLst/>
+          </a:prstGeom>
+          <a:noFill/>
+        </p:spPr>
+        <p:txBody>
+          <a:bodyPr wrap="square">
+            <a:spAutoFit/>
+          </a:bodyPr>
+          <a:lstStyle/>
+          <a:p>
+            <a:pPr algn="ctr">
+              <a:lnSpc>
+                <a:spcPct val="100000"/>
+              </a:lnSpc>
+            </a:pPr>
+            <a:r>
+              <a:rPr lang="en-US" sz="1600" dirty="0">
+                <a:solidFill>
+                  <a:srgbClr val="FF0000"/>
+                </a:solidFill>
+                <a:latin typeface="+mj-lt"/>
+              </a:rPr>
+              <a:t>process is a bit complex in regression, and out of our scope</a:t>
+            </a:r>
+            <a:endParaRPr lang="en-US" dirty="0">
+              <a:solidFill>
+                <a:srgbClr val="FF0000"/>
+              </a:solidFill>
+              <a:latin typeface="+mj-lt"/>
+            </a:endParaRPr>
           </a:p>
         </p:txBody>
       </p:sp>

</xml_diff>